<commit_message>
upate_Neural Discrete Representation Learning
</commit_message>
<xml_diff>
--- a/Base_Model/GAN+VAE+Diffusion/论文作图.pptx
+++ b/Base_Model/GAN+VAE+Diffusion/论文作图.pptx
@@ -8,7 +8,7 @@
     <p:notesMasterId r:id="rId4"/>
   </p:notesMasterIdLst>
   <p:handoutMasterIdLst>
-    <p:handoutMasterId r:id="rId11"/>
+    <p:handoutMasterId r:id="rId12"/>
   </p:handoutMasterIdLst>
   <p:sldIdLst>
     <p:sldId id="256" r:id="rId3"/>
@@ -16,8 +16,9 @@
     <p:sldId id="257" r:id="rId6"/>
     <p:sldId id="259" r:id="rId7"/>
     <p:sldId id="260" r:id="rId8"/>
-    <p:sldId id="262" r:id="rId9"/>
-    <p:sldId id="263" r:id="rId10"/>
+    <p:sldId id="264" r:id="rId9"/>
+    <p:sldId id="262" r:id="rId10"/>
+    <p:sldId id="263" r:id="rId11"/>
   </p:sldIdLst>
   <p:sldSz cx="12192000" cy="6858000"/>
   <p:notesSz cx="7103745" cy="10234295"/>
@@ -119,7 +120,7 @@
   <p:extLst>
     <p:ext uri="{EFAFB233-063F-42B5-8137-9DF3F51BA10A}">
       <p15:sldGuideLst xmlns:p15="http://schemas.microsoft.com/office/powerpoint/2012/main">
-        <p15:guide id="1" orient="horz" pos="2178" userDrawn="1">
+        <p15:guide id="1" orient="horz" pos="2191" userDrawn="1">
           <p15:clr>
             <a:srgbClr val="A4A3A4"/>
           </p15:clr>
@@ -6728,7 +6729,7 @@
       <p:grpSpPr/>
       <p:pic>
         <p:nvPicPr>
-          <p:cNvPr id="5" name="图片 4"/>
+          <p:cNvPr id="10" name="图片 9"/>
           <p:cNvPicPr>
             <a:picLocks noChangeAspect="1"/>
           </p:cNvPicPr>
@@ -6746,6 +6747,34 @@
         </p:blipFill>
         <p:spPr>
           <a:xfrm>
+            <a:off x="215900" y="3122930"/>
+            <a:ext cx="8966200" cy="3136900"/>
+          </a:xfrm>
+          <a:prstGeom prst="rect">
+            <a:avLst/>
+          </a:prstGeom>
+        </p:spPr>
+      </p:pic>
+      <p:pic>
+        <p:nvPicPr>
+          <p:cNvPr id="5" name="图片 4"/>
+          <p:cNvPicPr>
+            <a:picLocks noChangeAspect="1"/>
+          </p:cNvPicPr>
+          <p:nvPr>
+            <p:custDataLst>
+              <p:tags r:id="rId3"/>
+            </p:custDataLst>
+          </p:nvPr>
+        </p:nvPicPr>
+        <p:blipFill>
+          <a:blip r:embed="rId4"/>
+          <a:stretch>
+            <a:fillRect/>
+          </a:stretch>
+        </p:blipFill>
+        <p:spPr>
+          <a:xfrm>
             <a:off x="0" y="426085"/>
             <a:ext cx="4053840" cy="1707515"/>
           </a:xfrm>
@@ -6762,12 +6791,12 @@
           </p:cNvPicPr>
           <p:nvPr>
             <p:custDataLst>
-              <p:tags r:id="rId3"/>
+              <p:tags r:id="rId5"/>
             </p:custDataLst>
           </p:nvPr>
         </p:nvPicPr>
         <p:blipFill>
-          <a:blip r:embed="rId4"/>
+          <a:blip r:embed="rId6"/>
           <a:stretch>
             <a:fillRect/>
           </a:stretch>
@@ -6788,7 +6817,7 @@
           <p:cNvSpPr txBox="1"/>
           <p:nvPr>
             <p:custDataLst>
-              <p:tags r:id="rId5"/>
+              <p:tags r:id="rId7"/>
             </p:custDataLst>
           </p:nvPr>
         </p:nvSpPr>
@@ -6861,7 +6890,7 @@
           <p:cNvSpPr txBox="1"/>
           <p:nvPr>
             <p:custDataLst>
-              <p:tags r:id="rId6"/>
+              <p:tags r:id="rId8"/>
             </p:custDataLst>
           </p:nvPr>
         </p:nvSpPr>
@@ -6934,13 +6963,13 @@
           <p:cNvSpPr txBox="1"/>
           <p:nvPr>
             <p:custDataLst>
-              <p:tags r:id="rId7"/>
+              <p:tags r:id="rId9"/>
             </p:custDataLst>
           </p:nvPr>
         </p:nvSpPr>
         <p:spPr>
           <a:xfrm>
-            <a:off x="8186420" y="2456180"/>
+            <a:off x="8567420" y="2075180"/>
             <a:ext cx="2799715" cy="575310"/>
           </a:xfrm>
           <a:prstGeom prst="rect">
@@ -7008,34 +7037,568 @@
           </a:p>
         </p:txBody>
       </p:sp>
-      <p:pic>
-        <p:nvPicPr>
-          <p:cNvPr id="10" name="图片 9"/>
-          <p:cNvPicPr>
-            <a:picLocks noChangeAspect="1"/>
-          </p:cNvPicPr>
+      <p:sp>
+        <p:nvSpPr>
+          <p:cNvPr id="2" name="文本框 1"/>
+          <p:cNvSpPr txBox="1"/>
           <p:nvPr>
             <p:custDataLst>
-              <p:tags r:id="rId8"/>
+              <p:tags r:id="rId10"/>
             </p:custDataLst>
           </p:nvPr>
-        </p:nvPicPr>
-        <p:blipFill>
-          <a:blip r:embed="rId9"/>
-          <a:stretch>
-            <a:fillRect/>
-          </a:stretch>
-        </p:blipFill>
+        </p:nvSpPr>
         <p:spPr>
           <a:xfrm>
-            <a:off x="1612900" y="3630930"/>
-            <a:ext cx="8966200" cy="3136900"/>
+            <a:off x="2531745" y="3190875"/>
+            <a:ext cx="2799715" cy="575310"/>
           </a:xfrm>
           <a:prstGeom prst="rect">
             <a:avLst/>
           </a:prstGeom>
-        </p:spPr>
-      </p:pic>
+          <a:noFill/>
+        </p:spPr>
+        <p:txBody>
+          <a:bodyPr wrap="square" rtlCol="0">
+            <a:noAutofit/>
+          </a:bodyPr>
+          <a:p>
+            <a:pPr algn="ctr"/>
+            <a:r>
+              <a:rPr lang="zh-CN" altLang="en-US" sz="1400" b="1">
+                <a:latin typeface="微软雅黑" charset="0"/>
+                <a:ea typeface="微软雅黑" charset="0"/>
+                <a:cs typeface="微软雅黑" charset="0"/>
+              </a:rPr>
+              <a:t>维护了一个</a:t>
+            </a:r>
+            <a:r>
+              <a:rPr lang="en-US" altLang="zh-CN" sz="1400" b="1">
+                <a:latin typeface="微软雅黑" charset="0"/>
+                <a:ea typeface="微软雅黑" charset="0"/>
+                <a:cs typeface="微软雅黑" charset="0"/>
+              </a:rPr>
+              <a:t>Code</a:t>
+            </a:r>
+            <a:r>
+              <a:rPr lang="en-US" altLang="zh-CN" sz="1400" b="1">
+                <a:latin typeface="微软雅黑" charset="0"/>
+                <a:ea typeface="微软雅黑" charset="0"/>
+                <a:cs typeface="微软雅黑" charset="0"/>
+              </a:rPr>
+              <a:t>Book</a:t>
+            </a:r>
+            <a:endParaRPr lang="en-US" altLang="zh-CN" sz="1400" b="1">
+              <a:latin typeface="微软雅黑" charset="0"/>
+              <a:ea typeface="微软雅黑" charset="0"/>
+              <a:cs typeface="微软雅黑" charset="0"/>
+            </a:endParaRPr>
+          </a:p>
+        </p:txBody>
+      </p:sp>
+      <p:sp>
+        <p:nvSpPr>
+          <p:cNvPr id="3" name="文本框 2"/>
+          <p:cNvSpPr txBox="1"/>
+          <p:nvPr>
+            <p:custDataLst>
+              <p:tags r:id="rId11"/>
+            </p:custDataLst>
+          </p:nvPr>
+        </p:nvSpPr>
+        <p:spPr>
+          <a:xfrm>
+            <a:off x="-27305" y="5984875"/>
+            <a:ext cx="3314065" cy="575310"/>
+          </a:xfrm>
+          <a:prstGeom prst="rect">
+            <a:avLst/>
+          </a:prstGeom>
+          <a:noFill/>
+        </p:spPr>
+        <p:txBody>
+          <a:bodyPr wrap="square" rtlCol="0">
+            <a:noAutofit/>
+          </a:bodyPr>
+          <a:p>
+            <a:pPr algn="ctr"/>
+            <a:r>
+              <a:rPr lang="zh-CN" altLang="en-US" sz="1400" b="1">
+                <a:latin typeface="微软雅黑" charset="0"/>
+                <a:ea typeface="微软雅黑" charset="0"/>
+                <a:cs typeface="微软雅黑" charset="0"/>
+              </a:rPr>
+              <a:t>将图像映射成</a:t>
+            </a:r>
+            <a:r>
+              <a:rPr lang="en-US" altLang="zh-CN" sz="1400" b="1">
+                <a:latin typeface="微软雅黑" charset="0"/>
+                <a:ea typeface="微软雅黑" charset="0"/>
+                <a:cs typeface="微软雅黑" charset="0"/>
+              </a:rPr>
+              <a:t>n</a:t>
+            </a:r>
+            <a:r>
+              <a:rPr lang="zh-CN" altLang="en-US" sz="1400" b="1">
+                <a:latin typeface="微软雅黑" charset="0"/>
+                <a:ea typeface="微软雅黑" charset="0"/>
+                <a:cs typeface="微软雅黑" charset="0"/>
+              </a:rPr>
+              <a:t>个特征后</a:t>
+            </a:r>
+            <a:r>
+              <a:rPr lang="en-US" altLang="zh-CN" sz="1400" b="1">
+                <a:latin typeface="微软雅黑" charset="0"/>
+                <a:ea typeface="微软雅黑" charset="0"/>
+                <a:cs typeface="微软雅黑" charset="0"/>
+              </a:rPr>
+              <a:t>(</a:t>
+            </a:r>
+            <a:r>
+              <a:rPr lang="zh-CN" altLang="en-US" sz="1400" b="1">
+                <a:latin typeface="微软雅黑" charset="0"/>
+                <a:ea typeface="微软雅黑" charset="0"/>
+                <a:cs typeface="微软雅黑" charset="0"/>
+              </a:rPr>
+              <a:t>连续</a:t>
+            </a:r>
+            <a:r>
+              <a:rPr lang="en-US" altLang="zh-CN" sz="1400" b="1">
+                <a:latin typeface="微软雅黑" charset="0"/>
+                <a:ea typeface="微软雅黑" charset="0"/>
+                <a:cs typeface="微软雅黑" charset="0"/>
+              </a:rPr>
+              <a:t>)</a:t>
+            </a:r>
+            <a:r>
+              <a:rPr lang="zh-CN" altLang="en-US" sz="1400" b="1">
+                <a:latin typeface="微软雅黑" charset="0"/>
+                <a:ea typeface="微软雅黑" charset="0"/>
+                <a:cs typeface="微软雅黑" charset="0"/>
+              </a:rPr>
+              <a:t>，将每个特征和</a:t>
+            </a:r>
+            <a:r>
+              <a:rPr lang="en-US" altLang="zh-CN" sz="1400" b="1">
+                <a:latin typeface="微软雅黑" charset="0"/>
+                <a:ea typeface="微软雅黑" charset="0"/>
+                <a:cs typeface="微软雅黑" charset="0"/>
+              </a:rPr>
+              <a:t>codebook</a:t>
+            </a:r>
+            <a:r>
+              <a:rPr lang="zh-CN" altLang="en-US" sz="1400" b="1">
+                <a:latin typeface="微软雅黑" charset="0"/>
+                <a:ea typeface="微软雅黑" charset="0"/>
+                <a:cs typeface="微软雅黑" charset="0"/>
+              </a:rPr>
+              <a:t>对比，替换为最近的</a:t>
+            </a:r>
+            <a:r>
+              <a:rPr lang="en-US" altLang="zh-CN" sz="1400" b="1">
+                <a:latin typeface="微软雅黑" charset="0"/>
+                <a:ea typeface="微软雅黑" charset="0"/>
+                <a:cs typeface="微软雅黑" charset="0"/>
+              </a:rPr>
+              <a:t>codebook</a:t>
+            </a:r>
+            <a:r>
+              <a:rPr lang="zh-CN" altLang="en-US" sz="1400" b="1">
+                <a:latin typeface="微软雅黑" charset="0"/>
+                <a:ea typeface="微软雅黑" charset="0"/>
+                <a:cs typeface="微软雅黑" charset="0"/>
+              </a:rPr>
+              <a:t>中的特征</a:t>
+            </a:r>
+            <a:r>
+              <a:rPr lang="en-US" altLang="zh-CN" sz="1400" b="1">
+                <a:latin typeface="微软雅黑" charset="0"/>
+                <a:ea typeface="微软雅黑" charset="0"/>
+                <a:cs typeface="微软雅黑" charset="0"/>
+              </a:rPr>
+              <a:t>(</a:t>
+            </a:r>
+            <a:r>
+              <a:rPr lang="zh-CN" altLang="en-US" sz="1400" b="1">
+                <a:latin typeface="微软雅黑" charset="0"/>
+                <a:ea typeface="微软雅黑" charset="0"/>
+                <a:cs typeface="微软雅黑" charset="0"/>
+              </a:rPr>
+              <a:t>离散</a:t>
+            </a:r>
+            <a:r>
+              <a:rPr lang="en-US" altLang="zh-CN" sz="1400" b="1">
+                <a:latin typeface="微软雅黑" charset="0"/>
+                <a:ea typeface="微软雅黑" charset="0"/>
+                <a:cs typeface="微软雅黑" charset="0"/>
+              </a:rPr>
+              <a:t>)</a:t>
+            </a:r>
+            <a:endParaRPr lang="en-US" altLang="zh-CN" sz="1400" b="1">
+              <a:latin typeface="微软雅黑" charset="0"/>
+              <a:ea typeface="微软雅黑" charset="0"/>
+              <a:cs typeface="微软雅黑" charset="0"/>
+            </a:endParaRPr>
+          </a:p>
+        </p:txBody>
+      </p:sp>
+      <p:sp>
+        <p:nvSpPr>
+          <p:cNvPr id="16" name="矩形: 圆角 36"/>
+          <p:cNvSpPr/>
+          <p:nvPr>
+            <p:custDataLst>
+              <p:tags r:id="rId12"/>
+            </p:custDataLst>
+          </p:nvPr>
+        </p:nvSpPr>
+        <p:spPr>
+          <a:xfrm rot="10800000" flipV="1">
+            <a:off x="2429510" y="3096260"/>
+            <a:ext cx="3016885" cy="1410335"/>
+          </a:xfrm>
+          <a:prstGeom prst="roundRect">
+            <a:avLst>
+              <a:gd name="adj" fmla="val 10039"/>
+            </a:avLst>
+          </a:prstGeom>
+          <a:noFill/>
+          <a:ln w="38100">
+            <a:solidFill>
+              <a:schemeClr val="tx1"/>
+            </a:solidFill>
+            <a:prstDash val="lgDash"/>
+          </a:ln>
+        </p:spPr>
+        <p:style>
+          <a:lnRef idx="2">
+            <a:schemeClr val="accent1">
+              <a:shade val="15000"/>
+            </a:schemeClr>
+          </a:lnRef>
+          <a:fillRef idx="1">
+            <a:schemeClr val="accent1"/>
+          </a:fillRef>
+          <a:effectRef idx="0">
+            <a:schemeClr val="accent1"/>
+          </a:effectRef>
+          <a:fontRef idx="minor">
+            <a:schemeClr val="lt1"/>
+          </a:fontRef>
+        </p:style>
+        <p:txBody>
+          <a:bodyPr rtlCol="0" anchor="ctr"/>
+          <a:p>
+            <a:pPr algn="ctr"/>
+            <a:endParaRPr lang="zh-CN" altLang="en-US"/>
+          </a:p>
+        </p:txBody>
+      </p:sp>
+      <p:sp>
+        <p:nvSpPr>
+          <p:cNvPr id="4" name="矩形: 圆角 36"/>
+          <p:cNvSpPr/>
+          <p:nvPr>
+            <p:custDataLst>
+              <p:tags r:id="rId13"/>
+            </p:custDataLst>
+          </p:nvPr>
+        </p:nvSpPr>
+        <p:spPr>
+          <a:xfrm rot="10800000" flipV="1">
+            <a:off x="-27940" y="4505960"/>
+            <a:ext cx="3314700" cy="2352040"/>
+          </a:xfrm>
+          <a:prstGeom prst="roundRect">
+            <a:avLst>
+              <a:gd name="adj" fmla="val 10039"/>
+            </a:avLst>
+          </a:prstGeom>
+          <a:noFill/>
+          <a:ln w="38100">
+            <a:solidFill>
+              <a:schemeClr val="tx1"/>
+            </a:solidFill>
+            <a:prstDash val="lgDash"/>
+          </a:ln>
+        </p:spPr>
+        <p:style>
+          <a:lnRef idx="2">
+            <a:schemeClr val="accent1">
+              <a:shade val="15000"/>
+            </a:schemeClr>
+          </a:lnRef>
+          <a:fillRef idx="1">
+            <a:schemeClr val="accent1"/>
+          </a:fillRef>
+          <a:effectRef idx="0">
+            <a:schemeClr val="accent1"/>
+          </a:effectRef>
+          <a:fontRef idx="minor">
+            <a:schemeClr val="lt1"/>
+          </a:fontRef>
+        </p:style>
+        <p:txBody>
+          <a:bodyPr rtlCol="0" anchor="ctr"/>
+          <a:p>
+            <a:pPr algn="ctr"/>
+            <a:endParaRPr lang="zh-CN" altLang="en-US"/>
+          </a:p>
+        </p:txBody>
+      </p:sp>
+      <p:sp>
+        <p:nvSpPr>
+          <p:cNvPr id="8" name="文本框 7"/>
+          <p:cNvSpPr txBox="1"/>
+          <p:nvPr>
+            <p:custDataLst>
+              <p:tags r:id="rId14"/>
+            </p:custDataLst>
+          </p:nvPr>
+        </p:nvSpPr>
+        <p:spPr>
+          <a:xfrm>
+            <a:off x="4090670" y="5984875"/>
+            <a:ext cx="3314065" cy="575310"/>
+          </a:xfrm>
+          <a:prstGeom prst="rect">
+            <a:avLst/>
+          </a:prstGeom>
+          <a:noFill/>
+        </p:spPr>
+        <p:txBody>
+          <a:bodyPr wrap="square" rtlCol="0">
+            <a:noAutofit/>
+          </a:bodyPr>
+          <a:p>
+            <a:pPr algn="ctr"/>
+            <a:r>
+              <a:rPr lang="zh-CN" altLang="en-US" sz="1400" b="1">
+                <a:latin typeface="微软雅黑" charset="0"/>
+                <a:ea typeface="微软雅黑" charset="0"/>
+                <a:cs typeface="微软雅黑" charset="0"/>
+              </a:rPr>
+              <a:t>根据离散的特征去恢复</a:t>
+            </a:r>
+            <a:r>
+              <a:rPr lang="zh-CN" altLang="en-US" sz="1400" b="1">
+                <a:latin typeface="微软雅黑" charset="0"/>
+                <a:ea typeface="微软雅黑" charset="0"/>
+                <a:cs typeface="微软雅黑" charset="0"/>
+              </a:rPr>
+              <a:t>图像</a:t>
+            </a:r>
+            <a:endParaRPr lang="zh-CN" altLang="en-US" sz="1400" b="1">
+              <a:latin typeface="微软雅黑" charset="0"/>
+              <a:ea typeface="微软雅黑" charset="0"/>
+              <a:cs typeface="微软雅黑" charset="0"/>
+            </a:endParaRPr>
+          </a:p>
+        </p:txBody>
+      </p:sp>
+      <p:sp>
+        <p:nvSpPr>
+          <p:cNvPr id="11" name="矩形: 圆角 36"/>
+          <p:cNvSpPr/>
+          <p:nvPr>
+            <p:custDataLst>
+              <p:tags r:id="rId15"/>
+            </p:custDataLst>
+          </p:nvPr>
+        </p:nvSpPr>
+        <p:spPr>
+          <a:xfrm rot="10800000" flipV="1">
+            <a:off x="4544060" y="4506595"/>
+            <a:ext cx="2486660" cy="1876425"/>
+          </a:xfrm>
+          <a:prstGeom prst="roundRect">
+            <a:avLst>
+              <a:gd name="adj" fmla="val 10039"/>
+            </a:avLst>
+          </a:prstGeom>
+          <a:noFill/>
+          <a:ln w="38100">
+            <a:solidFill>
+              <a:schemeClr val="tx1"/>
+            </a:solidFill>
+            <a:prstDash val="lgDash"/>
+          </a:ln>
+        </p:spPr>
+        <p:style>
+          <a:lnRef idx="2">
+            <a:schemeClr val="accent1">
+              <a:shade val="15000"/>
+            </a:schemeClr>
+          </a:lnRef>
+          <a:fillRef idx="1">
+            <a:schemeClr val="accent1"/>
+          </a:fillRef>
+          <a:effectRef idx="0">
+            <a:schemeClr val="accent1"/>
+          </a:effectRef>
+          <a:fontRef idx="minor">
+            <a:schemeClr val="lt1"/>
+          </a:fontRef>
+        </p:style>
+        <p:txBody>
+          <a:bodyPr rtlCol="0" anchor="ctr"/>
+          <a:p>
+            <a:pPr algn="ctr"/>
+            <a:endParaRPr lang="zh-CN" altLang="en-US"/>
+          </a:p>
+        </p:txBody>
+      </p:sp>
+      <p:sp>
+        <p:nvSpPr>
+          <p:cNvPr id="12" name="文本框 11"/>
+          <p:cNvSpPr txBox="1"/>
+          <p:nvPr>
+            <p:custDataLst>
+              <p:tags r:id="rId16"/>
+            </p:custDataLst>
+          </p:nvPr>
+        </p:nvSpPr>
+        <p:spPr>
+          <a:xfrm>
+            <a:off x="8627745" y="4206875"/>
+            <a:ext cx="3313430" cy="1315720"/>
+          </a:xfrm>
+          <a:prstGeom prst="rect">
+            <a:avLst/>
+          </a:prstGeom>
+          <a:noFill/>
+        </p:spPr>
+        <p:txBody>
+          <a:bodyPr wrap="square" rtlCol="0">
+            <a:noAutofit/>
+          </a:bodyPr>
+          <a:p>
+            <a:pPr algn="ctr"/>
+            <a:r>
+              <a:rPr lang="en-US" altLang="zh-CN" sz="1400" b="1">
+                <a:latin typeface="微软雅黑" charset="0"/>
+                <a:ea typeface="微软雅黑" charset="0"/>
+                <a:cs typeface="微软雅黑" charset="0"/>
+              </a:rPr>
+              <a:t>Encoder+Decoder</a:t>
+            </a:r>
+            <a:r>
+              <a:rPr lang="zh-CN" altLang="en-US" sz="1400" b="1">
+                <a:latin typeface="微软雅黑" charset="0"/>
+                <a:ea typeface="微软雅黑" charset="0"/>
+                <a:cs typeface="微软雅黑" charset="0"/>
+              </a:rPr>
+              <a:t>训练</a:t>
+            </a:r>
+            <a:br>
+              <a:rPr lang="zh-CN" altLang="en-US" sz="1400" b="1">
+                <a:latin typeface="微软雅黑" charset="0"/>
+                <a:ea typeface="微软雅黑" charset="0"/>
+                <a:cs typeface="微软雅黑" charset="0"/>
+              </a:rPr>
+            </a:br>
+            <a:r>
+              <a:rPr lang="zh-CN" altLang="en-US" sz="1400" b="1">
+                <a:latin typeface="微软雅黑" charset="0"/>
+                <a:ea typeface="微软雅黑" charset="0"/>
+                <a:cs typeface="微软雅黑" charset="0"/>
+              </a:rPr>
+              <a:t>根据初始图像和重建图像的</a:t>
+            </a:r>
+            <a:r>
+              <a:rPr lang="en-US" altLang="zh-CN" sz="1400" b="1">
+                <a:latin typeface="微软雅黑" charset="0"/>
+                <a:ea typeface="微软雅黑" charset="0"/>
+                <a:cs typeface="微软雅黑" charset="0"/>
+              </a:rPr>
+              <a:t>MSE Loss</a:t>
+            </a:r>
+            <a:br>
+              <a:rPr lang="en-US" altLang="zh-CN" sz="1400" b="1">
+                <a:latin typeface="微软雅黑" charset="0"/>
+                <a:ea typeface="微软雅黑" charset="0"/>
+                <a:cs typeface="微软雅黑" charset="0"/>
+              </a:rPr>
+            </a:br>
+            <a:r>
+              <a:rPr lang="en-US" altLang="zh-CN" sz="1400" b="1">
+                <a:latin typeface="微软雅黑" charset="0"/>
+                <a:ea typeface="微软雅黑" charset="0"/>
+                <a:cs typeface="微软雅黑" charset="0"/>
+              </a:rPr>
+              <a:t>codebook</a:t>
+            </a:r>
+            <a:r>
+              <a:rPr lang="zh-CN" altLang="en-US" sz="1400" b="1">
+                <a:latin typeface="微软雅黑" charset="0"/>
+                <a:ea typeface="微软雅黑" charset="0"/>
+                <a:cs typeface="微软雅黑" charset="0"/>
+              </a:rPr>
+              <a:t>训练</a:t>
+            </a:r>
+            <a:endParaRPr lang="zh-CN" altLang="en-US" sz="1400" b="1">
+              <a:latin typeface="微软雅黑" charset="0"/>
+              <a:ea typeface="微软雅黑" charset="0"/>
+              <a:cs typeface="微软雅黑" charset="0"/>
+            </a:endParaRPr>
+          </a:p>
+          <a:p>
+            <a:pPr algn="ctr"/>
+            <a:r>
+              <a:rPr lang="zh-CN" altLang="en-US" sz="1400" b="1">
+                <a:latin typeface="微软雅黑" charset="0"/>
+                <a:ea typeface="微软雅黑" charset="0"/>
+                <a:cs typeface="微软雅黑" charset="0"/>
+              </a:rPr>
+              <a:t>在初始输入特征中，计算和</a:t>
+            </a:r>
+            <a:r>
+              <a:rPr lang="en-US" altLang="zh-CN" sz="1400" b="1">
+                <a:latin typeface="微软雅黑" charset="0"/>
+                <a:ea typeface="微软雅黑" charset="0"/>
+                <a:cs typeface="微软雅黑" charset="0"/>
+              </a:rPr>
+              <a:t>codebook</a:t>
+            </a:r>
+            <a:r>
+              <a:rPr lang="zh-CN" altLang="en-US" sz="1400" b="1">
+                <a:latin typeface="微软雅黑" charset="0"/>
+                <a:ea typeface="微软雅黑" charset="0"/>
+                <a:cs typeface="微软雅黑" charset="0"/>
+              </a:rPr>
+              <a:t>中的距离，离的最近的那个</a:t>
+            </a:r>
+            <a:r>
+              <a:rPr lang="en-US" altLang="zh-CN" sz="1400" b="1">
+                <a:latin typeface="微软雅黑" charset="0"/>
+                <a:ea typeface="微软雅黑" charset="0"/>
+                <a:cs typeface="微软雅黑" charset="0"/>
+              </a:rPr>
+              <a:t>codebook</a:t>
+            </a:r>
+            <a:r>
+              <a:rPr lang="zh-CN" altLang="en-US" sz="1400" b="1">
+                <a:latin typeface="微软雅黑" charset="0"/>
+                <a:ea typeface="微软雅黑" charset="0"/>
+                <a:cs typeface="微软雅黑" charset="0"/>
+              </a:rPr>
+              <a:t>中的特征朝真实的特征方向优化（朝着真实的</a:t>
+            </a:r>
+            <a:r>
+              <a:rPr lang="zh-CN" altLang="en-US" sz="1400" b="1">
+                <a:latin typeface="微软雅黑" charset="0"/>
+                <a:ea typeface="微软雅黑" charset="0"/>
+                <a:cs typeface="微软雅黑" charset="0"/>
+              </a:rPr>
+              <a:t>方向拉一下）</a:t>
+            </a:r>
+            <a:endParaRPr lang="zh-CN" altLang="en-US" sz="1400" b="1">
+              <a:latin typeface="微软雅黑" charset="0"/>
+              <a:ea typeface="微软雅黑" charset="0"/>
+              <a:cs typeface="微软雅黑" charset="0"/>
+            </a:endParaRPr>
+          </a:p>
+        </p:txBody>
+      </p:sp>
     </p:spTree>
   </p:cSld>
   <p:clrMapOvr>
@@ -7054,43 +7617,2360 @@
         <p:nvPr/>
       </p:nvGrpSpPr>
       <p:grpSpPr/>
-      <p:sp>
-        <p:nvSpPr>
-          <p:cNvPr id="2" name="标题 1"/>
-          <p:cNvSpPr>
-            <a:spLocks noGrp="1"/>
-          </p:cNvSpPr>
-          <p:nvPr>
-            <p:ph type="ctrTitle"/>
-          </p:nvPr>
-        </p:nvSpPr>
-        <p:spPr/>
-        <p:txBody>
-          <a:bodyPr/>
-          <a:p>
-            <a:r>
-              <a:rPr lang="en-US" altLang="zh-CN"/>
-              <a:t>GAN</a:t>
-            </a:r>
-            <a:endParaRPr lang="en-US" altLang="zh-CN"/>
-          </a:p>
-        </p:txBody>
-      </p:sp>
-      <p:sp>
-        <p:nvSpPr>
-          <p:cNvPr id="3" name="副标题 2"/>
-          <p:cNvSpPr>
-            <a:spLocks noGrp="1"/>
-          </p:cNvSpPr>
-          <p:nvPr>
-            <p:ph type="subTitle" idx="1"/>
-          </p:nvPr>
-        </p:nvSpPr>
-        <p:spPr/>
-        <p:txBody>
-          <a:bodyPr/>
-          <a:p>
+      <p:pic>
+        <p:nvPicPr>
+          <p:cNvPr id="34" name="图片 33"/>
+          <p:cNvPicPr>
+            <a:picLocks noChangeAspect="1"/>
+          </p:cNvPicPr>
+          <p:nvPr>
+            <p:custDataLst>
+              <p:tags r:id="rId1"/>
+            </p:custDataLst>
+          </p:nvPr>
+        </p:nvPicPr>
+        <p:blipFill>
+          <a:blip r:embed="rId2"/>
+          <a:stretch>
+            <a:fillRect/>
+          </a:stretch>
+        </p:blipFill>
+        <p:spPr>
+          <a:xfrm>
+            <a:off x="393700" y="4068445"/>
+            <a:ext cx="6303010" cy="2205355"/>
+          </a:xfrm>
+          <a:prstGeom prst="rect">
+            <a:avLst/>
+          </a:prstGeom>
+        </p:spPr>
+      </p:pic>
+      <p:pic>
+        <p:nvPicPr>
+          <p:cNvPr id="4" name="图片 3"/>
+          <p:cNvPicPr>
+            <a:picLocks noChangeAspect="1"/>
+          </p:cNvPicPr>
+          <p:nvPr>
+            <p:custDataLst>
+              <p:tags r:id="rId3"/>
+            </p:custDataLst>
+          </p:nvPr>
+        </p:nvPicPr>
+        <p:blipFill>
+          <a:blip r:embed="rId4"/>
+          <a:stretch>
+            <a:fillRect/>
+          </a:stretch>
+        </p:blipFill>
+        <p:spPr>
+          <a:xfrm>
+            <a:off x="1477010" y="497205"/>
+            <a:ext cx="2647950" cy="1951355"/>
+          </a:xfrm>
+          <a:prstGeom prst="rect">
+            <a:avLst/>
+          </a:prstGeom>
+        </p:spPr>
+      </p:pic>
+      <p:pic>
+        <p:nvPicPr>
+          <p:cNvPr id="5" name="图片 4"/>
+          <p:cNvPicPr>
+            <a:picLocks noChangeAspect="1"/>
+          </p:cNvPicPr>
+          <p:nvPr>
+            <p:custDataLst>
+              <p:tags r:id="rId5"/>
+            </p:custDataLst>
+          </p:nvPr>
+        </p:nvPicPr>
+        <p:blipFill>
+          <a:blip r:embed="rId6"/>
+          <a:stretch>
+            <a:fillRect/>
+          </a:stretch>
+        </p:blipFill>
+        <p:spPr>
+          <a:xfrm>
+            <a:off x="170815" y="1013460"/>
+            <a:ext cx="774700" cy="838200"/>
+          </a:xfrm>
+          <a:prstGeom prst="rect">
+            <a:avLst/>
+          </a:prstGeom>
+        </p:spPr>
+      </p:pic>
+      <p:pic>
+        <p:nvPicPr>
+          <p:cNvPr id="6" name="图片 5"/>
+          <p:cNvPicPr>
+            <a:picLocks noChangeAspect="1"/>
+          </p:cNvPicPr>
+          <p:nvPr>
+            <p:custDataLst>
+              <p:tags r:id="rId7"/>
+            </p:custDataLst>
+          </p:nvPr>
+        </p:nvPicPr>
+        <p:blipFill>
+          <a:blip r:embed="rId8"/>
+          <a:stretch>
+            <a:fillRect/>
+          </a:stretch>
+        </p:blipFill>
+        <p:spPr>
+          <a:xfrm>
+            <a:off x="4712970" y="139065"/>
+            <a:ext cx="748030" cy="746760"/>
+          </a:xfrm>
+          <a:prstGeom prst="rect">
+            <a:avLst/>
+          </a:prstGeom>
+        </p:spPr>
+      </p:pic>
+      <p:pic>
+        <p:nvPicPr>
+          <p:cNvPr id="7" name="图片 6"/>
+          <p:cNvPicPr>
+            <a:picLocks noChangeAspect="1"/>
+          </p:cNvPicPr>
+          <p:nvPr>
+            <p:custDataLst>
+              <p:tags r:id="rId9"/>
+            </p:custDataLst>
+          </p:nvPr>
+        </p:nvPicPr>
+        <p:blipFill>
+          <a:blip r:embed="rId10"/>
+          <a:stretch>
+            <a:fillRect/>
+          </a:stretch>
+        </p:blipFill>
+        <p:spPr>
+          <a:xfrm>
+            <a:off x="4712970" y="1108710"/>
+            <a:ext cx="738505" cy="615950"/>
+          </a:xfrm>
+          <a:prstGeom prst="rect">
+            <a:avLst/>
+          </a:prstGeom>
+        </p:spPr>
+      </p:pic>
+      <p:pic>
+        <p:nvPicPr>
+          <p:cNvPr id="8" name="图片 7"/>
+          <p:cNvPicPr>
+            <a:picLocks noChangeAspect="1"/>
+          </p:cNvPicPr>
+          <p:nvPr>
+            <p:custDataLst>
+              <p:tags r:id="rId11"/>
+            </p:custDataLst>
+          </p:nvPr>
+        </p:nvPicPr>
+        <p:blipFill>
+          <a:blip r:embed="rId12"/>
+          <a:stretch>
+            <a:fillRect/>
+          </a:stretch>
+        </p:blipFill>
+        <p:spPr>
+          <a:xfrm>
+            <a:off x="4696460" y="1920240"/>
+            <a:ext cx="746760" cy="746760"/>
+          </a:xfrm>
+          <a:prstGeom prst="rect">
+            <a:avLst/>
+          </a:prstGeom>
+        </p:spPr>
+      </p:pic>
+      <p:sp>
+        <p:nvSpPr>
+          <p:cNvPr id="9" name="椭圆 8"/>
+          <p:cNvSpPr/>
+          <p:nvPr/>
+        </p:nvSpPr>
+        <p:spPr>
+          <a:xfrm>
+            <a:off x="2331720" y="1945005"/>
+            <a:ext cx="75565" cy="75565"/>
+          </a:xfrm>
+          <a:prstGeom prst="ellipse">
+            <a:avLst/>
+          </a:prstGeom>
+          <a:solidFill>
+            <a:schemeClr val="tx1"/>
+          </a:solidFill>
+        </p:spPr>
+        <p:style>
+          <a:lnRef idx="2">
+            <a:schemeClr val="accent1">
+              <a:lumMod val="75000"/>
+            </a:schemeClr>
+          </a:lnRef>
+          <a:fillRef idx="1">
+            <a:schemeClr val="accent1"/>
+          </a:fillRef>
+          <a:effectRef idx="0">
+            <a:srgbClr val="FFFFFF"/>
+          </a:effectRef>
+          <a:fontRef idx="minor">
+            <a:schemeClr val="lt1"/>
+          </a:fontRef>
+        </p:style>
+        <p:txBody>
+          <a:bodyPr rtlCol="0" anchor="ctr"/>
+          <a:p>
+            <a:pPr algn="ctr"/>
             <a:endParaRPr lang="zh-CN" altLang="en-US"/>
+          </a:p>
+        </p:txBody>
+      </p:sp>
+      <p:sp>
+        <p:nvSpPr>
+          <p:cNvPr id="10" name="椭圆 9"/>
+          <p:cNvSpPr/>
+          <p:nvPr>
+            <p:custDataLst>
+              <p:tags r:id="rId13"/>
+            </p:custDataLst>
+          </p:nvPr>
+        </p:nvSpPr>
+        <p:spPr>
+          <a:xfrm>
+            <a:off x="2435860" y="1802765"/>
+            <a:ext cx="75565" cy="75565"/>
+          </a:xfrm>
+          <a:prstGeom prst="ellipse">
+            <a:avLst/>
+          </a:prstGeom>
+        </p:spPr>
+        <p:style>
+          <a:lnRef idx="2">
+            <a:schemeClr val="accent1">
+              <a:lumMod val="75000"/>
+            </a:schemeClr>
+          </a:lnRef>
+          <a:fillRef idx="1">
+            <a:schemeClr val="accent1"/>
+          </a:fillRef>
+          <a:effectRef idx="0">
+            <a:srgbClr val="FFFFFF"/>
+          </a:effectRef>
+          <a:fontRef idx="minor">
+            <a:schemeClr val="lt1"/>
+          </a:fontRef>
+        </p:style>
+        <p:txBody>
+          <a:bodyPr rtlCol="0" anchor="ctr"/>
+          <a:p>
+            <a:pPr algn="ctr"/>
+            <a:endParaRPr lang="zh-CN" altLang="en-US"/>
+          </a:p>
+        </p:txBody>
+      </p:sp>
+      <p:sp>
+        <p:nvSpPr>
+          <p:cNvPr id="11" name="椭圆 10"/>
+          <p:cNvSpPr/>
+          <p:nvPr>
+            <p:custDataLst>
+              <p:tags r:id="rId14"/>
+            </p:custDataLst>
+          </p:nvPr>
+        </p:nvSpPr>
+        <p:spPr>
+          <a:xfrm>
+            <a:off x="2661920" y="1228725"/>
+            <a:ext cx="75565" cy="75565"/>
+          </a:xfrm>
+          <a:prstGeom prst="ellipse">
+            <a:avLst/>
+          </a:prstGeom>
+        </p:spPr>
+        <p:style>
+          <a:lnRef idx="2">
+            <a:schemeClr val="accent1">
+              <a:lumMod val="75000"/>
+            </a:schemeClr>
+          </a:lnRef>
+          <a:fillRef idx="1">
+            <a:schemeClr val="accent1"/>
+          </a:fillRef>
+          <a:effectRef idx="0">
+            <a:srgbClr val="FFFFFF"/>
+          </a:effectRef>
+          <a:fontRef idx="minor">
+            <a:schemeClr val="lt1"/>
+          </a:fontRef>
+        </p:style>
+        <p:txBody>
+          <a:bodyPr rtlCol="0" anchor="ctr"/>
+          <a:p>
+            <a:pPr algn="ctr"/>
+            <a:endParaRPr lang="zh-CN" altLang="en-US"/>
+          </a:p>
+        </p:txBody>
+      </p:sp>
+      <p:sp>
+        <p:nvSpPr>
+          <p:cNvPr id="12" name="椭圆 11"/>
+          <p:cNvSpPr/>
+          <p:nvPr>
+            <p:custDataLst>
+              <p:tags r:id="rId15"/>
+            </p:custDataLst>
+          </p:nvPr>
+        </p:nvSpPr>
+        <p:spPr>
+          <a:xfrm>
+            <a:off x="2585720" y="1444625"/>
+            <a:ext cx="75565" cy="75565"/>
+          </a:xfrm>
+          <a:prstGeom prst="ellipse">
+            <a:avLst/>
+          </a:prstGeom>
+        </p:spPr>
+        <p:style>
+          <a:lnRef idx="2">
+            <a:schemeClr val="accent1">
+              <a:lumMod val="75000"/>
+            </a:schemeClr>
+          </a:lnRef>
+          <a:fillRef idx="1">
+            <a:schemeClr val="accent1"/>
+          </a:fillRef>
+          <a:effectRef idx="0">
+            <a:srgbClr val="FFFFFF"/>
+          </a:effectRef>
+          <a:fontRef idx="minor">
+            <a:schemeClr val="lt1"/>
+          </a:fontRef>
+        </p:style>
+        <p:txBody>
+          <a:bodyPr rtlCol="0" anchor="ctr"/>
+          <a:p>
+            <a:pPr algn="ctr"/>
+            <a:endParaRPr lang="zh-CN" altLang="en-US"/>
+          </a:p>
+        </p:txBody>
+      </p:sp>
+      <p:sp>
+        <p:nvSpPr>
+          <p:cNvPr id="13" name="椭圆 12"/>
+          <p:cNvSpPr/>
+          <p:nvPr>
+            <p:custDataLst>
+              <p:tags r:id="rId16"/>
+            </p:custDataLst>
+          </p:nvPr>
+        </p:nvSpPr>
+        <p:spPr>
+          <a:xfrm>
+            <a:off x="2204720" y="2079625"/>
+            <a:ext cx="75565" cy="75565"/>
+          </a:xfrm>
+          <a:prstGeom prst="ellipse">
+            <a:avLst/>
+          </a:prstGeom>
+        </p:spPr>
+        <p:style>
+          <a:lnRef idx="2">
+            <a:schemeClr val="accent1">
+              <a:lumMod val="75000"/>
+            </a:schemeClr>
+          </a:lnRef>
+          <a:fillRef idx="1">
+            <a:schemeClr val="accent1"/>
+          </a:fillRef>
+          <a:effectRef idx="0">
+            <a:srgbClr val="FFFFFF"/>
+          </a:effectRef>
+          <a:fontRef idx="minor">
+            <a:schemeClr val="lt1"/>
+          </a:fontRef>
+        </p:style>
+        <p:txBody>
+          <a:bodyPr rtlCol="0" anchor="ctr"/>
+          <a:p>
+            <a:pPr algn="ctr"/>
+            <a:endParaRPr lang="zh-CN" altLang="en-US"/>
+          </a:p>
+        </p:txBody>
+      </p:sp>
+      <p:sp>
+        <p:nvSpPr>
+          <p:cNvPr id="14" name="椭圆 13"/>
+          <p:cNvSpPr/>
+          <p:nvPr>
+            <p:custDataLst>
+              <p:tags r:id="rId17"/>
+            </p:custDataLst>
+          </p:nvPr>
+        </p:nvSpPr>
+        <p:spPr>
+          <a:xfrm>
+            <a:off x="3129280" y="1444625"/>
+            <a:ext cx="75565" cy="75565"/>
+          </a:xfrm>
+          <a:prstGeom prst="ellipse">
+            <a:avLst/>
+          </a:prstGeom>
+        </p:spPr>
+        <p:style>
+          <a:lnRef idx="2">
+            <a:schemeClr val="accent1">
+              <a:lumMod val="75000"/>
+            </a:schemeClr>
+          </a:lnRef>
+          <a:fillRef idx="1">
+            <a:schemeClr val="accent1"/>
+          </a:fillRef>
+          <a:effectRef idx="0">
+            <a:srgbClr val="FFFFFF"/>
+          </a:effectRef>
+          <a:fontRef idx="minor">
+            <a:schemeClr val="lt1"/>
+          </a:fontRef>
+        </p:style>
+        <p:txBody>
+          <a:bodyPr rtlCol="0" anchor="ctr"/>
+          <a:p>
+            <a:pPr algn="ctr"/>
+            <a:endParaRPr lang="zh-CN" altLang="en-US"/>
+          </a:p>
+        </p:txBody>
+      </p:sp>
+      <p:sp>
+        <p:nvSpPr>
+          <p:cNvPr id="15" name="椭圆 14"/>
+          <p:cNvSpPr/>
+          <p:nvPr>
+            <p:custDataLst>
+              <p:tags r:id="rId18"/>
+            </p:custDataLst>
+          </p:nvPr>
+        </p:nvSpPr>
+        <p:spPr>
+          <a:xfrm>
+            <a:off x="3263900" y="1825625"/>
+            <a:ext cx="75565" cy="75565"/>
+          </a:xfrm>
+          <a:prstGeom prst="ellipse">
+            <a:avLst/>
+          </a:prstGeom>
+        </p:spPr>
+        <p:style>
+          <a:lnRef idx="2">
+            <a:schemeClr val="accent1">
+              <a:lumMod val="75000"/>
+            </a:schemeClr>
+          </a:lnRef>
+          <a:fillRef idx="1">
+            <a:schemeClr val="accent1"/>
+          </a:fillRef>
+          <a:effectRef idx="0">
+            <a:srgbClr val="FFFFFF"/>
+          </a:effectRef>
+          <a:fontRef idx="minor">
+            <a:schemeClr val="lt1"/>
+          </a:fontRef>
+        </p:style>
+        <p:txBody>
+          <a:bodyPr rtlCol="0" anchor="ctr"/>
+          <a:p>
+            <a:pPr algn="ctr"/>
+            <a:endParaRPr lang="zh-CN" altLang="en-US"/>
+          </a:p>
+        </p:txBody>
+      </p:sp>
+      <p:sp>
+        <p:nvSpPr>
+          <p:cNvPr id="16" name="椭圆 15"/>
+          <p:cNvSpPr/>
+          <p:nvPr>
+            <p:custDataLst>
+              <p:tags r:id="rId19"/>
+            </p:custDataLst>
+          </p:nvPr>
+        </p:nvSpPr>
+        <p:spPr>
+          <a:xfrm>
+            <a:off x="2600960" y="1355725"/>
+            <a:ext cx="75565" cy="75565"/>
+          </a:xfrm>
+          <a:prstGeom prst="ellipse">
+            <a:avLst/>
+          </a:prstGeom>
+          <a:solidFill>
+            <a:schemeClr val="tx1"/>
+          </a:solidFill>
+        </p:spPr>
+        <p:style>
+          <a:lnRef idx="2">
+            <a:schemeClr val="accent1">
+              <a:lumMod val="75000"/>
+            </a:schemeClr>
+          </a:lnRef>
+          <a:fillRef idx="1">
+            <a:schemeClr val="accent1"/>
+          </a:fillRef>
+          <a:effectRef idx="0">
+            <a:srgbClr val="FFFFFF"/>
+          </a:effectRef>
+          <a:fontRef idx="minor">
+            <a:schemeClr val="lt1"/>
+          </a:fontRef>
+        </p:style>
+        <p:txBody>
+          <a:bodyPr rtlCol="0" anchor="ctr"/>
+          <a:p>
+            <a:pPr algn="ctr"/>
+            <a:endParaRPr lang="zh-CN" altLang="en-US"/>
+          </a:p>
+        </p:txBody>
+      </p:sp>
+      <p:sp>
+        <p:nvSpPr>
+          <p:cNvPr id="17" name="椭圆 16"/>
+          <p:cNvSpPr/>
+          <p:nvPr>
+            <p:custDataLst>
+              <p:tags r:id="rId20"/>
+            </p:custDataLst>
+          </p:nvPr>
+        </p:nvSpPr>
+        <p:spPr>
+          <a:xfrm>
+            <a:off x="3177540" y="1609725"/>
+            <a:ext cx="75565" cy="75565"/>
+          </a:xfrm>
+          <a:prstGeom prst="ellipse">
+            <a:avLst/>
+          </a:prstGeom>
+          <a:solidFill>
+            <a:schemeClr val="tx1"/>
+          </a:solidFill>
+        </p:spPr>
+        <p:style>
+          <a:lnRef idx="2">
+            <a:schemeClr val="accent1">
+              <a:lumMod val="75000"/>
+            </a:schemeClr>
+          </a:lnRef>
+          <a:fillRef idx="1">
+            <a:schemeClr val="accent1"/>
+          </a:fillRef>
+          <a:effectRef idx="0">
+            <a:srgbClr val="FFFFFF"/>
+          </a:effectRef>
+          <a:fontRef idx="minor">
+            <a:schemeClr val="lt1"/>
+          </a:fontRef>
+        </p:style>
+        <p:txBody>
+          <a:bodyPr rtlCol="0" anchor="ctr"/>
+          <a:p>
+            <a:pPr algn="ctr"/>
+            <a:endParaRPr lang="zh-CN" altLang="en-US"/>
+          </a:p>
+        </p:txBody>
+      </p:sp>
+      <p:sp>
+        <p:nvSpPr>
+          <p:cNvPr id="18" name="右箭头 17"/>
+          <p:cNvSpPr/>
+          <p:nvPr/>
+        </p:nvSpPr>
+        <p:spPr>
+          <a:xfrm rot="19260000">
+            <a:off x="2157095" y="1987550"/>
+            <a:ext cx="123190" cy="92075"/>
+          </a:xfrm>
+          <a:prstGeom prst="rightArrow">
+            <a:avLst/>
+          </a:prstGeom>
+        </p:spPr>
+        <p:style>
+          <a:lnRef idx="2">
+            <a:schemeClr val="accent1">
+              <a:lumMod val="75000"/>
+            </a:schemeClr>
+          </a:lnRef>
+          <a:fillRef idx="1">
+            <a:schemeClr val="accent1"/>
+          </a:fillRef>
+          <a:effectRef idx="0">
+            <a:srgbClr val="FFFFFF"/>
+          </a:effectRef>
+          <a:fontRef idx="minor">
+            <a:schemeClr val="lt1"/>
+          </a:fontRef>
+        </p:style>
+        <p:txBody>
+          <a:bodyPr rtlCol="0" anchor="ctr"/>
+          <a:p>
+            <a:pPr algn="ctr"/>
+            <a:endParaRPr lang="zh-CN" altLang="en-US"/>
+          </a:p>
+        </p:txBody>
+      </p:sp>
+      <p:sp>
+        <p:nvSpPr>
+          <p:cNvPr id="19" name="右箭头 18"/>
+          <p:cNvSpPr/>
+          <p:nvPr>
+            <p:custDataLst>
+              <p:tags r:id="rId21"/>
+            </p:custDataLst>
+          </p:nvPr>
+        </p:nvSpPr>
+        <p:spPr>
+          <a:xfrm rot="7200000">
+            <a:off x="2306955" y="1774825"/>
+            <a:ext cx="123190" cy="92075"/>
+          </a:xfrm>
+          <a:prstGeom prst="rightArrow">
+            <a:avLst/>
+          </a:prstGeom>
+        </p:spPr>
+        <p:style>
+          <a:lnRef idx="2">
+            <a:schemeClr val="accent1">
+              <a:lumMod val="75000"/>
+            </a:schemeClr>
+          </a:lnRef>
+          <a:fillRef idx="1">
+            <a:schemeClr val="accent1"/>
+          </a:fillRef>
+          <a:effectRef idx="0">
+            <a:srgbClr val="FFFFFF"/>
+          </a:effectRef>
+          <a:fontRef idx="minor">
+            <a:schemeClr val="lt1"/>
+          </a:fontRef>
+        </p:style>
+        <p:txBody>
+          <a:bodyPr rtlCol="0" anchor="ctr"/>
+          <a:p>
+            <a:pPr algn="ctr"/>
+            <a:endParaRPr lang="zh-CN" altLang="en-US"/>
+          </a:p>
+        </p:txBody>
+      </p:sp>
+      <p:sp>
+        <p:nvSpPr>
+          <p:cNvPr id="20" name="右箭头 19"/>
+          <p:cNvSpPr/>
+          <p:nvPr>
+            <p:custDataLst>
+              <p:tags r:id="rId22"/>
+            </p:custDataLst>
+          </p:nvPr>
+        </p:nvSpPr>
+        <p:spPr>
+          <a:xfrm rot="7200000">
+            <a:off x="2560955" y="1266825"/>
+            <a:ext cx="123190" cy="92075"/>
+          </a:xfrm>
+          <a:prstGeom prst="rightArrow">
+            <a:avLst/>
+          </a:prstGeom>
+        </p:spPr>
+        <p:style>
+          <a:lnRef idx="2">
+            <a:schemeClr val="accent1">
+              <a:lumMod val="75000"/>
+            </a:schemeClr>
+          </a:lnRef>
+          <a:fillRef idx="1">
+            <a:schemeClr val="accent1"/>
+          </a:fillRef>
+          <a:effectRef idx="0">
+            <a:srgbClr val="FFFFFF"/>
+          </a:effectRef>
+          <a:fontRef idx="minor">
+            <a:schemeClr val="lt1"/>
+          </a:fontRef>
+        </p:style>
+        <p:txBody>
+          <a:bodyPr rtlCol="0" anchor="ctr"/>
+          <a:p>
+            <a:pPr algn="ctr"/>
+            <a:endParaRPr lang="zh-CN" altLang="en-US"/>
+          </a:p>
+        </p:txBody>
+      </p:sp>
+      <p:sp>
+        <p:nvSpPr>
+          <p:cNvPr id="21" name="右箭头 20"/>
+          <p:cNvSpPr/>
+          <p:nvPr>
+            <p:custDataLst>
+              <p:tags r:id="rId23"/>
+            </p:custDataLst>
+          </p:nvPr>
+        </p:nvSpPr>
+        <p:spPr>
+          <a:xfrm rot="4200000">
+            <a:off x="3195955" y="1504315"/>
+            <a:ext cx="123190" cy="92075"/>
+          </a:xfrm>
+          <a:prstGeom prst="rightArrow">
+            <a:avLst/>
+          </a:prstGeom>
+        </p:spPr>
+        <p:style>
+          <a:lnRef idx="2">
+            <a:schemeClr val="accent1">
+              <a:lumMod val="75000"/>
+            </a:schemeClr>
+          </a:lnRef>
+          <a:fillRef idx="1">
+            <a:schemeClr val="accent1"/>
+          </a:fillRef>
+          <a:effectRef idx="0">
+            <a:srgbClr val="FFFFFF"/>
+          </a:effectRef>
+          <a:fontRef idx="minor">
+            <a:schemeClr val="lt1"/>
+          </a:fontRef>
+        </p:style>
+        <p:txBody>
+          <a:bodyPr rtlCol="0" anchor="ctr"/>
+          <a:p>
+            <a:pPr algn="ctr"/>
+            <a:endParaRPr lang="zh-CN" altLang="en-US"/>
+          </a:p>
+        </p:txBody>
+      </p:sp>
+      <p:sp>
+        <p:nvSpPr>
+          <p:cNvPr id="22" name="右箭头 21"/>
+          <p:cNvSpPr/>
+          <p:nvPr>
+            <p:custDataLst>
+              <p:tags r:id="rId24"/>
+            </p:custDataLst>
+          </p:nvPr>
+        </p:nvSpPr>
+        <p:spPr>
+          <a:xfrm rot="17220000">
+            <a:off x="2494915" y="1369060"/>
+            <a:ext cx="123190" cy="92075"/>
+          </a:xfrm>
+          <a:prstGeom prst="rightArrow">
+            <a:avLst/>
+          </a:prstGeom>
+        </p:spPr>
+        <p:style>
+          <a:lnRef idx="2">
+            <a:schemeClr val="accent1">
+              <a:lumMod val="75000"/>
+            </a:schemeClr>
+          </a:lnRef>
+          <a:fillRef idx="1">
+            <a:schemeClr val="accent1"/>
+          </a:fillRef>
+          <a:effectRef idx="0">
+            <a:srgbClr val="FFFFFF"/>
+          </a:effectRef>
+          <a:fontRef idx="minor">
+            <a:schemeClr val="lt1"/>
+          </a:fontRef>
+        </p:style>
+        <p:txBody>
+          <a:bodyPr rtlCol="0" anchor="ctr"/>
+          <a:p>
+            <a:pPr algn="ctr"/>
+            <a:endParaRPr lang="zh-CN" altLang="en-US"/>
+          </a:p>
+        </p:txBody>
+      </p:sp>
+      <p:sp>
+        <p:nvSpPr>
+          <p:cNvPr id="23" name="右箭头 22"/>
+          <p:cNvSpPr/>
+          <p:nvPr>
+            <p:custDataLst>
+              <p:tags r:id="rId25"/>
+            </p:custDataLst>
+          </p:nvPr>
+        </p:nvSpPr>
+        <p:spPr>
+          <a:xfrm rot="15240000">
+            <a:off x="3264535" y="1675765"/>
+            <a:ext cx="123190" cy="92075"/>
+          </a:xfrm>
+          <a:prstGeom prst="rightArrow">
+            <a:avLst/>
+          </a:prstGeom>
+        </p:spPr>
+        <p:style>
+          <a:lnRef idx="2">
+            <a:schemeClr val="accent1">
+              <a:lumMod val="75000"/>
+            </a:schemeClr>
+          </a:lnRef>
+          <a:fillRef idx="1">
+            <a:schemeClr val="accent1"/>
+          </a:fillRef>
+          <a:effectRef idx="0">
+            <a:srgbClr val="FFFFFF"/>
+          </a:effectRef>
+          <a:fontRef idx="minor">
+            <a:schemeClr val="lt1"/>
+          </a:fontRef>
+        </p:style>
+        <p:txBody>
+          <a:bodyPr rtlCol="0" anchor="ctr"/>
+          <a:p>
+            <a:pPr algn="ctr"/>
+            <a:endParaRPr lang="zh-CN" altLang="en-US"/>
+          </a:p>
+        </p:txBody>
+      </p:sp>
+      <p:sp>
+        <p:nvSpPr>
+          <p:cNvPr id="24" name="文本框 23"/>
+          <p:cNvSpPr txBox="1"/>
+          <p:nvPr>
+            <p:custDataLst>
+              <p:tags r:id="rId26"/>
+            </p:custDataLst>
+          </p:nvPr>
+        </p:nvSpPr>
+        <p:spPr>
+          <a:xfrm>
+            <a:off x="893445" y="2448560"/>
+            <a:ext cx="3802380" cy="746125"/>
+          </a:xfrm>
+          <a:prstGeom prst="rect">
+            <a:avLst/>
+          </a:prstGeom>
+          <a:noFill/>
+        </p:spPr>
+        <p:txBody>
+          <a:bodyPr wrap="square" rtlCol="0">
+            <a:noAutofit/>
+          </a:bodyPr>
+          <a:p>
+            <a:pPr algn="ctr"/>
+            <a:r>
+              <a:rPr lang="zh-CN" altLang="en-US" sz="1200" b="1">
+                <a:latin typeface="微软雅黑" charset="0"/>
+                <a:ea typeface="微软雅黑" charset="0"/>
+                <a:cs typeface="微软雅黑" charset="0"/>
+              </a:rPr>
+              <a:t>对于连续映射</a:t>
+            </a:r>
+            <a:r>
+              <a:rPr lang="en-US" altLang="zh-CN" sz="1200" b="1">
+                <a:latin typeface="微软雅黑" charset="0"/>
+                <a:ea typeface="微软雅黑" charset="0"/>
+                <a:cs typeface="微软雅黑" charset="0"/>
+              </a:rPr>
+              <a:t>(VAE)</a:t>
+            </a:r>
+            <a:br>
+              <a:rPr lang="en-US" altLang="zh-CN" sz="1200" b="1">
+                <a:latin typeface="微软雅黑" charset="0"/>
+                <a:ea typeface="微软雅黑" charset="0"/>
+                <a:cs typeface="微软雅黑" charset="0"/>
+              </a:rPr>
+            </a:br>
+            <a:r>
+              <a:rPr lang="zh-CN" altLang="en-US" sz="1200" b="1">
+                <a:latin typeface="微软雅黑" charset="0"/>
+                <a:ea typeface="微软雅黑" charset="0"/>
+                <a:cs typeface="微软雅黑" charset="0"/>
+              </a:rPr>
+              <a:t>可能会出现聚类效应</a:t>
+            </a:r>
+            <a:br>
+              <a:rPr lang="zh-CN" altLang="en-US" sz="1200" b="1">
+                <a:latin typeface="微软雅黑" charset="0"/>
+                <a:ea typeface="微软雅黑" charset="0"/>
+                <a:cs typeface="微软雅黑" charset="0"/>
+              </a:rPr>
+            </a:br>
+            <a:r>
+              <a:rPr lang="zh-CN" altLang="en-US" sz="1200" b="1">
+                <a:latin typeface="微软雅黑" charset="0"/>
+                <a:ea typeface="微软雅黑" charset="0"/>
+                <a:cs typeface="微软雅黑" charset="0"/>
+              </a:rPr>
+              <a:t>虽然原本在分布中随机取不同的点</a:t>
+            </a:r>
+            <a:br>
+              <a:rPr lang="zh-CN" altLang="en-US" sz="1200" b="1">
+                <a:latin typeface="微软雅黑" charset="0"/>
+                <a:ea typeface="微软雅黑" charset="0"/>
+                <a:cs typeface="微软雅黑" charset="0"/>
+              </a:rPr>
+            </a:br>
+            <a:r>
+              <a:rPr lang="zh-CN" altLang="en-US" sz="1200" b="1">
+                <a:latin typeface="微软雅黑" charset="0"/>
+                <a:ea typeface="微软雅黑" charset="0"/>
+                <a:cs typeface="微软雅黑" charset="0"/>
+              </a:rPr>
+              <a:t>但是如果</a:t>
+            </a:r>
+            <a:r>
+              <a:rPr lang="en-US" altLang="zh-CN" sz="1200" b="1">
+                <a:latin typeface="微软雅黑" charset="0"/>
+                <a:ea typeface="微软雅黑" charset="0"/>
+                <a:cs typeface="微软雅黑" charset="0"/>
+              </a:rPr>
+              <a:t>decoder</a:t>
+            </a:r>
+            <a:r>
+              <a:rPr lang="zh-CN" altLang="en-US" sz="1200" b="1">
+                <a:latin typeface="微软雅黑" charset="0"/>
+                <a:ea typeface="微软雅黑" charset="0"/>
+                <a:cs typeface="微软雅黑" charset="0"/>
+              </a:rPr>
+              <a:t>过于强大，会将不同的点牵引到附近相同的点上</a:t>
+            </a:r>
+            <a:br>
+              <a:rPr lang="zh-CN" altLang="en-US" sz="1200" b="1">
+                <a:latin typeface="微软雅黑" charset="0"/>
+                <a:ea typeface="微软雅黑" charset="0"/>
+                <a:cs typeface="微软雅黑" charset="0"/>
+              </a:rPr>
+            </a:br>
+            <a:r>
+              <a:rPr lang="zh-CN" altLang="en-US" sz="1200" b="1">
+                <a:latin typeface="微软雅黑" charset="0"/>
+                <a:ea typeface="微软雅黑" charset="0"/>
+                <a:cs typeface="微软雅黑" charset="0"/>
+              </a:rPr>
+              <a:t>从而导致生成的图像随机性下降，只生成几类图像</a:t>
+            </a:r>
+            <a:endParaRPr lang="zh-CN" altLang="en-US" sz="1200" b="1">
+              <a:latin typeface="微软雅黑" charset="0"/>
+              <a:ea typeface="微软雅黑" charset="0"/>
+              <a:cs typeface="微软雅黑" charset="0"/>
+            </a:endParaRPr>
+          </a:p>
+        </p:txBody>
+      </p:sp>
+      <p:sp>
+        <p:nvSpPr>
+          <p:cNvPr id="25" name="右箭头 24"/>
+          <p:cNvSpPr/>
+          <p:nvPr/>
+        </p:nvSpPr>
+        <p:spPr>
+          <a:xfrm>
+            <a:off x="986790" y="1349375"/>
+            <a:ext cx="382270" cy="168275"/>
+          </a:xfrm>
+          <a:prstGeom prst="rightArrow">
+            <a:avLst/>
+          </a:prstGeom>
+        </p:spPr>
+        <p:style>
+          <a:lnRef idx="2">
+            <a:schemeClr val="accent1">
+              <a:lumMod val="75000"/>
+            </a:schemeClr>
+          </a:lnRef>
+          <a:fillRef idx="1">
+            <a:schemeClr val="accent1"/>
+          </a:fillRef>
+          <a:effectRef idx="0">
+            <a:srgbClr val="FFFFFF"/>
+          </a:effectRef>
+          <a:fontRef idx="minor">
+            <a:schemeClr val="lt1"/>
+          </a:fontRef>
+        </p:style>
+        <p:txBody>
+          <a:bodyPr rtlCol="0" anchor="ctr"/>
+          <a:p>
+            <a:pPr algn="ctr"/>
+            <a:endParaRPr lang="zh-CN" altLang="en-US"/>
+          </a:p>
+        </p:txBody>
+      </p:sp>
+      <p:sp>
+        <p:nvSpPr>
+          <p:cNvPr id="26" name="右箭头 25"/>
+          <p:cNvSpPr/>
+          <p:nvPr>
+            <p:custDataLst>
+              <p:tags r:id="rId27"/>
+            </p:custDataLst>
+          </p:nvPr>
+        </p:nvSpPr>
+        <p:spPr>
+          <a:xfrm>
+            <a:off x="4161790" y="1349375"/>
+            <a:ext cx="382270" cy="168275"/>
+          </a:xfrm>
+          <a:prstGeom prst="rightArrow">
+            <a:avLst/>
+          </a:prstGeom>
+        </p:spPr>
+        <p:style>
+          <a:lnRef idx="2">
+            <a:schemeClr val="accent1">
+              <a:lumMod val="75000"/>
+            </a:schemeClr>
+          </a:lnRef>
+          <a:fillRef idx="1">
+            <a:schemeClr val="accent1"/>
+          </a:fillRef>
+          <a:effectRef idx="0">
+            <a:srgbClr val="FFFFFF"/>
+          </a:effectRef>
+          <a:fontRef idx="minor">
+            <a:schemeClr val="lt1"/>
+          </a:fontRef>
+        </p:style>
+        <p:txBody>
+          <a:bodyPr rtlCol="0" anchor="ctr"/>
+          <a:p>
+            <a:pPr algn="ctr"/>
+            <a:endParaRPr lang="zh-CN" altLang="en-US"/>
+          </a:p>
+        </p:txBody>
+      </p:sp>
+      <p:sp>
+        <p:nvSpPr>
+          <p:cNvPr id="27" name="右箭头 26"/>
+          <p:cNvSpPr/>
+          <p:nvPr>
+            <p:custDataLst>
+              <p:tags r:id="rId28"/>
+            </p:custDataLst>
+          </p:nvPr>
+        </p:nvSpPr>
+        <p:spPr>
+          <a:xfrm rot="19100646">
+            <a:off x="4169410" y="739775"/>
+            <a:ext cx="382270" cy="168275"/>
+          </a:xfrm>
+          <a:prstGeom prst="rightArrow">
+            <a:avLst/>
+          </a:prstGeom>
+        </p:spPr>
+        <p:style>
+          <a:lnRef idx="2">
+            <a:schemeClr val="accent1">
+              <a:lumMod val="75000"/>
+            </a:schemeClr>
+          </a:lnRef>
+          <a:fillRef idx="1">
+            <a:schemeClr val="accent1"/>
+          </a:fillRef>
+          <a:effectRef idx="0">
+            <a:srgbClr val="FFFFFF"/>
+          </a:effectRef>
+          <a:fontRef idx="minor">
+            <a:schemeClr val="lt1"/>
+          </a:fontRef>
+        </p:style>
+        <p:txBody>
+          <a:bodyPr rtlCol="0" anchor="ctr"/>
+          <a:p>
+            <a:pPr algn="ctr"/>
+            <a:endParaRPr lang="zh-CN" altLang="en-US"/>
+          </a:p>
+        </p:txBody>
+      </p:sp>
+      <p:sp>
+        <p:nvSpPr>
+          <p:cNvPr id="28" name="右箭头 27"/>
+          <p:cNvSpPr/>
+          <p:nvPr>
+            <p:custDataLst>
+              <p:tags r:id="rId29"/>
+            </p:custDataLst>
+          </p:nvPr>
+        </p:nvSpPr>
+        <p:spPr>
+          <a:xfrm rot="2360646">
+            <a:off x="4174490" y="1955165"/>
+            <a:ext cx="382270" cy="168275"/>
+          </a:xfrm>
+          <a:prstGeom prst="rightArrow">
+            <a:avLst/>
+          </a:prstGeom>
+        </p:spPr>
+        <p:style>
+          <a:lnRef idx="2">
+            <a:schemeClr val="accent1">
+              <a:lumMod val="75000"/>
+            </a:schemeClr>
+          </a:lnRef>
+          <a:fillRef idx="1">
+            <a:schemeClr val="accent1"/>
+          </a:fillRef>
+          <a:effectRef idx="0">
+            <a:srgbClr val="FFFFFF"/>
+          </a:effectRef>
+          <a:fontRef idx="minor">
+            <a:schemeClr val="lt1"/>
+          </a:fontRef>
+        </p:style>
+        <p:txBody>
+          <a:bodyPr rtlCol="0" anchor="ctr"/>
+          <a:p>
+            <a:pPr algn="ctr"/>
+            <a:endParaRPr lang="zh-CN" altLang="en-US"/>
+          </a:p>
+        </p:txBody>
+      </p:sp>
+      <p:pic>
+        <p:nvPicPr>
+          <p:cNvPr id="29" name="图片 28"/>
+          <p:cNvPicPr>
+            <a:picLocks noChangeAspect="1"/>
+          </p:cNvPicPr>
+          <p:nvPr>
+            <p:custDataLst>
+              <p:tags r:id="rId30"/>
+            </p:custDataLst>
+          </p:nvPr>
+        </p:nvPicPr>
+        <p:blipFill>
+          <a:blip r:embed="rId31"/>
+          <a:stretch>
+            <a:fillRect/>
+          </a:stretch>
+        </p:blipFill>
+        <p:spPr>
+          <a:xfrm>
+            <a:off x="5620385" y="349250"/>
+            <a:ext cx="3312795" cy="1395095"/>
+          </a:xfrm>
+          <a:prstGeom prst="rect">
+            <a:avLst/>
+          </a:prstGeom>
+        </p:spPr>
+      </p:pic>
+      <p:pic>
+        <p:nvPicPr>
+          <p:cNvPr id="30" name="图片 29"/>
+          <p:cNvPicPr>
+            <a:picLocks noChangeAspect="1"/>
+          </p:cNvPicPr>
+          <p:nvPr>
+            <p:custDataLst>
+              <p:tags r:id="rId32"/>
+            </p:custDataLst>
+          </p:nvPr>
+        </p:nvPicPr>
+        <p:blipFill>
+          <a:blip r:embed="rId33"/>
+          <a:stretch>
+            <a:fillRect/>
+          </a:stretch>
+        </p:blipFill>
+        <p:spPr>
+          <a:xfrm>
+            <a:off x="9102090" y="645795"/>
+            <a:ext cx="2715260" cy="880745"/>
+          </a:xfrm>
+          <a:prstGeom prst="rect">
+            <a:avLst/>
+          </a:prstGeom>
+        </p:spPr>
+      </p:pic>
+      <p:sp>
+        <p:nvSpPr>
+          <p:cNvPr id="31" name="文本框 30"/>
+          <p:cNvSpPr txBox="1"/>
+          <p:nvPr>
+            <p:custDataLst>
+              <p:tags r:id="rId34"/>
+            </p:custDataLst>
+          </p:nvPr>
+        </p:nvSpPr>
+        <p:spPr>
+          <a:xfrm>
+            <a:off x="9141460" y="0"/>
+            <a:ext cx="2799715" cy="575310"/>
+          </a:xfrm>
+          <a:prstGeom prst="rect">
+            <a:avLst/>
+          </a:prstGeom>
+          <a:noFill/>
+        </p:spPr>
+        <p:txBody>
+          <a:bodyPr wrap="square" rtlCol="0">
+            <a:noAutofit/>
+          </a:bodyPr>
+          <a:p>
+            <a:pPr algn="ctr"/>
+            <a:r>
+              <a:rPr lang="en-US" altLang="zh-CN" sz="1400" b="1">
+                <a:latin typeface="微软雅黑" charset="0"/>
+                <a:ea typeface="微软雅黑" charset="0"/>
+                <a:cs typeface="微软雅黑" charset="0"/>
+              </a:rPr>
+              <a:t>VQ-VAE</a:t>
+            </a:r>
+            <a:br>
+              <a:rPr lang="en-US" altLang="zh-CN" sz="1400" b="1">
+                <a:latin typeface="微软雅黑" charset="0"/>
+                <a:ea typeface="微软雅黑" charset="0"/>
+                <a:cs typeface="微软雅黑" charset="0"/>
+              </a:rPr>
+            </a:br>
+            <a:r>
+              <a:rPr lang="zh-CN" altLang="en-US" sz="1400" b="1">
+                <a:latin typeface="微软雅黑" charset="0"/>
+                <a:ea typeface="微软雅黑" charset="0"/>
+                <a:cs typeface="微软雅黑" charset="0"/>
+              </a:rPr>
+              <a:t>采用离散化，来降低吸附的</a:t>
+            </a:r>
+            <a:r>
+              <a:rPr lang="zh-CN" altLang="en-US" sz="1400" b="1">
+                <a:latin typeface="微软雅黑" charset="0"/>
+                <a:ea typeface="微软雅黑" charset="0"/>
+                <a:cs typeface="微软雅黑" charset="0"/>
+              </a:rPr>
+              <a:t>问题</a:t>
+            </a:r>
+            <a:endParaRPr lang="zh-CN" altLang="en-US" sz="1400" b="1">
+              <a:latin typeface="微软雅黑" charset="0"/>
+              <a:ea typeface="微软雅黑" charset="0"/>
+              <a:cs typeface="微软雅黑" charset="0"/>
+            </a:endParaRPr>
+          </a:p>
+        </p:txBody>
+      </p:sp>
+      <p:sp>
+        <p:nvSpPr>
+          <p:cNvPr id="32" name="文本框 31"/>
+          <p:cNvSpPr txBox="1"/>
+          <p:nvPr>
+            <p:custDataLst>
+              <p:tags r:id="rId35"/>
+            </p:custDataLst>
+          </p:nvPr>
+        </p:nvSpPr>
+        <p:spPr>
+          <a:xfrm>
+            <a:off x="5876925" y="58420"/>
+            <a:ext cx="2799715" cy="575310"/>
+          </a:xfrm>
+          <a:prstGeom prst="rect">
+            <a:avLst/>
+          </a:prstGeom>
+          <a:noFill/>
+        </p:spPr>
+        <p:txBody>
+          <a:bodyPr wrap="square" rtlCol="0">
+            <a:noAutofit/>
+          </a:bodyPr>
+          <a:p>
+            <a:pPr algn="ctr"/>
+            <a:r>
+              <a:rPr lang="en-US" altLang="zh-CN" sz="1400" b="1">
+                <a:latin typeface="微软雅黑" charset="0"/>
+                <a:ea typeface="微软雅黑" charset="0"/>
+                <a:cs typeface="微软雅黑" charset="0"/>
+              </a:rPr>
+              <a:t>VAE</a:t>
+            </a:r>
+            <a:endParaRPr lang="zh-CN" altLang="en-US" sz="1400" b="1">
+              <a:latin typeface="微软雅黑" charset="0"/>
+              <a:ea typeface="微软雅黑" charset="0"/>
+              <a:cs typeface="微软雅黑" charset="0"/>
+            </a:endParaRPr>
+          </a:p>
+        </p:txBody>
+      </p:sp>
+      <p:sp>
+        <p:nvSpPr>
+          <p:cNvPr id="36" name="文本框 35"/>
+          <p:cNvSpPr txBox="1"/>
+          <p:nvPr>
+            <p:custDataLst>
+              <p:tags r:id="rId36"/>
+            </p:custDataLst>
+          </p:nvPr>
+        </p:nvSpPr>
+        <p:spPr>
+          <a:xfrm>
+            <a:off x="1663700" y="4084955"/>
+            <a:ext cx="2799715" cy="575310"/>
+          </a:xfrm>
+          <a:prstGeom prst="rect">
+            <a:avLst/>
+          </a:prstGeom>
+          <a:noFill/>
+        </p:spPr>
+        <p:txBody>
+          <a:bodyPr wrap="square" rtlCol="0">
+            <a:noAutofit/>
+          </a:bodyPr>
+          <a:p>
+            <a:pPr algn="ctr"/>
+            <a:r>
+              <a:rPr lang="zh-CN" altLang="en-US" sz="1200" b="1">
+                <a:latin typeface="微软雅黑" charset="0"/>
+                <a:ea typeface="微软雅黑" charset="0"/>
+                <a:cs typeface="微软雅黑" charset="0"/>
+              </a:rPr>
+              <a:t>维护了一个</a:t>
+            </a:r>
+            <a:r>
+              <a:rPr lang="en-US" altLang="zh-CN" sz="1200" b="1">
+                <a:latin typeface="微软雅黑" charset="0"/>
+                <a:ea typeface="微软雅黑" charset="0"/>
+                <a:cs typeface="微软雅黑" charset="0"/>
+              </a:rPr>
+              <a:t>Code</a:t>
+            </a:r>
+            <a:r>
+              <a:rPr lang="en-US" altLang="zh-CN" sz="1200" b="1">
+                <a:latin typeface="微软雅黑" charset="0"/>
+                <a:ea typeface="微软雅黑" charset="0"/>
+                <a:cs typeface="微软雅黑" charset="0"/>
+              </a:rPr>
+              <a:t>Book</a:t>
+            </a:r>
+            <a:endParaRPr lang="en-US" altLang="zh-CN" sz="1200" b="1">
+              <a:latin typeface="微软雅黑" charset="0"/>
+              <a:ea typeface="微软雅黑" charset="0"/>
+              <a:cs typeface="微软雅黑" charset="0"/>
+            </a:endParaRPr>
+          </a:p>
+        </p:txBody>
+      </p:sp>
+      <p:sp>
+        <p:nvSpPr>
+          <p:cNvPr id="37" name="文本框 36"/>
+          <p:cNvSpPr txBox="1"/>
+          <p:nvPr>
+            <p:custDataLst>
+              <p:tags r:id="rId37"/>
+            </p:custDataLst>
+          </p:nvPr>
+        </p:nvSpPr>
+        <p:spPr>
+          <a:xfrm>
+            <a:off x="-27305" y="5984875"/>
+            <a:ext cx="3314065" cy="575310"/>
+          </a:xfrm>
+          <a:prstGeom prst="rect">
+            <a:avLst/>
+          </a:prstGeom>
+          <a:noFill/>
+        </p:spPr>
+        <p:txBody>
+          <a:bodyPr wrap="square" rtlCol="0">
+            <a:noAutofit/>
+          </a:bodyPr>
+          <a:p>
+            <a:pPr algn="ctr"/>
+            <a:r>
+              <a:rPr lang="zh-CN" altLang="en-US" sz="1200" b="1">
+                <a:latin typeface="微软雅黑" charset="0"/>
+                <a:ea typeface="微软雅黑" charset="0"/>
+                <a:cs typeface="微软雅黑" charset="0"/>
+              </a:rPr>
+              <a:t>将图像映射成</a:t>
+            </a:r>
+            <a:r>
+              <a:rPr lang="en-US" altLang="zh-CN" sz="1200" b="1">
+                <a:latin typeface="微软雅黑" charset="0"/>
+                <a:ea typeface="微软雅黑" charset="0"/>
+                <a:cs typeface="微软雅黑" charset="0"/>
+              </a:rPr>
+              <a:t>n</a:t>
+            </a:r>
+            <a:r>
+              <a:rPr lang="zh-CN" altLang="en-US" sz="1200" b="1">
+                <a:latin typeface="微软雅黑" charset="0"/>
+                <a:ea typeface="微软雅黑" charset="0"/>
+                <a:cs typeface="微软雅黑" charset="0"/>
+              </a:rPr>
+              <a:t>个特征后</a:t>
+            </a:r>
+            <a:r>
+              <a:rPr lang="en-US" altLang="zh-CN" sz="1200" b="1">
+                <a:latin typeface="微软雅黑" charset="0"/>
+                <a:ea typeface="微软雅黑" charset="0"/>
+                <a:cs typeface="微软雅黑" charset="0"/>
+              </a:rPr>
+              <a:t>(</a:t>
+            </a:r>
+            <a:r>
+              <a:rPr lang="zh-CN" altLang="en-US" sz="1200" b="1">
+                <a:latin typeface="微软雅黑" charset="0"/>
+                <a:ea typeface="微软雅黑" charset="0"/>
+                <a:cs typeface="微软雅黑" charset="0"/>
+              </a:rPr>
+              <a:t>连续</a:t>
+            </a:r>
+            <a:r>
+              <a:rPr lang="en-US" altLang="zh-CN" sz="1200" b="1">
+                <a:latin typeface="微软雅黑" charset="0"/>
+                <a:ea typeface="微软雅黑" charset="0"/>
+                <a:cs typeface="微软雅黑" charset="0"/>
+              </a:rPr>
+              <a:t>)</a:t>
+            </a:r>
+            <a:r>
+              <a:rPr lang="zh-CN" altLang="en-US" sz="1200" b="1">
+                <a:latin typeface="微软雅黑" charset="0"/>
+                <a:ea typeface="微软雅黑" charset="0"/>
+                <a:cs typeface="微软雅黑" charset="0"/>
+              </a:rPr>
+              <a:t>，将每个特征和</a:t>
+            </a:r>
+            <a:r>
+              <a:rPr lang="en-US" altLang="zh-CN" sz="1200" b="1">
+                <a:latin typeface="微软雅黑" charset="0"/>
+                <a:ea typeface="微软雅黑" charset="0"/>
+                <a:cs typeface="微软雅黑" charset="0"/>
+              </a:rPr>
+              <a:t>codebook</a:t>
+            </a:r>
+            <a:r>
+              <a:rPr lang="zh-CN" altLang="en-US" sz="1200" b="1">
+                <a:latin typeface="微软雅黑" charset="0"/>
+                <a:ea typeface="微软雅黑" charset="0"/>
+                <a:cs typeface="微软雅黑" charset="0"/>
+              </a:rPr>
+              <a:t>对比，替换为最近的</a:t>
+            </a:r>
+            <a:r>
+              <a:rPr lang="en-US" altLang="zh-CN" sz="1200" b="1">
+                <a:latin typeface="微软雅黑" charset="0"/>
+                <a:ea typeface="微软雅黑" charset="0"/>
+                <a:cs typeface="微软雅黑" charset="0"/>
+              </a:rPr>
+              <a:t>codebook</a:t>
+            </a:r>
+            <a:r>
+              <a:rPr lang="zh-CN" altLang="en-US" sz="1200" b="1">
+                <a:latin typeface="微软雅黑" charset="0"/>
+                <a:ea typeface="微软雅黑" charset="0"/>
+                <a:cs typeface="微软雅黑" charset="0"/>
+              </a:rPr>
+              <a:t>中的特征</a:t>
+            </a:r>
+            <a:r>
+              <a:rPr lang="en-US" altLang="zh-CN" sz="1200" b="1">
+                <a:latin typeface="微软雅黑" charset="0"/>
+                <a:ea typeface="微软雅黑" charset="0"/>
+                <a:cs typeface="微软雅黑" charset="0"/>
+              </a:rPr>
+              <a:t>(</a:t>
+            </a:r>
+            <a:r>
+              <a:rPr lang="zh-CN" altLang="en-US" sz="1200" b="1">
+                <a:latin typeface="微软雅黑" charset="0"/>
+                <a:ea typeface="微软雅黑" charset="0"/>
+                <a:cs typeface="微软雅黑" charset="0"/>
+              </a:rPr>
+              <a:t>离散</a:t>
+            </a:r>
+            <a:r>
+              <a:rPr lang="en-US" altLang="zh-CN" sz="1200" b="1">
+                <a:latin typeface="微软雅黑" charset="0"/>
+                <a:ea typeface="微软雅黑" charset="0"/>
+                <a:cs typeface="微软雅黑" charset="0"/>
+              </a:rPr>
+              <a:t>)</a:t>
+            </a:r>
+            <a:endParaRPr lang="en-US" altLang="zh-CN" sz="1200" b="1">
+              <a:latin typeface="微软雅黑" charset="0"/>
+              <a:ea typeface="微软雅黑" charset="0"/>
+              <a:cs typeface="微软雅黑" charset="0"/>
+            </a:endParaRPr>
+          </a:p>
+        </p:txBody>
+      </p:sp>
+      <p:sp>
+        <p:nvSpPr>
+          <p:cNvPr id="38" name="矩形: 圆角 36"/>
+          <p:cNvSpPr/>
+          <p:nvPr>
+            <p:custDataLst>
+              <p:tags r:id="rId38"/>
+            </p:custDataLst>
+          </p:nvPr>
+        </p:nvSpPr>
+        <p:spPr>
+          <a:xfrm rot="10800000" flipV="1">
+            <a:off x="2036445" y="3957955"/>
+            <a:ext cx="2054225" cy="1075055"/>
+          </a:xfrm>
+          <a:prstGeom prst="roundRect">
+            <a:avLst>
+              <a:gd name="adj" fmla="val 10039"/>
+            </a:avLst>
+          </a:prstGeom>
+          <a:noFill/>
+          <a:ln w="38100">
+            <a:solidFill>
+              <a:schemeClr val="tx1"/>
+            </a:solidFill>
+            <a:prstDash val="lgDash"/>
+          </a:ln>
+        </p:spPr>
+        <p:style>
+          <a:lnRef idx="2">
+            <a:schemeClr val="accent1">
+              <a:shade val="15000"/>
+            </a:schemeClr>
+          </a:lnRef>
+          <a:fillRef idx="1">
+            <a:schemeClr val="accent1"/>
+          </a:fillRef>
+          <a:effectRef idx="0">
+            <a:schemeClr val="accent1"/>
+          </a:effectRef>
+          <a:fontRef idx="minor">
+            <a:schemeClr val="lt1"/>
+          </a:fontRef>
+        </p:style>
+        <p:txBody>
+          <a:bodyPr rtlCol="0" anchor="ctr"/>
+          <a:p>
+            <a:pPr algn="ctr"/>
+            <a:endParaRPr lang="zh-CN" altLang="en-US"/>
+          </a:p>
+        </p:txBody>
+      </p:sp>
+      <p:sp>
+        <p:nvSpPr>
+          <p:cNvPr id="39" name="矩形: 圆角 36"/>
+          <p:cNvSpPr/>
+          <p:nvPr>
+            <p:custDataLst>
+              <p:tags r:id="rId39"/>
+            </p:custDataLst>
+          </p:nvPr>
+        </p:nvSpPr>
+        <p:spPr>
+          <a:xfrm rot="10800000" flipV="1">
+            <a:off x="-27940" y="5033645"/>
+            <a:ext cx="3315335" cy="1526540"/>
+          </a:xfrm>
+          <a:prstGeom prst="roundRect">
+            <a:avLst>
+              <a:gd name="adj" fmla="val 10039"/>
+            </a:avLst>
+          </a:prstGeom>
+          <a:noFill/>
+          <a:ln w="38100">
+            <a:solidFill>
+              <a:schemeClr val="tx1"/>
+            </a:solidFill>
+            <a:prstDash val="lgDash"/>
+          </a:ln>
+        </p:spPr>
+        <p:style>
+          <a:lnRef idx="2">
+            <a:schemeClr val="accent1">
+              <a:shade val="15000"/>
+            </a:schemeClr>
+          </a:lnRef>
+          <a:fillRef idx="1">
+            <a:schemeClr val="accent1"/>
+          </a:fillRef>
+          <a:effectRef idx="0">
+            <a:schemeClr val="accent1"/>
+          </a:effectRef>
+          <a:fontRef idx="minor">
+            <a:schemeClr val="lt1"/>
+          </a:fontRef>
+        </p:style>
+        <p:txBody>
+          <a:bodyPr rtlCol="0" anchor="ctr"/>
+          <a:p>
+            <a:pPr algn="ctr"/>
+            <a:endParaRPr lang="zh-CN" altLang="en-US"/>
+          </a:p>
+        </p:txBody>
+      </p:sp>
+      <p:sp>
+        <p:nvSpPr>
+          <p:cNvPr id="40" name="文本框 39"/>
+          <p:cNvSpPr txBox="1"/>
+          <p:nvPr>
+            <p:custDataLst>
+              <p:tags r:id="rId40"/>
+            </p:custDataLst>
+          </p:nvPr>
+        </p:nvSpPr>
+        <p:spPr>
+          <a:xfrm>
+            <a:off x="3863340" y="6111875"/>
+            <a:ext cx="1390650" cy="575310"/>
+          </a:xfrm>
+          <a:prstGeom prst="rect">
+            <a:avLst/>
+          </a:prstGeom>
+          <a:noFill/>
+        </p:spPr>
+        <p:txBody>
+          <a:bodyPr wrap="square" rtlCol="0">
+            <a:noAutofit/>
+          </a:bodyPr>
+          <a:p>
+            <a:pPr algn="ctr"/>
+            <a:r>
+              <a:rPr lang="zh-CN" altLang="en-US" sz="1200" b="1">
+                <a:latin typeface="微软雅黑" charset="0"/>
+                <a:ea typeface="微软雅黑" charset="0"/>
+                <a:cs typeface="微软雅黑" charset="0"/>
+              </a:rPr>
+              <a:t>根据离散的特征去恢复图像</a:t>
+            </a:r>
+            <a:endParaRPr lang="zh-CN" altLang="en-US" sz="1200" b="1">
+              <a:latin typeface="微软雅黑" charset="0"/>
+              <a:ea typeface="微软雅黑" charset="0"/>
+              <a:cs typeface="微软雅黑" charset="0"/>
+            </a:endParaRPr>
+          </a:p>
+        </p:txBody>
+      </p:sp>
+      <p:sp>
+        <p:nvSpPr>
+          <p:cNvPr id="41" name="矩形: 圆角 36"/>
+          <p:cNvSpPr/>
+          <p:nvPr>
+            <p:custDataLst>
+              <p:tags r:id="rId41"/>
+            </p:custDataLst>
+          </p:nvPr>
+        </p:nvSpPr>
+        <p:spPr>
+          <a:xfrm rot="10800000" flipV="1">
+            <a:off x="3627755" y="5029835"/>
+            <a:ext cx="1626235" cy="1657985"/>
+          </a:xfrm>
+          <a:prstGeom prst="roundRect">
+            <a:avLst>
+              <a:gd name="adj" fmla="val 10039"/>
+            </a:avLst>
+          </a:prstGeom>
+          <a:noFill/>
+          <a:ln w="38100">
+            <a:solidFill>
+              <a:schemeClr val="tx1"/>
+            </a:solidFill>
+            <a:prstDash val="lgDash"/>
+          </a:ln>
+        </p:spPr>
+        <p:style>
+          <a:lnRef idx="2">
+            <a:schemeClr val="accent1">
+              <a:shade val="15000"/>
+            </a:schemeClr>
+          </a:lnRef>
+          <a:fillRef idx="1">
+            <a:schemeClr val="accent1"/>
+          </a:fillRef>
+          <a:effectRef idx="0">
+            <a:schemeClr val="accent1"/>
+          </a:effectRef>
+          <a:fontRef idx="minor">
+            <a:schemeClr val="lt1"/>
+          </a:fontRef>
+        </p:style>
+        <p:txBody>
+          <a:bodyPr rtlCol="0" anchor="ctr"/>
+          <a:p>
+            <a:pPr algn="ctr"/>
+            <a:endParaRPr lang="zh-CN" altLang="en-US"/>
+          </a:p>
+        </p:txBody>
+      </p:sp>
+      <p:sp>
+        <p:nvSpPr>
+          <p:cNvPr id="42" name="文本框 41"/>
+          <p:cNvSpPr txBox="1"/>
+          <p:nvPr>
+            <p:custDataLst>
+              <p:tags r:id="rId42"/>
+            </p:custDataLst>
+          </p:nvPr>
+        </p:nvSpPr>
+        <p:spPr>
+          <a:xfrm>
+            <a:off x="8627745" y="4206875"/>
+            <a:ext cx="3313430" cy="1315720"/>
+          </a:xfrm>
+          <a:prstGeom prst="rect">
+            <a:avLst/>
+          </a:prstGeom>
+          <a:noFill/>
+        </p:spPr>
+        <p:txBody>
+          <a:bodyPr wrap="square" rtlCol="0">
+            <a:noAutofit/>
+          </a:bodyPr>
+          <a:p>
+            <a:pPr algn="ctr"/>
+            <a:r>
+              <a:rPr lang="en-US" altLang="zh-CN" sz="1400" b="1">
+                <a:latin typeface="微软雅黑" charset="0"/>
+                <a:ea typeface="微软雅黑" charset="0"/>
+                <a:cs typeface="微软雅黑" charset="0"/>
+              </a:rPr>
+              <a:t>Encoder+Decoder</a:t>
+            </a:r>
+            <a:r>
+              <a:rPr lang="zh-CN" altLang="en-US" sz="1400" b="1">
+                <a:latin typeface="微软雅黑" charset="0"/>
+                <a:ea typeface="微软雅黑" charset="0"/>
+                <a:cs typeface="微软雅黑" charset="0"/>
+              </a:rPr>
+              <a:t>训练</a:t>
+            </a:r>
+            <a:br>
+              <a:rPr lang="zh-CN" altLang="en-US" sz="1400" b="1">
+                <a:latin typeface="微软雅黑" charset="0"/>
+                <a:ea typeface="微软雅黑" charset="0"/>
+                <a:cs typeface="微软雅黑" charset="0"/>
+              </a:rPr>
+            </a:br>
+            <a:r>
+              <a:rPr lang="zh-CN" altLang="en-US" sz="1400" b="1">
+                <a:latin typeface="微软雅黑" charset="0"/>
+                <a:ea typeface="微软雅黑" charset="0"/>
+                <a:cs typeface="微软雅黑" charset="0"/>
+              </a:rPr>
+              <a:t>根据初始图像和重建图像的</a:t>
+            </a:r>
+            <a:r>
+              <a:rPr lang="en-US" altLang="zh-CN" sz="1400" b="1">
+                <a:latin typeface="微软雅黑" charset="0"/>
+                <a:ea typeface="微软雅黑" charset="0"/>
+                <a:cs typeface="微软雅黑" charset="0"/>
+              </a:rPr>
+              <a:t>MSE Loss</a:t>
+            </a:r>
+            <a:br>
+              <a:rPr lang="en-US" altLang="zh-CN" sz="1400" b="1">
+                <a:latin typeface="微软雅黑" charset="0"/>
+                <a:ea typeface="微软雅黑" charset="0"/>
+                <a:cs typeface="微软雅黑" charset="0"/>
+              </a:rPr>
+            </a:br>
+            <a:r>
+              <a:rPr lang="en-US" altLang="zh-CN" sz="1400" b="1">
+                <a:latin typeface="微软雅黑" charset="0"/>
+                <a:ea typeface="微软雅黑" charset="0"/>
+                <a:cs typeface="微软雅黑" charset="0"/>
+              </a:rPr>
+              <a:t>codebook</a:t>
+            </a:r>
+            <a:r>
+              <a:rPr lang="zh-CN" altLang="en-US" sz="1400" b="1">
+                <a:latin typeface="微软雅黑" charset="0"/>
+                <a:ea typeface="微软雅黑" charset="0"/>
+                <a:cs typeface="微软雅黑" charset="0"/>
+              </a:rPr>
+              <a:t>训练</a:t>
+            </a:r>
+            <a:endParaRPr lang="zh-CN" altLang="en-US" sz="1400" b="1">
+              <a:latin typeface="微软雅黑" charset="0"/>
+              <a:ea typeface="微软雅黑" charset="0"/>
+              <a:cs typeface="微软雅黑" charset="0"/>
+            </a:endParaRPr>
+          </a:p>
+          <a:p>
+            <a:pPr algn="ctr"/>
+            <a:r>
+              <a:rPr lang="zh-CN" altLang="en-US" sz="1400" b="1">
+                <a:latin typeface="微软雅黑" charset="0"/>
+                <a:ea typeface="微软雅黑" charset="0"/>
+                <a:cs typeface="微软雅黑" charset="0"/>
+              </a:rPr>
+              <a:t>在初始输入特征中，计算和</a:t>
+            </a:r>
+            <a:r>
+              <a:rPr lang="en-US" altLang="zh-CN" sz="1400" b="1">
+                <a:latin typeface="微软雅黑" charset="0"/>
+                <a:ea typeface="微软雅黑" charset="0"/>
+                <a:cs typeface="微软雅黑" charset="0"/>
+              </a:rPr>
+              <a:t>codebook</a:t>
+            </a:r>
+            <a:r>
+              <a:rPr lang="zh-CN" altLang="en-US" sz="1400" b="1">
+                <a:latin typeface="微软雅黑" charset="0"/>
+                <a:ea typeface="微软雅黑" charset="0"/>
+                <a:cs typeface="微软雅黑" charset="0"/>
+              </a:rPr>
+              <a:t>中的距离，离的最近的那个</a:t>
+            </a:r>
+            <a:r>
+              <a:rPr lang="en-US" altLang="zh-CN" sz="1400" b="1">
+                <a:latin typeface="微软雅黑" charset="0"/>
+                <a:ea typeface="微软雅黑" charset="0"/>
+                <a:cs typeface="微软雅黑" charset="0"/>
+              </a:rPr>
+              <a:t>codebook</a:t>
+            </a:r>
+            <a:r>
+              <a:rPr lang="zh-CN" altLang="en-US" sz="1400" b="1">
+                <a:latin typeface="微软雅黑" charset="0"/>
+                <a:ea typeface="微软雅黑" charset="0"/>
+                <a:cs typeface="微软雅黑" charset="0"/>
+              </a:rPr>
+              <a:t>中的特征朝真实的特征方向优化（朝着真实的</a:t>
+            </a:r>
+            <a:r>
+              <a:rPr lang="zh-CN" altLang="en-US" sz="1400" b="1">
+                <a:latin typeface="微软雅黑" charset="0"/>
+                <a:ea typeface="微软雅黑" charset="0"/>
+                <a:cs typeface="微软雅黑" charset="0"/>
+              </a:rPr>
+              <a:t>方向拉一下）</a:t>
+            </a:r>
+            <a:endParaRPr lang="zh-CN" altLang="en-US" sz="1400" b="1">
+              <a:latin typeface="微软雅黑" charset="0"/>
+              <a:ea typeface="微软雅黑" charset="0"/>
+              <a:cs typeface="微软雅黑" charset="0"/>
+            </a:endParaRPr>
+          </a:p>
+        </p:txBody>
+      </p:sp>
+      <p:sp>
+        <p:nvSpPr>
+          <p:cNvPr id="43" name="文本框 42"/>
+          <p:cNvSpPr txBox="1"/>
+          <p:nvPr>
+            <p:custDataLst>
+              <p:tags r:id="rId43"/>
+            </p:custDataLst>
+          </p:nvPr>
+        </p:nvSpPr>
+        <p:spPr>
+          <a:xfrm>
+            <a:off x="4463415" y="4080510"/>
+            <a:ext cx="5005070" cy="878205"/>
+          </a:xfrm>
+          <a:prstGeom prst="rect">
+            <a:avLst/>
+          </a:prstGeom>
+          <a:noFill/>
+        </p:spPr>
+        <p:txBody>
+          <a:bodyPr wrap="square" rtlCol="0">
+            <a:noAutofit/>
+          </a:bodyPr>
+          <a:p>
+            <a:pPr algn="ctr"/>
+            <a:r>
+              <a:rPr lang="zh-CN" altLang="en-US" sz="1400" b="1">
+                <a:solidFill>
+                  <a:srgbClr val="C00000"/>
+                </a:solidFill>
+                <a:latin typeface="微软雅黑" charset="0"/>
+                <a:ea typeface="微软雅黑" charset="0"/>
+                <a:cs typeface="微软雅黑" charset="0"/>
+              </a:rPr>
+              <a:t>离散化梯度不可微分</a:t>
+            </a:r>
+            <a:br>
+              <a:rPr lang="zh-CN" altLang="en-US" sz="1400" b="1">
+                <a:solidFill>
+                  <a:srgbClr val="C00000"/>
+                </a:solidFill>
+                <a:latin typeface="微软雅黑" charset="0"/>
+                <a:ea typeface="微软雅黑" charset="0"/>
+                <a:cs typeface="微软雅黑" charset="0"/>
+              </a:rPr>
+            </a:br>
+            <a:r>
+              <a:rPr lang="zh-CN" altLang="en-US" sz="1400" b="1">
+                <a:solidFill>
+                  <a:srgbClr val="C00000"/>
+                </a:solidFill>
+                <a:latin typeface="微软雅黑" charset="0"/>
+                <a:ea typeface="微软雅黑" charset="0"/>
+                <a:cs typeface="微软雅黑" charset="0"/>
+              </a:rPr>
+              <a:t>直接使用编码器</a:t>
+            </a:r>
+            <a:r>
+              <a:rPr lang="en-US" altLang="zh-CN" sz="1400" b="1">
+                <a:solidFill>
+                  <a:srgbClr val="C00000"/>
+                </a:solidFill>
+                <a:latin typeface="微软雅黑" charset="0"/>
+                <a:ea typeface="微软雅黑" charset="0"/>
+                <a:cs typeface="微软雅黑" charset="0"/>
+              </a:rPr>
+              <a:t>(</a:t>
+            </a:r>
+            <a:r>
+              <a:rPr lang="zh-CN" altLang="en-US" sz="1400" b="1">
+                <a:solidFill>
+                  <a:srgbClr val="C00000"/>
+                </a:solidFill>
+                <a:latin typeface="微软雅黑" charset="0"/>
+                <a:ea typeface="微软雅黑" charset="0"/>
+                <a:cs typeface="微软雅黑" charset="0"/>
+              </a:rPr>
+              <a:t>还未离散化</a:t>
+            </a:r>
+            <a:r>
+              <a:rPr lang="en-US" altLang="zh-CN" sz="1400" b="1">
+                <a:solidFill>
+                  <a:srgbClr val="C00000"/>
+                </a:solidFill>
+                <a:latin typeface="微软雅黑" charset="0"/>
+                <a:ea typeface="微软雅黑" charset="0"/>
+                <a:cs typeface="微软雅黑" charset="0"/>
+              </a:rPr>
+              <a:t>)</a:t>
+            </a:r>
+            <a:r>
+              <a:rPr lang="zh-CN" altLang="en-US" sz="1400" b="1">
+                <a:solidFill>
+                  <a:srgbClr val="C00000"/>
+                </a:solidFill>
+                <a:latin typeface="微软雅黑" charset="0"/>
+                <a:ea typeface="微软雅黑" charset="0"/>
+                <a:cs typeface="微软雅黑" charset="0"/>
+              </a:rPr>
+              <a:t>的输出作为离散向量的</a:t>
+            </a:r>
+            <a:r>
+              <a:rPr lang="zh-CN" altLang="en-US" sz="1400" b="1">
+                <a:solidFill>
+                  <a:srgbClr val="C00000"/>
+                </a:solidFill>
+                <a:latin typeface="微软雅黑" charset="0"/>
+                <a:ea typeface="微软雅黑" charset="0"/>
+                <a:cs typeface="微软雅黑" charset="0"/>
+              </a:rPr>
+              <a:t>梯度</a:t>
+            </a:r>
+            <a:endParaRPr lang="zh-CN" altLang="en-US" sz="1400" b="1">
+              <a:solidFill>
+                <a:srgbClr val="C00000"/>
+              </a:solidFill>
+              <a:latin typeface="微软雅黑" charset="0"/>
+              <a:ea typeface="微软雅黑" charset="0"/>
+              <a:cs typeface="微软雅黑" charset="0"/>
+            </a:endParaRPr>
+          </a:p>
+        </p:txBody>
+      </p:sp>
+      <p:pic>
+        <p:nvPicPr>
+          <p:cNvPr id="44" name="图片 43"/>
+          <p:cNvPicPr>
+            <a:picLocks noChangeAspect="1"/>
+          </p:cNvPicPr>
+          <p:nvPr>
+            <p:custDataLst>
+              <p:tags r:id="rId44"/>
+            </p:custDataLst>
+          </p:nvPr>
+        </p:nvPicPr>
+        <p:blipFill>
+          <a:blip r:embed="rId45"/>
+          <a:stretch>
+            <a:fillRect/>
+          </a:stretch>
+        </p:blipFill>
+        <p:spPr>
+          <a:xfrm>
+            <a:off x="6014720" y="2042160"/>
+            <a:ext cx="5537200" cy="406400"/>
+          </a:xfrm>
+          <a:prstGeom prst="rect">
+            <a:avLst/>
+          </a:prstGeom>
+        </p:spPr>
+      </p:pic>
+      <p:sp>
+        <p:nvSpPr>
+          <p:cNvPr id="45" name="文本框 44"/>
+          <p:cNvSpPr txBox="1"/>
+          <p:nvPr>
+            <p:custDataLst>
+              <p:tags r:id="rId46"/>
+            </p:custDataLst>
+          </p:nvPr>
+        </p:nvSpPr>
+        <p:spPr>
+          <a:xfrm>
+            <a:off x="6096635" y="2428875"/>
+            <a:ext cx="1886585" cy="615315"/>
+          </a:xfrm>
+          <a:prstGeom prst="rect">
+            <a:avLst/>
+          </a:prstGeom>
+          <a:noFill/>
+        </p:spPr>
+        <p:txBody>
+          <a:bodyPr wrap="square" rtlCol="0">
+            <a:noAutofit/>
+          </a:bodyPr>
+          <a:p>
+            <a:pPr algn="ctr"/>
+            <a:r>
+              <a:rPr lang="zh-CN" altLang="en-US" sz="1400" b="1">
+                <a:latin typeface="微软雅黑" charset="0"/>
+                <a:ea typeface="微软雅黑" charset="0"/>
+                <a:cs typeface="微软雅黑" charset="0"/>
+              </a:rPr>
+              <a:t>重建损失</a:t>
+            </a:r>
+            <a:br>
+              <a:rPr lang="zh-CN" altLang="en-US" sz="1400" b="1">
+                <a:latin typeface="微软雅黑" charset="0"/>
+                <a:ea typeface="微软雅黑" charset="0"/>
+                <a:cs typeface="微软雅黑" charset="0"/>
+              </a:rPr>
+            </a:br>
+            <a:r>
+              <a:rPr lang="zh-CN" altLang="en-US" sz="1400" b="1">
+                <a:latin typeface="微软雅黑" charset="0"/>
+                <a:ea typeface="微软雅黑" charset="0"/>
+                <a:cs typeface="微软雅黑" charset="0"/>
+              </a:rPr>
+              <a:t>训练编码器和</a:t>
+            </a:r>
+            <a:r>
+              <a:rPr lang="zh-CN" altLang="en-US" sz="1400" b="1">
+                <a:latin typeface="微软雅黑" charset="0"/>
+                <a:ea typeface="微软雅黑" charset="0"/>
+                <a:cs typeface="微软雅黑" charset="0"/>
+              </a:rPr>
+              <a:t>解码器</a:t>
+            </a:r>
+            <a:endParaRPr lang="zh-CN" altLang="en-US" sz="1400" b="1">
+              <a:latin typeface="微软雅黑" charset="0"/>
+              <a:ea typeface="微软雅黑" charset="0"/>
+              <a:cs typeface="微软雅黑" charset="0"/>
+            </a:endParaRPr>
+          </a:p>
+        </p:txBody>
+      </p:sp>
+      <p:sp>
+        <p:nvSpPr>
+          <p:cNvPr id="46" name="文本框 45"/>
+          <p:cNvSpPr txBox="1"/>
+          <p:nvPr>
+            <p:custDataLst>
+              <p:tags r:id="rId47"/>
+            </p:custDataLst>
+          </p:nvPr>
+        </p:nvSpPr>
+        <p:spPr>
+          <a:xfrm>
+            <a:off x="7983220" y="2428875"/>
+            <a:ext cx="1559560" cy="615315"/>
+          </a:xfrm>
+          <a:prstGeom prst="rect">
+            <a:avLst/>
+          </a:prstGeom>
+          <a:noFill/>
+        </p:spPr>
+        <p:txBody>
+          <a:bodyPr wrap="square" rtlCol="0">
+            <a:noAutofit/>
+          </a:bodyPr>
+          <a:p>
+            <a:pPr algn="ctr"/>
+            <a:r>
+              <a:rPr lang="zh-CN" altLang="en-US" sz="1400" b="1">
+                <a:latin typeface="微软雅黑" charset="0"/>
+                <a:ea typeface="微软雅黑" charset="0"/>
+                <a:cs typeface="微软雅黑" charset="0"/>
+              </a:rPr>
+              <a:t>嵌入更新</a:t>
+            </a:r>
+            <a:br>
+              <a:rPr lang="zh-CN" altLang="en-US" sz="1400" b="1">
+                <a:latin typeface="微软雅黑" charset="0"/>
+                <a:ea typeface="微软雅黑" charset="0"/>
+                <a:cs typeface="微软雅黑" charset="0"/>
+              </a:rPr>
+            </a:br>
+            <a:r>
+              <a:rPr lang="zh-CN" altLang="en-US" sz="1400" b="1">
+                <a:latin typeface="微软雅黑" charset="0"/>
+                <a:ea typeface="微软雅黑" charset="0"/>
+                <a:cs typeface="微软雅黑" charset="0"/>
+              </a:rPr>
+              <a:t>把词典</a:t>
+            </a:r>
+            <a:r>
+              <a:rPr lang="zh-CN" altLang="en-US" sz="1400" b="1">
+                <a:latin typeface="微软雅黑" charset="0"/>
+                <a:ea typeface="微软雅黑" charset="0"/>
+                <a:cs typeface="微软雅黑" charset="0"/>
+              </a:rPr>
+              <a:t>向量向编码器</a:t>
+            </a:r>
+            <a:r>
+              <a:rPr lang="zh-CN" altLang="en-US" sz="1400" b="1">
+                <a:latin typeface="微软雅黑" charset="0"/>
+                <a:ea typeface="微软雅黑" charset="0"/>
+                <a:cs typeface="微软雅黑" charset="0"/>
+              </a:rPr>
+              <a:t>更新</a:t>
+            </a:r>
+            <a:endParaRPr lang="zh-CN" altLang="en-US" sz="1400" b="1">
+              <a:latin typeface="微软雅黑" charset="0"/>
+              <a:ea typeface="微软雅黑" charset="0"/>
+              <a:cs typeface="微软雅黑" charset="0"/>
+            </a:endParaRPr>
+          </a:p>
+        </p:txBody>
+      </p:sp>
+      <p:sp>
+        <p:nvSpPr>
+          <p:cNvPr id="47" name="文本框 46"/>
+          <p:cNvSpPr txBox="1"/>
+          <p:nvPr>
+            <p:custDataLst>
+              <p:tags r:id="rId48"/>
+            </p:custDataLst>
+          </p:nvPr>
+        </p:nvSpPr>
+        <p:spPr>
+          <a:xfrm>
+            <a:off x="9888220" y="2428875"/>
+            <a:ext cx="1559560" cy="615315"/>
+          </a:xfrm>
+          <a:prstGeom prst="rect">
+            <a:avLst/>
+          </a:prstGeom>
+          <a:noFill/>
+        </p:spPr>
+        <p:txBody>
+          <a:bodyPr wrap="square" rtlCol="0">
+            <a:noAutofit/>
+          </a:bodyPr>
+          <a:p>
+            <a:pPr algn="ctr"/>
+            <a:r>
+              <a:rPr lang="zh-CN" altLang="en-US" sz="1400" b="1">
+                <a:latin typeface="微软雅黑" charset="0"/>
+                <a:ea typeface="微软雅黑" charset="0"/>
+                <a:cs typeface="微软雅黑" charset="0"/>
+              </a:rPr>
+              <a:t>承诺项损失</a:t>
+            </a:r>
+            <a:br>
+              <a:rPr lang="zh-CN" altLang="en-US" sz="1400" b="1">
+                <a:latin typeface="微软雅黑" charset="0"/>
+                <a:ea typeface="微软雅黑" charset="0"/>
+                <a:cs typeface="微软雅黑" charset="0"/>
+              </a:rPr>
+            </a:br>
+            <a:r>
+              <a:rPr lang="zh-CN" altLang="en-US" sz="1400" b="1">
+                <a:latin typeface="微软雅黑" charset="0"/>
+                <a:ea typeface="微软雅黑" charset="0"/>
+                <a:cs typeface="微软雅黑" charset="0"/>
+              </a:rPr>
+              <a:t>鼓励编码器输出靠近词典</a:t>
+            </a:r>
+            <a:r>
+              <a:rPr lang="zh-CN" altLang="en-US" sz="1400" b="1">
+                <a:latin typeface="微软雅黑" charset="0"/>
+                <a:ea typeface="微软雅黑" charset="0"/>
+                <a:cs typeface="微软雅黑" charset="0"/>
+              </a:rPr>
+              <a:t>向量</a:t>
+            </a:r>
+            <a:endParaRPr lang="zh-CN" altLang="en-US" sz="1400" b="1">
+              <a:latin typeface="微软雅黑" charset="0"/>
+              <a:ea typeface="微软雅黑" charset="0"/>
+              <a:cs typeface="微软雅黑" charset="0"/>
+            </a:endParaRPr>
+          </a:p>
+        </p:txBody>
+      </p:sp>
+      <p:sp>
+        <p:nvSpPr>
+          <p:cNvPr id="48" name="文本框 47"/>
+          <p:cNvSpPr txBox="1"/>
+          <p:nvPr>
+            <p:custDataLst>
+              <p:tags r:id="rId49"/>
+            </p:custDataLst>
+          </p:nvPr>
+        </p:nvSpPr>
+        <p:spPr>
+          <a:xfrm>
+            <a:off x="6491605" y="3063875"/>
+            <a:ext cx="4257040" cy="774700"/>
+          </a:xfrm>
+          <a:prstGeom prst="rect">
+            <a:avLst/>
+          </a:prstGeom>
+          <a:noFill/>
+        </p:spPr>
+        <p:txBody>
+          <a:bodyPr wrap="square" rtlCol="0">
+            <a:noAutofit/>
+          </a:bodyPr>
+          <a:p>
+            <a:pPr algn="ctr"/>
+            <a:r>
+              <a:rPr lang="zh-CN" altLang="en-US" sz="1400" b="1">
+                <a:latin typeface="微软雅黑" charset="0"/>
+                <a:ea typeface="微软雅黑" charset="0"/>
+                <a:cs typeface="微软雅黑" charset="0"/>
+              </a:rPr>
+              <a:t>解码器</a:t>
+            </a:r>
+            <a:r>
+              <a:rPr lang="en-US" altLang="zh-CN" sz="1400" b="1">
+                <a:latin typeface="微软雅黑" charset="0"/>
+                <a:ea typeface="微软雅黑" charset="0"/>
+                <a:cs typeface="微软雅黑" charset="0"/>
+              </a:rPr>
+              <a:t>:</a:t>
+            </a:r>
+            <a:r>
+              <a:rPr lang="zh-CN" altLang="en-US" sz="1400" b="1">
+                <a:latin typeface="微软雅黑" charset="0"/>
+                <a:ea typeface="微软雅黑" charset="0"/>
+                <a:cs typeface="微软雅黑" charset="0"/>
+              </a:rPr>
+              <a:t>只接受第一项</a:t>
+            </a:r>
+            <a:r>
+              <a:rPr lang="zh-CN" altLang="en-US" sz="1400" b="1">
+                <a:latin typeface="微软雅黑" charset="0"/>
+                <a:ea typeface="微软雅黑" charset="0"/>
+                <a:cs typeface="微软雅黑" charset="0"/>
+              </a:rPr>
+              <a:t>优化</a:t>
+            </a:r>
+            <a:endParaRPr lang="zh-CN" altLang="en-US" sz="1400" b="1">
+              <a:latin typeface="微软雅黑" charset="0"/>
+              <a:ea typeface="微软雅黑" charset="0"/>
+              <a:cs typeface="微软雅黑" charset="0"/>
+            </a:endParaRPr>
+          </a:p>
+          <a:p>
+            <a:pPr algn="ctr"/>
+            <a:r>
+              <a:rPr lang="zh-CN" altLang="en-US" sz="1400" b="1">
+                <a:latin typeface="微软雅黑" charset="0"/>
+                <a:ea typeface="微软雅黑" charset="0"/>
+                <a:cs typeface="微软雅黑" charset="0"/>
+              </a:rPr>
+              <a:t>编码器</a:t>
+            </a:r>
+            <a:r>
+              <a:rPr lang="en-US" altLang="zh-CN" sz="1400" b="1">
+                <a:latin typeface="微软雅黑" charset="0"/>
+                <a:ea typeface="微软雅黑" charset="0"/>
+                <a:cs typeface="微软雅黑" charset="0"/>
+              </a:rPr>
+              <a:t>: </a:t>
+            </a:r>
+            <a:r>
+              <a:rPr lang="zh-CN" altLang="en-US" sz="1400" b="1">
+                <a:latin typeface="微软雅黑" charset="0"/>
+                <a:ea typeface="微软雅黑" charset="0"/>
+                <a:cs typeface="微软雅黑" charset="0"/>
+              </a:rPr>
+              <a:t>接受第一项</a:t>
+            </a:r>
+            <a:r>
+              <a:rPr lang="en-US" altLang="zh-CN" sz="1400" b="1">
+                <a:latin typeface="微软雅黑" charset="0"/>
+                <a:ea typeface="微软雅黑" charset="0"/>
+                <a:cs typeface="微软雅黑" charset="0"/>
+              </a:rPr>
+              <a:t>+</a:t>
+            </a:r>
+            <a:r>
+              <a:rPr lang="zh-CN" altLang="en-US" sz="1400" b="1">
+                <a:latin typeface="微软雅黑" charset="0"/>
+                <a:ea typeface="微软雅黑" charset="0"/>
+                <a:cs typeface="微软雅黑" charset="0"/>
+              </a:rPr>
+              <a:t>第三项优化</a:t>
+            </a:r>
+            <a:br>
+              <a:rPr lang="zh-CN" altLang="en-US" sz="1400" b="1">
+                <a:latin typeface="微软雅黑" charset="0"/>
+                <a:ea typeface="微软雅黑" charset="0"/>
+                <a:cs typeface="微软雅黑" charset="0"/>
+              </a:rPr>
+            </a:br>
+            <a:r>
+              <a:rPr lang="zh-CN" altLang="en-US" sz="1400" b="1">
+                <a:latin typeface="微软雅黑" charset="0"/>
+                <a:ea typeface="微软雅黑" charset="0"/>
+                <a:cs typeface="微软雅黑" charset="0"/>
+              </a:rPr>
+              <a:t>嵌入向量</a:t>
+            </a:r>
+            <a:r>
+              <a:rPr lang="en-US" altLang="zh-CN" sz="1400" b="1">
+                <a:latin typeface="微软雅黑" charset="0"/>
+                <a:ea typeface="微软雅黑" charset="0"/>
+                <a:cs typeface="微软雅黑" charset="0"/>
+              </a:rPr>
+              <a:t>: </a:t>
+            </a:r>
+            <a:r>
+              <a:rPr lang="zh-CN" altLang="en-US" sz="1400" b="1">
+                <a:latin typeface="微软雅黑" charset="0"/>
+                <a:ea typeface="微软雅黑" charset="0"/>
+                <a:cs typeface="微软雅黑" charset="0"/>
+              </a:rPr>
+              <a:t>只接受</a:t>
+            </a:r>
+            <a:r>
+              <a:rPr lang="zh-CN" altLang="en-US" sz="1400" b="1">
+                <a:latin typeface="微软雅黑" charset="0"/>
+                <a:ea typeface="微软雅黑" charset="0"/>
+                <a:cs typeface="微软雅黑" charset="0"/>
+              </a:rPr>
+              <a:t>第二项</a:t>
+            </a:r>
+            <a:endParaRPr lang="zh-CN" altLang="en-US" sz="1400" b="1">
+              <a:latin typeface="微软雅黑" charset="0"/>
+              <a:ea typeface="微软雅黑" charset="0"/>
+              <a:cs typeface="微软雅黑" charset="0"/>
+            </a:endParaRPr>
+          </a:p>
+          <a:p>
+            <a:pPr algn="ctr"/>
+            <a:r>
+              <a:rPr lang="zh-CN" altLang="en-US" sz="1400" b="1">
+                <a:latin typeface="微软雅黑" charset="0"/>
+                <a:ea typeface="微软雅黑" charset="0"/>
+                <a:cs typeface="微软雅黑" charset="0"/>
+              </a:rPr>
+              <a:t>𝛽</a:t>
+            </a:r>
+            <a:r>
+              <a:rPr lang="en-US" altLang="zh-CN" sz="1400" b="1">
+                <a:latin typeface="微软雅黑" charset="0"/>
+                <a:ea typeface="微软雅黑" charset="0"/>
+                <a:cs typeface="微软雅黑" charset="0"/>
+              </a:rPr>
+              <a:t> =0.25</a:t>
+            </a:r>
+            <a:endParaRPr lang="en-US" altLang="zh-CN" sz="1400" b="1">
+              <a:latin typeface="微软雅黑" charset="0"/>
+              <a:ea typeface="微软雅黑" charset="0"/>
+              <a:cs typeface="微软雅黑" charset="0"/>
+            </a:endParaRPr>
           </a:p>
         </p:txBody>
       </p:sp>
@@ -7103,6 +9983,64 @@
 </file>
 
 <file path=ppt/slides/slide7.xml><?xml version="1.0" encoding="utf-8"?>
+<p:sld xmlns:a="http://schemas.openxmlformats.org/drawingml/2006/main" xmlns:r="http://schemas.openxmlformats.org/officeDocument/2006/relationships" xmlns:p="http://schemas.openxmlformats.org/presentationml/2006/main">
+  <p:cSld>
+    <p:spTree>
+      <p:nvGrpSpPr>
+        <p:cNvPr id="1" name=""/>
+        <p:cNvGrpSpPr/>
+        <p:nvPr/>
+      </p:nvGrpSpPr>
+      <p:grpSpPr/>
+      <p:sp>
+        <p:nvSpPr>
+          <p:cNvPr id="2" name="标题 1"/>
+          <p:cNvSpPr>
+            <a:spLocks noGrp="1"/>
+          </p:cNvSpPr>
+          <p:nvPr>
+            <p:ph type="ctrTitle"/>
+          </p:nvPr>
+        </p:nvSpPr>
+        <p:spPr/>
+        <p:txBody>
+          <a:bodyPr/>
+          <a:p>
+            <a:r>
+              <a:rPr lang="en-US" altLang="zh-CN"/>
+              <a:t>GAN</a:t>
+            </a:r>
+            <a:endParaRPr lang="en-US" altLang="zh-CN"/>
+          </a:p>
+        </p:txBody>
+      </p:sp>
+      <p:sp>
+        <p:nvSpPr>
+          <p:cNvPr id="3" name="副标题 2"/>
+          <p:cNvSpPr>
+            <a:spLocks noGrp="1"/>
+          </p:cNvSpPr>
+          <p:nvPr>
+            <p:ph type="subTitle" idx="1"/>
+          </p:nvPr>
+        </p:nvSpPr>
+        <p:spPr/>
+        <p:txBody>
+          <a:bodyPr/>
+          <a:p>
+            <a:endParaRPr lang="zh-CN" altLang="en-US"/>
+          </a:p>
+        </p:txBody>
+      </p:sp>
+    </p:spTree>
+  </p:cSld>
+  <p:clrMapOvr>
+    <a:masterClrMapping/>
+  </p:clrMapOvr>
+</p:sld>
+</file>
+
+<file path=ppt/slides/slide8.xml><?xml version="1.0" encoding="utf-8"?>
 <p:sld xmlns:a="http://schemas.openxmlformats.org/drawingml/2006/main" xmlns:r="http://schemas.openxmlformats.org/officeDocument/2006/relationships" xmlns:p="http://schemas.openxmlformats.org/presentationml/2006/main">
   <p:cSld>
     <p:spTree>
@@ -7160,7 +10098,7 @@
         </p:blipFill>
         <p:spPr>
           <a:xfrm>
-            <a:off x="371475" y="2023745"/>
+            <a:off x="6762750" y="558800"/>
             <a:ext cx="5153660" cy="1688465"/>
           </a:xfrm>
           <a:prstGeom prst="rect">
@@ -7208,7 +10146,7 @@
         </p:nvSpPr>
         <p:spPr>
           <a:xfrm>
-            <a:off x="7799705" y="110490"/>
+            <a:off x="1451610" y="1574800"/>
             <a:ext cx="3443605" cy="575310"/>
           </a:xfrm>
           <a:prstGeom prst="rect">
@@ -7256,8 +10194,8 @@
         </p:nvSpPr>
         <p:spPr>
           <a:xfrm>
-            <a:off x="1804670" y="558800"/>
-            <a:ext cx="4434840" cy="878205"/>
+            <a:off x="635" y="558800"/>
+            <a:ext cx="6946265" cy="878205"/>
           </a:xfrm>
           <a:prstGeom prst="rect">
             <a:avLst/>
@@ -7432,7 +10370,7 @@
         </p:nvSpPr>
         <p:spPr>
           <a:xfrm>
-            <a:off x="534670" y="3860800"/>
+            <a:off x="6946900" y="2120265"/>
             <a:ext cx="4878070" cy="878205"/>
           </a:xfrm>
           <a:prstGeom prst="rect">
@@ -7571,7 +10509,23 @@
                 <a:ea typeface="微软雅黑" charset="0"/>
                 <a:cs typeface="微软雅黑" charset="0"/>
               </a:rPr>
-              <a:t>生成器优化，变得更靠近真实分布</a:t>
+              <a:t>生成器优化，变得更靠</a:t>
+            </a:r>
+            <a:r>
+              <a:rPr lang="en-US" altLang="zh-CN" sz="1400" b="1">
+                <a:latin typeface="微软雅黑" charset="0"/>
+                <a:ea typeface="微软雅黑" charset="0"/>
+                <a:cs typeface="微软雅黑" charset="0"/>
+              </a:rPr>
+              <a:t> </a:t>
+            </a:r>
+            <a:r>
+              <a:rPr lang="zh-CN" altLang="en-US" sz="1400" b="1">
+                <a:latin typeface="微软雅黑" charset="0"/>
+                <a:ea typeface="微软雅黑" charset="0"/>
+                <a:cs typeface="微软雅黑" charset="0"/>
+              </a:rPr>
+              <a:t>近真实分布</a:t>
             </a:r>
             <a:br>
               <a:rPr lang="zh-CN" altLang="en-US" sz="1400" b="1">
@@ -7624,7 +10578,7 @@
         </p:nvSpPr>
         <p:spPr>
           <a:xfrm>
-            <a:off x="407670" y="1574800"/>
+            <a:off x="7065645" y="0"/>
             <a:ext cx="5005070" cy="878205"/>
           </a:xfrm>
           <a:prstGeom prst="rect">
@@ -7791,6 +10745,302 @@
           </a:p>
         </p:txBody>
       </p:sp>
+      <p:sp>
+        <p:nvSpPr>
+          <p:cNvPr id="13" name="文本框 12"/>
+          <p:cNvSpPr txBox="1"/>
+          <p:nvPr>
+            <p:custDataLst>
+              <p:tags r:id="rId11"/>
+            </p:custDataLst>
+          </p:nvPr>
+        </p:nvSpPr>
+        <p:spPr>
+          <a:xfrm>
+            <a:off x="1993900" y="3977640"/>
+            <a:ext cx="4878070" cy="334010"/>
+          </a:xfrm>
+          <a:prstGeom prst="rect">
+            <a:avLst/>
+          </a:prstGeom>
+          <a:noFill/>
+        </p:spPr>
+        <p:txBody>
+          <a:bodyPr wrap="square" rtlCol="0">
+            <a:noAutofit/>
+          </a:bodyPr>
+          <a:p>
+            <a:pPr algn="ctr"/>
+            <a:r>
+              <a:rPr lang="zh-CN" altLang="en-US" sz="1400" b="1">
+                <a:latin typeface="微软雅黑" charset="0"/>
+                <a:ea typeface="微软雅黑" charset="0"/>
+                <a:cs typeface="微软雅黑" charset="0"/>
+              </a:rPr>
+              <a:t>真实样本</a:t>
+            </a:r>
+            <a:r>
+              <a:rPr lang="en-US" altLang="zh-CN" sz="1400" b="1">
+                <a:latin typeface="微软雅黑" charset="0"/>
+                <a:ea typeface="微软雅黑" charset="0"/>
+                <a:cs typeface="微软雅黑" charset="0"/>
+              </a:rPr>
+              <a:t>x</a:t>
+            </a:r>
+            <a:r>
+              <a:rPr lang="zh-CN" altLang="en-US" sz="1400" b="1">
+                <a:latin typeface="微软雅黑" charset="0"/>
+                <a:ea typeface="微软雅黑" charset="0"/>
+                <a:cs typeface="微软雅黑" charset="0"/>
+              </a:rPr>
+              <a:t>和噪声样本</a:t>
+            </a:r>
+            <a:r>
+              <a:rPr lang="en-US" altLang="zh-CN" sz="1400" b="1">
+                <a:latin typeface="微软雅黑" charset="0"/>
+                <a:ea typeface="微软雅黑" charset="0"/>
+                <a:cs typeface="微软雅黑" charset="0"/>
+              </a:rPr>
+              <a:t>z</a:t>
+            </a:r>
+            <a:r>
+              <a:rPr lang="zh-CN" altLang="en-US" sz="1400" b="1">
+                <a:latin typeface="微软雅黑" charset="0"/>
+                <a:ea typeface="微软雅黑" charset="0"/>
+                <a:cs typeface="微软雅黑" charset="0"/>
+              </a:rPr>
+              <a:t>都采样</a:t>
+            </a:r>
+            <a:r>
+              <a:rPr lang="en-US" altLang="zh-CN" sz="1400" b="1">
+                <a:latin typeface="微软雅黑" charset="0"/>
+                <a:ea typeface="微软雅黑" charset="0"/>
+                <a:cs typeface="微软雅黑" charset="0"/>
+              </a:rPr>
+              <a:t>m</a:t>
+            </a:r>
+            <a:r>
+              <a:rPr lang="zh-CN" altLang="en-US" sz="1400" b="1">
+                <a:latin typeface="微软雅黑" charset="0"/>
+                <a:ea typeface="微软雅黑" charset="0"/>
+                <a:cs typeface="微软雅黑" charset="0"/>
+              </a:rPr>
+              <a:t>个</a:t>
+            </a:r>
+            <a:endParaRPr lang="zh-CN" altLang="en-US" sz="1400" b="1">
+              <a:latin typeface="微软雅黑" charset="0"/>
+              <a:ea typeface="微软雅黑" charset="0"/>
+              <a:cs typeface="微软雅黑" charset="0"/>
+            </a:endParaRPr>
+          </a:p>
+        </p:txBody>
+      </p:sp>
+      <p:sp>
+        <p:nvSpPr>
+          <p:cNvPr id="14" name="文本框 13"/>
+          <p:cNvSpPr txBox="1"/>
+          <p:nvPr>
+            <p:custDataLst>
+              <p:tags r:id="rId12"/>
+            </p:custDataLst>
+          </p:nvPr>
+        </p:nvSpPr>
+        <p:spPr>
+          <a:xfrm>
+            <a:off x="1993900" y="4739640"/>
+            <a:ext cx="4878070" cy="334010"/>
+          </a:xfrm>
+          <a:prstGeom prst="rect">
+            <a:avLst/>
+          </a:prstGeom>
+          <a:noFill/>
+        </p:spPr>
+        <p:txBody>
+          <a:bodyPr wrap="square" rtlCol="0">
+            <a:noAutofit/>
+          </a:bodyPr>
+          <a:p>
+            <a:pPr algn="ctr"/>
+            <a:r>
+              <a:rPr lang="zh-CN" altLang="en-US" sz="1400" b="1">
+                <a:latin typeface="微软雅黑" charset="0"/>
+                <a:ea typeface="微软雅黑" charset="0"/>
+                <a:cs typeface="微软雅黑" charset="0"/>
+              </a:rPr>
+              <a:t>第一步</a:t>
+            </a:r>
+            <a:r>
+              <a:rPr lang="en-US" altLang="zh-CN" sz="1400" b="1">
+                <a:latin typeface="微软雅黑" charset="0"/>
+                <a:ea typeface="微软雅黑" charset="0"/>
+                <a:cs typeface="微软雅黑" charset="0"/>
+              </a:rPr>
+              <a:t> </a:t>
+            </a:r>
+            <a:r>
+              <a:rPr lang="zh-CN" altLang="en-US" sz="1400" b="1">
+                <a:latin typeface="微软雅黑" charset="0"/>
+                <a:ea typeface="微软雅黑" charset="0"/>
+                <a:cs typeface="微软雅黑" charset="0"/>
+              </a:rPr>
+              <a:t>对辨别器求梯度，进行</a:t>
+            </a:r>
+            <a:r>
+              <a:rPr lang="en-US" altLang="zh-CN" sz="1400" b="1">
+                <a:latin typeface="微软雅黑" charset="0"/>
+                <a:ea typeface="微软雅黑" charset="0"/>
+                <a:cs typeface="微软雅黑" charset="0"/>
+              </a:rPr>
+              <a:t>K</a:t>
+            </a:r>
+            <a:r>
+              <a:rPr lang="zh-CN" altLang="en-US" sz="1400" b="1">
+                <a:latin typeface="微软雅黑" charset="0"/>
+                <a:ea typeface="微软雅黑" charset="0"/>
+                <a:cs typeface="微软雅黑" charset="0"/>
+              </a:rPr>
+              <a:t>次</a:t>
+            </a:r>
+            <a:endParaRPr lang="zh-CN" altLang="en-US" sz="1400" b="1">
+              <a:latin typeface="微软雅黑" charset="0"/>
+              <a:ea typeface="微软雅黑" charset="0"/>
+              <a:cs typeface="微软雅黑" charset="0"/>
+            </a:endParaRPr>
+          </a:p>
+        </p:txBody>
+      </p:sp>
+      <p:sp>
+        <p:nvSpPr>
+          <p:cNvPr id="15" name="文本框 14"/>
+          <p:cNvSpPr txBox="1"/>
+          <p:nvPr>
+            <p:custDataLst>
+              <p:tags r:id="rId13"/>
+            </p:custDataLst>
+          </p:nvPr>
+        </p:nvSpPr>
+        <p:spPr>
+          <a:xfrm>
+            <a:off x="1993900" y="5755640"/>
+            <a:ext cx="4878070" cy="334010"/>
+          </a:xfrm>
+          <a:prstGeom prst="rect">
+            <a:avLst/>
+          </a:prstGeom>
+          <a:noFill/>
+        </p:spPr>
+        <p:txBody>
+          <a:bodyPr wrap="square" rtlCol="0">
+            <a:noAutofit/>
+          </a:bodyPr>
+          <a:p>
+            <a:pPr algn="ctr"/>
+            <a:r>
+              <a:rPr lang="zh-CN" altLang="en-US" sz="1400" b="1">
+                <a:latin typeface="微软雅黑" charset="0"/>
+                <a:ea typeface="微软雅黑" charset="0"/>
+                <a:cs typeface="微软雅黑" charset="0"/>
+              </a:rPr>
+              <a:t>第二步</a:t>
+            </a:r>
+            <a:r>
+              <a:rPr lang="en-US" altLang="zh-CN" sz="1400" b="1">
+                <a:latin typeface="微软雅黑" charset="0"/>
+                <a:ea typeface="微软雅黑" charset="0"/>
+                <a:cs typeface="微软雅黑" charset="0"/>
+              </a:rPr>
+              <a:t> </a:t>
+            </a:r>
+            <a:r>
+              <a:rPr lang="zh-CN" altLang="en-US" sz="1400" b="1">
+                <a:latin typeface="微软雅黑" charset="0"/>
+                <a:ea typeface="微软雅黑" charset="0"/>
+                <a:cs typeface="微软雅黑" charset="0"/>
+              </a:rPr>
+              <a:t>对生成器求梯度，仅更新</a:t>
+            </a:r>
+            <a:r>
+              <a:rPr lang="zh-CN" altLang="en-US" sz="1400" b="1">
+                <a:latin typeface="微软雅黑" charset="0"/>
+                <a:ea typeface="微软雅黑" charset="0"/>
+                <a:cs typeface="微软雅黑" charset="0"/>
+              </a:rPr>
+              <a:t>第二部分，进行</a:t>
+            </a:r>
+            <a:r>
+              <a:rPr lang="en-US" altLang="zh-CN" sz="1400" b="1">
+                <a:latin typeface="微软雅黑" charset="0"/>
+                <a:ea typeface="微软雅黑" charset="0"/>
+                <a:cs typeface="微软雅黑" charset="0"/>
+              </a:rPr>
+              <a:t>K</a:t>
+            </a:r>
+            <a:r>
+              <a:rPr lang="zh-CN" altLang="en-US" sz="1400" b="1">
+                <a:latin typeface="微软雅黑" charset="0"/>
+                <a:ea typeface="微软雅黑" charset="0"/>
+                <a:cs typeface="微软雅黑" charset="0"/>
+              </a:rPr>
+              <a:t>次</a:t>
+            </a:r>
+            <a:endParaRPr lang="zh-CN" altLang="en-US" sz="1400" b="1">
+              <a:latin typeface="微软雅黑" charset="0"/>
+              <a:ea typeface="微软雅黑" charset="0"/>
+              <a:cs typeface="微软雅黑" charset="0"/>
+            </a:endParaRPr>
+          </a:p>
+        </p:txBody>
+      </p:sp>
+      <p:sp>
+        <p:nvSpPr>
+          <p:cNvPr id="16" name="文本框 15"/>
+          <p:cNvSpPr txBox="1"/>
+          <p:nvPr>
+            <p:custDataLst>
+              <p:tags r:id="rId14"/>
+            </p:custDataLst>
+          </p:nvPr>
+        </p:nvSpPr>
+        <p:spPr>
+          <a:xfrm>
+            <a:off x="1993900" y="6263640"/>
+            <a:ext cx="4878070" cy="334010"/>
+          </a:xfrm>
+          <a:prstGeom prst="rect">
+            <a:avLst/>
+          </a:prstGeom>
+          <a:noFill/>
+        </p:spPr>
+        <p:txBody>
+          <a:bodyPr wrap="square" rtlCol="0">
+            <a:noAutofit/>
+          </a:bodyPr>
+          <a:p>
+            <a:pPr algn="ctr"/>
+            <a:r>
+              <a:rPr lang="zh-CN" altLang="en-US" sz="1400" b="1">
+                <a:latin typeface="微软雅黑" charset="0"/>
+                <a:ea typeface="微软雅黑" charset="0"/>
+                <a:cs typeface="微软雅黑" charset="0"/>
+              </a:rPr>
+              <a:t>总的循环进行</a:t>
+            </a:r>
+            <a:r>
+              <a:rPr lang="zh-CN" altLang="en-US" sz="1400" b="1">
+                <a:latin typeface="微软雅黑" charset="0"/>
+                <a:ea typeface="微软雅黑" charset="0"/>
+                <a:cs typeface="微软雅黑" charset="0"/>
+              </a:rPr>
+              <a:t>多次</a:t>
+            </a:r>
+            <a:endParaRPr lang="zh-CN" altLang="en-US" sz="1400" b="1">
+              <a:latin typeface="微软雅黑" charset="0"/>
+              <a:ea typeface="微软雅黑" charset="0"/>
+              <a:cs typeface="微软雅黑" charset="0"/>
+            </a:endParaRPr>
+          </a:p>
+        </p:txBody>
+      </p:sp>
     </p:spTree>
   </p:cSld>
   <p:clrMapOvr>
@@ -7811,6 +11061,18 @@
 </p:tagLst>
 </file>
 
+<file path=ppt/tags/tag100.xml><?xml version="1.0" encoding="utf-8"?>
+<p:tagLst xmlns:p="http://schemas.openxmlformats.org/presentationml/2006/main">
+  <p:tag name="KSO_WM_BEAUTIFY_FLAG" val=""/>
+</p:tagLst>
+</file>
+
+<file path=ppt/tags/tag101.xml><?xml version="1.0" encoding="utf-8"?>
+<p:tagLst xmlns:p="http://schemas.openxmlformats.org/presentationml/2006/main">
+  <p:tag name="KSO_WM_BEAUTIFY_FLAG" val=""/>
+</p:tagLst>
+</file>
+
 <file path=ppt/tags/tag11.xml><?xml version="1.0" encoding="utf-8"?>
 <p:tagLst xmlns:p="http://schemas.openxmlformats.org/presentationml/2006/main">
   <p:tag name="KSO_WM_BEAUTIFY_FLAG" val=""/>
@@ -8075,25 +11337,319 @@
 </p:tagLst>
 </file>
 
+<file path=ppt/tags/tag51.xml><?xml version="1.0" encoding="utf-8"?>
+<p:tagLst xmlns:p="http://schemas.openxmlformats.org/presentationml/2006/main">
+  <p:tag name="KSO_WM_BEAUTIFY_FLAG" val=""/>
+</p:tagLst>
+</file>
+
+<file path=ppt/tags/tag52.xml><?xml version="1.0" encoding="utf-8"?>
+<p:tagLst xmlns:p="http://schemas.openxmlformats.org/presentationml/2006/main">
+  <p:tag name="KSO_WM_BEAUTIFY_FLAG" val=""/>
+</p:tagLst>
+</file>
+
+<file path=ppt/tags/tag53.xml><?xml version="1.0" encoding="utf-8"?>
+<p:tagLst xmlns:p="http://schemas.openxmlformats.org/presentationml/2006/main">
+  <p:tag name="KSO_WM_BEAUTIFY_FLAG" val=""/>
+</p:tagLst>
+</file>
+
+<file path=ppt/tags/tag54.xml><?xml version="1.0" encoding="utf-8"?>
+<p:tagLst xmlns:p="http://schemas.openxmlformats.org/presentationml/2006/main">
+  <p:tag name="KSO_WM_BEAUTIFY_FLAG" val=""/>
+</p:tagLst>
+</file>
+
+<file path=ppt/tags/tag55.xml><?xml version="1.0" encoding="utf-8"?>
+<p:tagLst xmlns:p="http://schemas.openxmlformats.org/presentationml/2006/main">
+  <p:tag name="KSO_WM_BEAUTIFY_FLAG" val=""/>
+</p:tagLst>
+</file>
+
+<file path=ppt/tags/tag56.xml><?xml version="1.0" encoding="utf-8"?>
+<p:tagLst xmlns:p="http://schemas.openxmlformats.org/presentationml/2006/main">
+  <p:tag name="KSO_WM_BEAUTIFY_FLAG" val=""/>
+</p:tagLst>
+</file>
+
+<file path=ppt/tags/tag57.xml><?xml version="1.0" encoding="utf-8"?>
+<p:tagLst xmlns:p="http://schemas.openxmlformats.org/presentationml/2006/main">
+  <p:tag name="KSO_WM_BEAUTIFY_FLAG" val=""/>
+</p:tagLst>
+</file>
+
+<file path=ppt/tags/tag58.xml><?xml version="1.0" encoding="utf-8"?>
+<p:tagLst xmlns:p="http://schemas.openxmlformats.org/presentationml/2006/main">
+  <p:tag name="KSO_WM_BEAUTIFY_FLAG" val=""/>
+</p:tagLst>
+</file>
+
+<file path=ppt/tags/tag59.xml><?xml version="1.0" encoding="utf-8"?>
+<p:tagLst xmlns:p="http://schemas.openxmlformats.org/presentationml/2006/main">
+  <p:tag name="KSO_WM_BEAUTIFY_FLAG" val=""/>
+</p:tagLst>
+</file>
+
 <file path=ppt/tags/tag6.xml><?xml version="1.0" encoding="utf-8"?>
 <p:tagLst xmlns:p="http://schemas.openxmlformats.org/presentationml/2006/main">
   <p:tag name="KSO_WM_BEAUTIFY_FLAG" val=""/>
 </p:tagLst>
 </file>
 
+<file path=ppt/tags/tag60.xml><?xml version="1.0" encoding="utf-8"?>
+<p:tagLst xmlns:p="http://schemas.openxmlformats.org/presentationml/2006/main">
+  <p:tag name="KSO_WM_BEAUTIFY_FLAG" val=""/>
+</p:tagLst>
+</file>
+
+<file path=ppt/tags/tag61.xml><?xml version="1.0" encoding="utf-8"?>
+<p:tagLst xmlns:p="http://schemas.openxmlformats.org/presentationml/2006/main">
+  <p:tag name="KSO_WM_BEAUTIFY_FLAG" val=""/>
+</p:tagLst>
+</file>
+
+<file path=ppt/tags/tag62.xml><?xml version="1.0" encoding="utf-8"?>
+<p:tagLst xmlns:p="http://schemas.openxmlformats.org/presentationml/2006/main">
+  <p:tag name="KSO_WM_BEAUTIFY_FLAG" val=""/>
+</p:tagLst>
+</file>
+
+<file path=ppt/tags/tag63.xml><?xml version="1.0" encoding="utf-8"?>
+<p:tagLst xmlns:p="http://schemas.openxmlformats.org/presentationml/2006/main">
+  <p:tag name="KSO_WM_BEAUTIFY_FLAG" val=""/>
+</p:tagLst>
+</file>
+
+<file path=ppt/tags/tag64.xml><?xml version="1.0" encoding="utf-8"?>
+<p:tagLst xmlns:p="http://schemas.openxmlformats.org/presentationml/2006/main">
+  <p:tag name="KSO_WM_BEAUTIFY_FLAG" val=""/>
+</p:tagLst>
+</file>
+
+<file path=ppt/tags/tag65.xml><?xml version="1.0" encoding="utf-8"?>
+<p:tagLst xmlns:p="http://schemas.openxmlformats.org/presentationml/2006/main">
+  <p:tag name="KSO_WM_BEAUTIFY_FLAG" val=""/>
+</p:tagLst>
+</file>
+
+<file path=ppt/tags/tag66.xml><?xml version="1.0" encoding="utf-8"?>
+<p:tagLst xmlns:p="http://schemas.openxmlformats.org/presentationml/2006/main">
+  <p:tag name="KSO_WM_BEAUTIFY_FLAG" val=""/>
+</p:tagLst>
+</file>
+
+<file path=ppt/tags/tag67.xml><?xml version="1.0" encoding="utf-8"?>
+<p:tagLst xmlns:p="http://schemas.openxmlformats.org/presentationml/2006/main">
+  <p:tag name="KSO_WM_BEAUTIFY_FLAG" val=""/>
+</p:tagLst>
+</file>
+
+<file path=ppt/tags/tag68.xml><?xml version="1.0" encoding="utf-8"?>
+<p:tagLst xmlns:p="http://schemas.openxmlformats.org/presentationml/2006/main">
+  <p:tag name="KSO_WM_BEAUTIFY_FLAG" val=""/>
+</p:tagLst>
+</file>
+
+<file path=ppt/tags/tag69.xml><?xml version="1.0" encoding="utf-8"?>
+<p:tagLst xmlns:p="http://schemas.openxmlformats.org/presentationml/2006/main">
+  <p:tag name="KSO_WM_BEAUTIFY_FLAG" val=""/>
+</p:tagLst>
+</file>
+
 <file path=ppt/tags/tag7.xml><?xml version="1.0" encoding="utf-8"?>
 <p:tagLst xmlns:p="http://schemas.openxmlformats.org/presentationml/2006/main">
   <p:tag name="KSO_WM_BEAUTIFY_FLAG" val=""/>
 </p:tagLst>
 </file>
 
+<file path=ppt/tags/tag70.xml><?xml version="1.0" encoding="utf-8"?>
+<p:tagLst xmlns:p="http://schemas.openxmlformats.org/presentationml/2006/main">
+  <p:tag name="KSO_WM_BEAUTIFY_FLAG" val=""/>
+</p:tagLst>
+</file>
+
+<file path=ppt/tags/tag71.xml><?xml version="1.0" encoding="utf-8"?>
+<p:tagLst xmlns:p="http://schemas.openxmlformats.org/presentationml/2006/main">
+  <p:tag name="KSO_WM_BEAUTIFY_FLAG" val=""/>
+</p:tagLst>
+</file>
+
+<file path=ppt/tags/tag72.xml><?xml version="1.0" encoding="utf-8"?>
+<p:tagLst xmlns:p="http://schemas.openxmlformats.org/presentationml/2006/main">
+  <p:tag name="KSO_WM_BEAUTIFY_FLAG" val=""/>
+</p:tagLst>
+</file>
+
+<file path=ppt/tags/tag73.xml><?xml version="1.0" encoding="utf-8"?>
+<p:tagLst xmlns:p="http://schemas.openxmlformats.org/presentationml/2006/main">
+  <p:tag name="KSO_WM_BEAUTIFY_FLAG" val=""/>
+</p:tagLst>
+</file>
+
+<file path=ppt/tags/tag74.xml><?xml version="1.0" encoding="utf-8"?>
+<p:tagLst xmlns:p="http://schemas.openxmlformats.org/presentationml/2006/main">
+  <p:tag name="KSO_WM_BEAUTIFY_FLAG" val=""/>
+</p:tagLst>
+</file>
+
+<file path=ppt/tags/tag75.xml><?xml version="1.0" encoding="utf-8"?>
+<p:tagLst xmlns:p="http://schemas.openxmlformats.org/presentationml/2006/main">
+  <p:tag name="KSO_WM_BEAUTIFY_FLAG" val=""/>
+</p:tagLst>
+</file>
+
+<file path=ppt/tags/tag76.xml><?xml version="1.0" encoding="utf-8"?>
+<p:tagLst xmlns:p="http://schemas.openxmlformats.org/presentationml/2006/main">
+  <p:tag name="KSO_WM_BEAUTIFY_FLAG" val=""/>
+</p:tagLst>
+</file>
+
+<file path=ppt/tags/tag77.xml><?xml version="1.0" encoding="utf-8"?>
+<p:tagLst xmlns:p="http://schemas.openxmlformats.org/presentationml/2006/main">
+  <p:tag name="KSO_WM_BEAUTIFY_FLAG" val=""/>
+</p:tagLst>
+</file>
+
+<file path=ppt/tags/tag78.xml><?xml version="1.0" encoding="utf-8"?>
+<p:tagLst xmlns:p="http://schemas.openxmlformats.org/presentationml/2006/main">
+  <p:tag name="KSO_WM_BEAUTIFY_FLAG" val=""/>
+</p:tagLst>
+</file>
+
+<file path=ppt/tags/tag79.xml><?xml version="1.0" encoding="utf-8"?>
+<p:tagLst xmlns:p="http://schemas.openxmlformats.org/presentationml/2006/main">
+  <p:tag name="KSO_WM_BEAUTIFY_FLAG" val=""/>
+</p:tagLst>
+</file>
+
 <file path=ppt/tags/tag8.xml><?xml version="1.0" encoding="utf-8"?>
 <p:tagLst xmlns:p="http://schemas.openxmlformats.org/presentationml/2006/main">
   <p:tag name="KSO_WM_BEAUTIFY_FLAG" val=""/>
 </p:tagLst>
 </file>
 
+<file path=ppt/tags/tag80.xml><?xml version="1.0" encoding="utf-8"?>
+<p:tagLst xmlns:p="http://schemas.openxmlformats.org/presentationml/2006/main">
+  <p:tag name="KSO_WM_BEAUTIFY_FLAG" val=""/>
+</p:tagLst>
+</file>
+
+<file path=ppt/tags/tag81.xml><?xml version="1.0" encoding="utf-8"?>
+<p:tagLst xmlns:p="http://schemas.openxmlformats.org/presentationml/2006/main">
+  <p:tag name="KSO_WM_BEAUTIFY_FLAG" val=""/>
+</p:tagLst>
+</file>
+
+<file path=ppt/tags/tag82.xml><?xml version="1.0" encoding="utf-8"?>
+<p:tagLst xmlns:p="http://schemas.openxmlformats.org/presentationml/2006/main">
+  <p:tag name="KSO_WM_BEAUTIFY_FLAG" val=""/>
+</p:tagLst>
+</file>
+
+<file path=ppt/tags/tag83.xml><?xml version="1.0" encoding="utf-8"?>
+<p:tagLst xmlns:p="http://schemas.openxmlformats.org/presentationml/2006/main">
+  <p:tag name="KSO_WM_BEAUTIFY_FLAG" val=""/>
+</p:tagLst>
+</file>
+
+<file path=ppt/tags/tag84.xml><?xml version="1.0" encoding="utf-8"?>
+<p:tagLst xmlns:p="http://schemas.openxmlformats.org/presentationml/2006/main">
+  <p:tag name="KSO_WM_BEAUTIFY_FLAG" val=""/>
+</p:tagLst>
+</file>
+
+<file path=ppt/tags/tag85.xml><?xml version="1.0" encoding="utf-8"?>
+<p:tagLst xmlns:p="http://schemas.openxmlformats.org/presentationml/2006/main">
+  <p:tag name="KSO_WM_BEAUTIFY_FLAG" val=""/>
+</p:tagLst>
+</file>
+
+<file path=ppt/tags/tag86.xml><?xml version="1.0" encoding="utf-8"?>
+<p:tagLst xmlns:p="http://schemas.openxmlformats.org/presentationml/2006/main">
+  <p:tag name="KSO_WM_BEAUTIFY_FLAG" val=""/>
+</p:tagLst>
+</file>
+
+<file path=ppt/tags/tag87.xml><?xml version="1.0" encoding="utf-8"?>
+<p:tagLst xmlns:p="http://schemas.openxmlformats.org/presentationml/2006/main">
+  <p:tag name="KSO_WM_BEAUTIFY_FLAG" val=""/>
+</p:tagLst>
+</file>
+
+<file path=ppt/tags/tag88.xml><?xml version="1.0" encoding="utf-8"?>
+<p:tagLst xmlns:p="http://schemas.openxmlformats.org/presentationml/2006/main">
+  <p:tag name="KSO_WM_BEAUTIFY_FLAG" val=""/>
+</p:tagLst>
+</file>
+
+<file path=ppt/tags/tag89.xml><?xml version="1.0" encoding="utf-8"?>
+<p:tagLst xmlns:p="http://schemas.openxmlformats.org/presentationml/2006/main">
+  <p:tag name="KSO_WM_BEAUTIFY_FLAG" val=""/>
+</p:tagLst>
+</file>
+
 <file path=ppt/tags/tag9.xml><?xml version="1.0" encoding="utf-8"?>
+<p:tagLst xmlns:p="http://schemas.openxmlformats.org/presentationml/2006/main">
+  <p:tag name="KSO_WM_BEAUTIFY_FLAG" val=""/>
+</p:tagLst>
+</file>
+
+<file path=ppt/tags/tag90.xml><?xml version="1.0" encoding="utf-8"?>
+<p:tagLst xmlns:p="http://schemas.openxmlformats.org/presentationml/2006/main">
+  <p:tag name="KSO_WM_BEAUTIFY_FLAG" val=""/>
+</p:tagLst>
+</file>
+
+<file path=ppt/tags/tag91.xml><?xml version="1.0" encoding="utf-8"?>
+<p:tagLst xmlns:p="http://schemas.openxmlformats.org/presentationml/2006/main">
+  <p:tag name="KSO_WM_BEAUTIFY_FLAG" val=""/>
+</p:tagLst>
+</file>
+
+<file path=ppt/tags/tag92.xml><?xml version="1.0" encoding="utf-8"?>
+<p:tagLst xmlns:p="http://schemas.openxmlformats.org/presentationml/2006/main">
+  <p:tag name="KSO_WM_BEAUTIFY_FLAG" val=""/>
+</p:tagLst>
+</file>
+
+<file path=ppt/tags/tag93.xml><?xml version="1.0" encoding="utf-8"?>
+<p:tagLst xmlns:p="http://schemas.openxmlformats.org/presentationml/2006/main">
+  <p:tag name="KSO_WM_BEAUTIFY_FLAG" val=""/>
+</p:tagLst>
+</file>
+
+<file path=ppt/tags/tag94.xml><?xml version="1.0" encoding="utf-8"?>
+<p:tagLst xmlns:p="http://schemas.openxmlformats.org/presentationml/2006/main">
+  <p:tag name="KSO_WM_BEAUTIFY_FLAG" val=""/>
+</p:tagLst>
+</file>
+
+<file path=ppt/tags/tag95.xml><?xml version="1.0" encoding="utf-8"?>
+<p:tagLst xmlns:p="http://schemas.openxmlformats.org/presentationml/2006/main">
+  <p:tag name="KSO_WM_BEAUTIFY_FLAG" val=""/>
+</p:tagLst>
+</file>
+
+<file path=ppt/tags/tag96.xml><?xml version="1.0" encoding="utf-8"?>
+<p:tagLst xmlns:p="http://schemas.openxmlformats.org/presentationml/2006/main">
+  <p:tag name="KSO_WM_BEAUTIFY_FLAG" val=""/>
+</p:tagLst>
+</file>
+
+<file path=ppt/tags/tag97.xml><?xml version="1.0" encoding="utf-8"?>
+<p:tagLst xmlns:p="http://schemas.openxmlformats.org/presentationml/2006/main">
+  <p:tag name="KSO_WM_BEAUTIFY_FLAG" val=""/>
+</p:tagLst>
+</file>
+
+<file path=ppt/tags/tag98.xml><?xml version="1.0" encoding="utf-8"?>
+<p:tagLst xmlns:p="http://schemas.openxmlformats.org/presentationml/2006/main">
+  <p:tag name="KSO_WM_BEAUTIFY_FLAG" val=""/>
+</p:tagLst>
+</file>
+
+<file path=ppt/tags/tag99.xml><?xml version="1.0" encoding="utf-8"?>
 <p:tagLst xmlns:p="http://schemas.openxmlformats.org/presentationml/2006/main">
   <p:tag name="KSO_WM_BEAUTIFY_FLAG" val=""/>
 </p:tagLst>

</xml_diff>

<commit_message>
update_Generating Diverse High-Fidelity Images with VQ-VAE-2
</commit_message>
<xml_diff>
--- a/Base_Model/GAN+VAE+Diffusion/论文作图.pptx
+++ b/Base_Model/GAN+VAE+Diffusion/论文作图.pptx
@@ -8,7 +8,7 @@
     <p:notesMasterId r:id="rId4"/>
   </p:notesMasterIdLst>
   <p:handoutMasterIdLst>
-    <p:handoutMasterId r:id="rId12"/>
+    <p:handoutMasterId r:id="rId14"/>
   </p:handoutMasterIdLst>
   <p:sldIdLst>
     <p:sldId id="256" r:id="rId3"/>
@@ -19,6 +19,8 @@
     <p:sldId id="264" r:id="rId9"/>
     <p:sldId id="262" r:id="rId10"/>
     <p:sldId id="263" r:id="rId11"/>
+    <p:sldId id="265" r:id="rId12"/>
+    <p:sldId id="266" r:id="rId13"/>
   </p:sldIdLst>
   <p:sldSz cx="12192000" cy="6858000"/>
   <p:notesSz cx="7103745" cy="10234295"/>
@@ -3579,6 +3581,816 @@
 </p:sld>
 </file>
 
+<file path=ppt/slides/slide10.xml><?xml version="1.0" encoding="utf-8"?>
+<p:sld xmlns:a="http://schemas.openxmlformats.org/drawingml/2006/main" xmlns:r="http://schemas.openxmlformats.org/officeDocument/2006/relationships" xmlns:p="http://schemas.openxmlformats.org/presentationml/2006/main">
+  <p:cSld>
+    <p:spTree>
+      <p:nvGrpSpPr>
+        <p:cNvPr id="1" name=""/>
+        <p:cNvGrpSpPr/>
+        <p:nvPr/>
+      </p:nvGrpSpPr>
+      <p:grpSpPr/>
+      <p:pic>
+        <p:nvPicPr>
+          <p:cNvPr id="4" name="图片 3"/>
+          <p:cNvPicPr>
+            <a:picLocks noChangeAspect="1"/>
+          </p:cNvPicPr>
+          <p:nvPr>
+            <p:custDataLst>
+              <p:tags r:id="rId1"/>
+            </p:custDataLst>
+          </p:nvPr>
+        </p:nvPicPr>
+        <p:blipFill>
+          <a:blip r:embed="rId2"/>
+          <a:stretch>
+            <a:fillRect/>
+          </a:stretch>
+        </p:blipFill>
+        <p:spPr>
+          <a:xfrm>
+            <a:off x="2399665" y="188595"/>
+            <a:ext cx="7392670" cy="2709545"/>
+          </a:xfrm>
+          <a:prstGeom prst="rect">
+            <a:avLst/>
+          </a:prstGeom>
+        </p:spPr>
+      </p:pic>
+      <p:pic>
+        <p:nvPicPr>
+          <p:cNvPr id="5" name="图片 4"/>
+          <p:cNvPicPr>
+            <a:picLocks noChangeAspect="1"/>
+          </p:cNvPicPr>
+          <p:nvPr>
+            <p:custDataLst>
+              <p:tags r:id="rId3"/>
+            </p:custDataLst>
+          </p:nvPr>
+        </p:nvPicPr>
+        <p:blipFill>
+          <a:blip r:embed="rId4"/>
+          <a:stretch>
+            <a:fillRect/>
+          </a:stretch>
+        </p:blipFill>
+        <p:spPr>
+          <a:xfrm>
+            <a:off x="2399665" y="3262630"/>
+            <a:ext cx="6931660" cy="3505835"/>
+          </a:xfrm>
+          <a:prstGeom prst="rect">
+            <a:avLst/>
+          </a:prstGeom>
+        </p:spPr>
+      </p:pic>
+      <p:sp>
+        <p:nvSpPr>
+          <p:cNvPr id="13" name="文本框 12"/>
+          <p:cNvSpPr txBox="1"/>
+          <p:nvPr>
+            <p:custDataLst>
+              <p:tags r:id="rId5"/>
+            </p:custDataLst>
+          </p:nvPr>
+        </p:nvSpPr>
+        <p:spPr>
+          <a:xfrm>
+            <a:off x="-86995" y="3991610"/>
+            <a:ext cx="2755265" cy="334010"/>
+          </a:xfrm>
+          <a:prstGeom prst="rect">
+            <a:avLst/>
+          </a:prstGeom>
+          <a:noFill/>
+        </p:spPr>
+        <p:txBody>
+          <a:bodyPr wrap="square" rtlCol="0">
+            <a:noAutofit/>
+          </a:bodyPr>
+          <a:p>
+            <a:pPr algn="ctr"/>
+            <a:r>
+              <a:rPr lang="zh-CN" altLang="en-US" sz="1200" b="1">
+                <a:latin typeface="微软雅黑" charset="0"/>
+                <a:ea typeface="微软雅黑" charset="0"/>
+                <a:cs typeface="微软雅黑" charset="0"/>
+              </a:rPr>
+              <a:t>顶层编码器提取图像高层</a:t>
+            </a:r>
+            <a:r>
+              <a:rPr lang="zh-CN" altLang="en-US" sz="1200" b="1">
+                <a:latin typeface="微软雅黑" charset="0"/>
+                <a:ea typeface="微软雅黑" charset="0"/>
+                <a:cs typeface="微软雅黑" charset="0"/>
+              </a:rPr>
+              <a:t>特征</a:t>
+            </a:r>
+            <a:endParaRPr lang="zh-CN" altLang="en-US" sz="1200" b="1">
+              <a:latin typeface="微软雅黑" charset="0"/>
+              <a:ea typeface="微软雅黑" charset="0"/>
+              <a:cs typeface="微软雅黑" charset="0"/>
+            </a:endParaRPr>
+          </a:p>
+        </p:txBody>
+      </p:sp>
+      <p:sp>
+        <p:nvSpPr>
+          <p:cNvPr id="6" name="文本框 5"/>
+          <p:cNvSpPr txBox="1"/>
+          <p:nvPr>
+            <p:custDataLst>
+              <p:tags r:id="rId6"/>
+            </p:custDataLst>
+          </p:nvPr>
+        </p:nvSpPr>
+        <p:spPr>
+          <a:xfrm>
+            <a:off x="-86995" y="4626610"/>
+            <a:ext cx="2755265" cy="334010"/>
+          </a:xfrm>
+          <a:prstGeom prst="rect">
+            <a:avLst/>
+          </a:prstGeom>
+          <a:noFill/>
+        </p:spPr>
+        <p:txBody>
+          <a:bodyPr wrap="square" rtlCol="0">
+            <a:noAutofit/>
+          </a:bodyPr>
+          <a:p>
+            <a:pPr algn="ctr"/>
+            <a:r>
+              <a:rPr lang="zh-CN" altLang="en-US" sz="1200" b="1">
+                <a:latin typeface="微软雅黑" charset="0"/>
+                <a:ea typeface="微软雅黑" charset="0"/>
+                <a:cs typeface="微软雅黑" charset="0"/>
+              </a:rPr>
+              <a:t>将高层特征用词典</a:t>
+            </a:r>
+            <a:r>
+              <a:rPr lang="zh-CN" altLang="en-US" sz="1200" b="1">
+                <a:latin typeface="微软雅黑" charset="0"/>
+                <a:ea typeface="微软雅黑" charset="0"/>
+                <a:cs typeface="微软雅黑" charset="0"/>
+              </a:rPr>
+              <a:t>量化</a:t>
+            </a:r>
+            <a:endParaRPr lang="zh-CN" altLang="en-US" sz="1200" b="1">
+              <a:latin typeface="微软雅黑" charset="0"/>
+              <a:ea typeface="微软雅黑" charset="0"/>
+              <a:cs typeface="微软雅黑" charset="0"/>
+            </a:endParaRPr>
+          </a:p>
+        </p:txBody>
+      </p:sp>
+      <p:sp>
+        <p:nvSpPr>
+          <p:cNvPr id="7" name="文本框 6"/>
+          <p:cNvSpPr txBox="1"/>
+          <p:nvPr>
+            <p:custDataLst>
+              <p:tags r:id="rId7"/>
+            </p:custDataLst>
+          </p:nvPr>
+        </p:nvSpPr>
+        <p:spPr>
+          <a:xfrm>
+            <a:off x="-86995" y="5007610"/>
+            <a:ext cx="2755265" cy="334010"/>
+          </a:xfrm>
+          <a:prstGeom prst="rect">
+            <a:avLst/>
+          </a:prstGeom>
+          <a:noFill/>
+        </p:spPr>
+        <p:txBody>
+          <a:bodyPr wrap="square" rtlCol="0">
+            <a:noAutofit/>
+          </a:bodyPr>
+          <a:p>
+            <a:pPr algn="ctr"/>
+            <a:r>
+              <a:rPr lang="zh-CN" altLang="en-US" sz="1200" b="1">
+                <a:latin typeface="微软雅黑" charset="0"/>
+                <a:ea typeface="微软雅黑" charset="0"/>
+                <a:cs typeface="微软雅黑" charset="0"/>
+              </a:rPr>
+              <a:t>结合高层特征和原图，用底层编码器提取</a:t>
+            </a:r>
+            <a:r>
+              <a:rPr lang="zh-CN" altLang="en-US" sz="1200" b="1">
+                <a:latin typeface="微软雅黑" charset="0"/>
+                <a:ea typeface="微软雅黑" charset="0"/>
+                <a:cs typeface="微软雅黑" charset="0"/>
+              </a:rPr>
+              <a:t>底层特征</a:t>
+            </a:r>
+            <a:endParaRPr lang="zh-CN" altLang="en-US" sz="1200" b="1">
+              <a:latin typeface="微软雅黑" charset="0"/>
+              <a:ea typeface="微软雅黑" charset="0"/>
+              <a:cs typeface="微软雅黑" charset="0"/>
+            </a:endParaRPr>
+          </a:p>
+        </p:txBody>
+      </p:sp>
+      <p:sp>
+        <p:nvSpPr>
+          <p:cNvPr id="8" name="文本框 7"/>
+          <p:cNvSpPr txBox="1"/>
+          <p:nvPr>
+            <p:custDataLst>
+              <p:tags r:id="rId8"/>
+            </p:custDataLst>
+          </p:nvPr>
+        </p:nvSpPr>
+        <p:spPr>
+          <a:xfrm>
+            <a:off x="-86995" y="5515610"/>
+            <a:ext cx="2755265" cy="334010"/>
+          </a:xfrm>
+          <a:prstGeom prst="rect">
+            <a:avLst/>
+          </a:prstGeom>
+          <a:noFill/>
+        </p:spPr>
+        <p:txBody>
+          <a:bodyPr wrap="square" rtlCol="0">
+            <a:noAutofit/>
+          </a:bodyPr>
+          <a:p>
+            <a:pPr algn="ctr"/>
+            <a:r>
+              <a:rPr lang="zh-CN" altLang="en-US" sz="1200" b="1">
+                <a:latin typeface="微软雅黑" charset="0"/>
+                <a:ea typeface="微软雅黑" charset="0"/>
+                <a:cs typeface="微软雅黑" charset="0"/>
+              </a:rPr>
+              <a:t>底层特征用词典</a:t>
+            </a:r>
+            <a:r>
+              <a:rPr lang="zh-CN" altLang="en-US" sz="1200" b="1">
+                <a:latin typeface="微软雅黑" charset="0"/>
+                <a:ea typeface="微软雅黑" charset="0"/>
+                <a:cs typeface="微软雅黑" charset="0"/>
+              </a:rPr>
+              <a:t>量化</a:t>
+            </a:r>
+            <a:endParaRPr lang="zh-CN" altLang="en-US" sz="1200" b="1">
+              <a:latin typeface="微软雅黑" charset="0"/>
+              <a:ea typeface="微软雅黑" charset="0"/>
+              <a:cs typeface="微软雅黑" charset="0"/>
+            </a:endParaRPr>
+          </a:p>
+        </p:txBody>
+      </p:sp>
+      <p:sp>
+        <p:nvSpPr>
+          <p:cNvPr id="9" name="文本框 8"/>
+          <p:cNvSpPr txBox="1"/>
+          <p:nvPr>
+            <p:custDataLst>
+              <p:tags r:id="rId9"/>
+            </p:custDataLst>
+          </p:nvPr>
+        </p:nvSpPr>
+        <p:spPr>
+          <a:xfrm>
+            <a:off x="-86995" y="5896610"/>
+            <a:ext cx="2755265" cy="334010"/>
+          </a:xfrm>
+          <a:prstGeom prst="rect">
+            <a:avLst/>
+          </a:prstGeom>
+          <a:noFill/>
+        </p:spPr>
+        <p:txBody>
+          <a:bodyPr wrap="square" rtlCol="0">
+            <a:noAutofit/>
+          </a:bodyPr>
+          <a:p>
+            <a:pPr algn="ctr"/>
+            <a:r>
+              <a:rPr lang="zh-CN" altLang="en-US" sz="1200" b="1">
+                <a:latin typeface="微软雅黑" charset="0"/>
+                <a:ea typeface="微软雅黑" charset="0"/>
+                <a:cs typeface="微软雅黑" charset="0"/>
+              </a:rPr>
+              <a:t>编码器接受两个</a:t>
+            </a:r>
+            <a:r>
+              <a:rPr lang="zh-CN" altLang="en-US" sz="1200" b="1">
+                <a:latin typeface="微软雅黑" charset="0"/>
+                <a:ea typeface="微软雅黑" charset="0"/>
+                <a:cs typeface="微软雅黑" charset="0"/>
+              </a:rPr>
+              <a:t>量化特征重建</a:t>
+            </a:r>
+            <a:r>
+              <a:rPr lang="zh-CN" altLang="en-US" sz="1200" b="1">
+                <a:latin typeface="微软雅黑" charset="0"/>
+                <a:ea typeface="微软雅黑" charset="0"/>
+                <a:cs typeface="微软雅黑" charset="0"/>
+              </a:rPr>
+              <a:t>图像</a:t>
+            </a:r>
+            <a:endParaRPr lang="zh-CN" altLang="en-US" sz="1200" b="1">
+              <a:latin typeface="微软雅黑" charset="0"/>
+              <a:ea typeface="微软雅黑" charset="0"/>
+              <a:cs typeface="微软雅黑" charset="0"/>
+            </a:endParaRPr>
+          </a:p>
+        </p:txBody>
+      </p:sp>
+      <p:sp>
+        <p:nvSpPr>
+          <p:cNvPr id="10" name="文本框 9"/>
+          <p:cNvSpPr txBox="1"/>
+          <p:nvPr>
+            <p:custDataLst>
+              <p:tags r:id="rId10"/>
+            </p:custDataLst>
+          </p:nvPr>
+        </p:nvSpPr>
+        <p:spPr>
+          <a:xfrm>
+            <a:off x="-86995" y="6404610"/>
+            <a:ext cx="2755265" cy="334010"/>
+          </a:xfrm>
+          <a:prstGeom prst="rect">
+            <a:avLst/>
+          </a:prstGeom>
+          <a:noFill/>
+        </p:spPr>
+        <p:txBody>
+          <a:bodyPr wrap="square" rtlCol="0">
+            <a:noAutofit/>
+          </a:bodyPr>
+          <a:p>
+            <a:pPr algn="ctr"/>
+            <a:r>
+              <a:rPr lang="zh-CN" altLang="en-US" sz="1200" b="1">
+                <a:latin typeface="微软雅黑" charset="0"/>
+                <a:ea typeface="微软雅黑" charset="0"/>
+                <a:cs typeface="微软雅黑" charset="0"/>
+              </a:rPr>
+              <a:t>根据损失函数更新模型</a:t>
+            </a:r>
+            <a:r>
+              <a:rPr lang="zh-CN" altLang="en-US" sz="1200" b="1">
+                <a:latin typeface="微软雅黑" charset="0"/>
+                <a:ea typeface="微软雅黑" charset="0"/>
+                <a:cs typeface="微软雅黑" charset="0"/>
+              </a:rPr>
+              <a:t>参数</a:t>
+            </a:r>
+            <a:endParaRPr lang="zh-CN" altLang="en-US" sz="1200" b="1">
+              <a:latin typeface="微软雅黑" charset="0"/>
+              <a:ea typeface="微软雅黑" charset="0"/>
+              <a:cs typeface="微软雅黑" charset="0"/>
+            </a:endParaRPr>
+          </a:p>
+        </p:txBody>
+      </p:sp>
+      <p:sp>
+        <p:nvSpPr>
+          <p:cNvPr id="11" name="文本框 10"/>
+          <p:cNvSpPr txBox="1"/>
+          <p:nvPr>
+            <p:custDataLst>
+              <p:tags r:id="rId11"/>
+            </p:custDataLst>
+          </p:nvPr>
+        </p:nvSpPr>
+        <p:spPr>
+          <a:xfrm>
+            <a:off x="8930005" y="4245610"/>
+            <a:ext cx="2755265" cy="334010"/>
+          </a:xfrm>
+          <a:prstGeom prst="rect">
+            <a:avLst/>
+          </a:prstGeom>
+          <a:noFill/>
+        </p:spPr>
+        <p:txBody>
+          <a:bodyPr wrap="square" rtlCol="0">
+            <a:noAutofit/>
+          </a:bodyPr>
+          <a:p>
+            <a:pPr algn="ctr"/>
+            <a:r>
+              <a:rPr lang="zh-CN" altLang="en-US" sz="1200" b="1">
+                <a:latin typeface="微软雅黑" charset="0"/>
+                <a:ea typeface="微软雅黑" charset="0"/>
+                <a:cs typeface="微软雅黑" charset="0"/>
+              </a:rPr>
+              <a:t>将量化数据加入</a:t>
+            </a:r>
+            <a:r>
+              <a:rPr lang="zh-CN" altLang="en-US" sz="1200" b="1">
+                <a:latin typeface="微软雅黑" charset="0"/>
+                <a:ea typeface="微软雅黑" charset="0"/>
+                <a:cs typeface="微软雅黑" charset="0"/>
+              </a:rPr>
+              <a:t>字典中</a:t>
+            </a:r>
+            <a:endParaRPr lang="zh-CN" altLang="en-US" sz="1200" b="1">
+              <a:latin typeface="微软雅黑" charset="0"/>
+              <a:ea typeface="微软雅黑" charset="0"/>
+              <a:cs typeface="微软雅黑" charset="0"/>
+            </a:endParaRPr>
+          </a:p>
+        </p:txBody>
+      </p:sp>
+      <p:sp>
+        <p:nvSpPr>
+          <p:cNvPr id="12" name="文本框 11"/>
+          <p:cNvSpPr txBox="1"/>
+          <p:nvPr>
+            <p:custDataLst>
+              <p:tags r:id="rId12"/>
+            </p:custDataLst>
+          </p:nvPr>
+        </p:nvSpPr>
+        <p:spPr>
+          <a:xfrm>
+            <a:off x="9057005" y="4766945"/>
+            <a:ext cx="2755265" cy="334010"/>
+          </a:xfrm>
+          <a:prstGeom prst="rect">
+            <a:avLst/>
+          </a:prstGeom>
+          <a:noFill/>
+        </p:spPr>
+        <p:txBody>
+          <a:bodyPr wrap="square" rtlCol="0">
+            <a:noAutofit/>
+          </a:bodyPr>
+          <a:p>
+            <a:pPr algn="ctr"/>
+            <a:r>
+              <a:rPr lang="zh-CN" altLang="en-US" sz="1200" b="1">
+                <a:latin typeface="微软雅黑" charset="0"/>
+                <a:ea typeface="微软雅黑" charset="0"/>
+                <a:cs typeface="微软雅黑" charset="0"/>
+              </a:rPr>
+              <a:t>训练自回归模型</a:t>
+            </a:r>
+            <a:br>
+              <a:rPr lang="zh-CN" altLang="en-US" sz="1200" b="1">
+                <a:latin typeface="微软雅黑" charset="0"/>
+                <a:ea typeface="微软雅黑" charset="0"/>
+                <a:cs typeface="微软雅黑" charset="0"/>
+              </a:rPr>
+            </a:br>
+            <a:r>
+              <a:rPr lang="zh-CN" altLang="en-US" sz="1200" b="1">
+                <a:latin typeface="微软雅黑" charset="0"/>
+                <a:ea typeface="微软雅黑" charset="0"/>
+                <a:cs typeface="微软雅黑" charset="0"/>
+              </a:rPr>
+              <a:t>建立潜变量索引之间的关系</a:t>
+            </a:r>
+            <a:br>
+              <a:rPr lang="zh-CN" altLang="en-US" sz="1200" b="1">
+                <a:latin typeface="微软雅黑" charset="0"/>
+                <a:ea typeface="微软雅黑" charset="0"/>
+                <a:cs typeface="微软雅黑" charset="0"/>
+              </a:rPr>
+            </a:br>
+            <a:r>
+              <a:rPr lang="zh-CN" altLang="en-US" sz="1200" b="1">
+                <a:latin typeface="微软雅黑" charset="0"/>
+                <a:ea typeface="微软雅黑" charset="0"/>
+                <a:cs typeface="微软雅黑" charset="0"/>
+              </a:rPr>
+              <a:t>训练成功的模型可以一次预测每个潜变量出现的</a:t>
+            </a:r>
+            <a:r>
+              <a:rPr lang="zh-CN" altLang="en-US" sz="1200" b="1">
+                <a:latin typeface="微软雅黑" charset="0"/>
+                <a:ea typeface="微软雅黑" charset="0"/>
+                <a:cs typeface="微软雅黑" charset="0"/>
+              </a:rPr>
+              <a:t>概率</a:t>
+            </a:r>
+            <a:endParaRPr lang="zh-CN" altLang="en-US" sz="1200" b="1">
+              <a:latin typeface="微软雅黑" charset="0"/>
+              <a:ea typeface="微软雅黑" charset="0"/>
+              <a:cs typeface="微软雅黑" charset="0"/>
+            </a:endParaRPr>
+          </a:p>
+        </p:txBody>
+      </p:sp>
+      <p:sp>
+        <p:nvSpPr>
+          <p:cNvPr id="14" name="文本框 13"/>
+          <p:cNvSpPr txBox="1"/>
+          <p:nvPr>
+            <p:custDataLst>
+              <p:tags r:id="rId13"/>
+            </p:custDataLst>
+          </p:nvPr>
+        </p:nvSpPr>
+        <p:spPr>
+          <a:xfrm>
+            <a:off x="9057005" y="5909945"/>
+            <a:ext cx="2755265" cy="334010"/>
+          </a:xfrm>
+          <a:prstGeom prst="rect">
+            <a:avLst/>
+          </a:prstGeom>
+          <a:noFill/>
+        </p:spPr>
+        <p:txBody>
+          <a:bodyPr wrap="square" rtlCol="0">
+            <a:noAutofit/>
+          </a:bodyPr>
+          <a:p>
+            <a:pPr algn="ctr"/>
+            <a:r>
+              <a:rPr lang="zh-CN" altLang="en-US" sz="1200" b="1">
+                <a:latin typeface="微软雅黑" charset="0"/>
+                <a:ea typeface="微软雅黑" charset="0"/>
+                <a:cs typeface="微软雅黑" charset="0"/>
+              </a:rPr>
+              <a:t>从概率分布中随机采样</a:t>
+            </a:r>
+            <a:r>
+              <a:rPr lang="zh-CN" altLang="en-US" sz="1200" b="1">
+                <a:latin typeface="微软雅黑" charset="0"/>
+                <a:ea typeface="微软雅黑" charset="0"/>
+                <a:cs typeface="微软雅黑" charset="0"/>
+              </a:rPr>
+              <a:t>潜变量</a:t>
+            </a:r>
+            <a:endParaRPr lang="zh-CN" altLang="en-US" sz="1200" b="1">
+              <a:latin typeface="微软雅黑" charset="0"/>
+              <a:ea typeface="微软雅黑" charset="0"/>
+              <a:cs typeface="微软雅黑" charset="0"/>
+            </a:endParaRPr>
+          </a:p>
+        </p:txBody>
+      </p:sp>
+      <p:sp>
+        <p:nvSpPr>
+          <p:cNvPr id="15" name="文本框 14"/>
+          <p:cNvSpPr txBox="1"/>
+          <p:nvPr>
+            <p:custDataLst>
+              <p:tags r:id="rId14"/>
+            </p:custDataLst>
+          </p:nvPr>
+        </p:nvSpPr>
+        <p:spPr>
+          <a:xfrm>
+            <a:off x="9057005" y="6290945"/>
+            <a:ext cx="2755265" cy="334010"/>
+          </a:xfrm>
+          <a:prstGeom prst="rect">
+            <a:avLst/>
+          </a:prstGeom>
+          <a:noFill/>
+        </p:spPr>
+        <p:txBody>
+          <a:bodyPr wrap="square" rtlCol="0">
+            <a:noAutofit/>
+          </a:bodyPr>
+          <a:p>
+            <a:pPr algn="ctr"/>
+            <a:r>
+              <a:rPr lang="zh-CN" altLang="en-US" sz="1200" b="1">
+                <a:latin typeface="微软雅黑" charset="0"/>
+                <a:ea typeface="微软雅黑" charset="0"/>
+                <a:cs typeface="微软雅黑" charset="0"/>
+              </a:rPr>
+              <a:t>生成</a:t>
+            </a:r>
+            <a:r>
+              <a:rPr lang="zh-CN" altLang="en-US" sz="1200" b="1">
+                <a:latin typeface="微软雅黑" charset="0"/>
+                <a:ea typeface="微软雅黑" charset="0"/>
+                <a:cs typeface="微软雅黑" charset="0"/>
+              </a:rPr>
+              <a:t>全新图像</a:t>
+            </a:r>
+            <a:endParaRPr lang="zh-CN" altLang="en-US" sz="1200" b="1">
+              <a:latin typeface="微软雅黑" charset="0"/>
+              <a:ea typeface="微软雅黑" charset="0"/>
+              <a:cs typeface="微软雅黑" charset="0"/>
+            </a:endParaRPr>
+          </a:p>
+        </p:txBody>
+      </p:sp>
+      <p:sp>
+        <p:nvSpPr>
+          <p:cNvPr id="16" name="文本框 15"/>
+          <p:cNvSpPr txBox="1"/>
+          <p:nvPr>
+            <p:custDataLst>
+              <p:tags r:id="rId15"/>
+            </p:custDataLst>
+          </p:nvPr>
+        </p:nvSpPr>
+        <p:spPr>
+          <a:xfrm>
+            <a:off x="167005" y="2213610"/>
+            <a:ext cx="2755265" cy="334010"/>
+          </a:xfrm>
+          <a:prstGeom prst="rect">
+            <a:avLst/>
+          </a:prstGeom>
+          <a:noFill/>
+        </p:spPr>
+        <p:txBody>
+          <a:bodyPr wrap="square" rtlCol="0">
+            <a:noAutofit/>
+          </a:bodyPr>
+          <a:p>
+            <a:pPr algn="ctr"/>
+            <a:r>
+              <a:rPr lang="en-US" altLang="zh-CN" sz="1200" b="1">
+                <a:latin typeface="微软雅黑" charset="0"/>
+                <a:ea typeface="微软雅黑" charset="0"/>
+                <a:cs typeface="微软雅黑" charset="0"/>
+              </a:rPr>
+              <a:t>256x256</a:t>
+            </a:r>
+            <a:r>
+              <a:rPr lang="zh-CN" altLang="en-US" sz="1200" b="1">
+                <a:latin typeface="微软雅黑" charset="0"/>
+                <a:ea typeface="微软雅黑" charset="0"/>
+                <a:cs typeface="微软雅黑" charset="0"/>
+              </a:rPr>
+              <a:t>图像</a:t>
+            </a:r>
+            <a:endParaRPr lang="zh-CN" altLang="en-US" sz="1200" b="1">
+              <a:latin typeface="微软雅黑" charset="0"/>
+              <a:ea typeface="微软雅黑" charset="0"/>
+              <a:cs typeface="微软雅黑" charset="0"/>
+            </a:endParaRPr>
+          </a:p>
+        </p:txBody>
+      </p:sp>
+      <p:sp>
+        <p:nvSpPr>
+          <p:cNvPr id="17" name="文本框 16"/>
+          <p:cNvSpPr txBox="1"/>
+          <p:nvPr>
+            <p:custDataLst>
+              <p:tags r:id="rId16"/>
+            </p:custDataLst>
+          </p:nvPr>
+        </p:nvSpPr>
+        <p:spPr>
+          <a:xfrm>
+            <a:off x="167005" y="1324610"/>
+            <a:ext cx="2755265" cy="334010"/>
+          </a:xfrm>
+          <a:prstGeom prst="rect">
+            <a:avLst/>
+          </a:prstGeom>
+          <a:noFill/>
+        </p:spPr>
+        <p:txBody>
+          <a:bodyPr wrap="square" rtlCol="0">
+            <a:noAutofit/>
+          </a:bodyPr>
+          <a:p>
+            <a:pPr algn="ctr"/>
+            <a:r>
+              <a:rPr lang="zh-CN" altLang="en-US" sz="1200" b="1">
+                <a:latin typeface="微软雅黑" charset="0"/>
+                <a:ea typeface="微软雅黑" charset="0"/>
+                <a:cs typeface="微软雅黑" charset="0"/>
+              </a:rPr>
+              <a:t>底层采样为</a:t>
+            </a:r>
+            <a:r>
+              <a:rPr lang="en-US" altLang="zh-CN" sz="1200" b="1">
+                <a:latin typeface="微软雅黑" charset="0"/>
+                <a:ea typeface="微软雅黑" charset="0"/>
+                <a:cs typeface="微软雅黑" charset="0"/>
+              </a:rPr>
+              <a:t>64x64</a:t>
+            </a:r>
+            <a:endParaRPr lang="en-US" altLang="zh-CN" sz="1200" b="1">
+              <a:latin typeface="微软雅黑" charset="0"/>
+              <a:ea typeface="微软雅黑" charset="0"/>
+              <a:cs typeface="微软雅黑" charset="0"/>
+            </a:endParaRPr>
+          </a:p>
+        </p:txBody>
+      </p:sp>
+      <p:sp>
+        <p:nvSpPr>
+          <p:cNvPr id="18" name="文本框 17"/>
+          <p:cNvSpPr txBox="1"/>
+          <p:nvPr>
+            <p:custDataLst>
+              <p:tags r:id="rId17"/>
+            </p:custDataLst>
+          </p:nvPr>
+        </p:nvSpPr>
+        <p:spPr>
+          <a:xfrm>
+            <a:off x="167005" y="562610"/>
+            <a:ext cx="2755265" cy="334010"/>
+          </a:xfrm>
+          <a:prstGeom prst="rect">
+            <a:avLst/>
+          </a:prstGeom>
+          <a:noFill/>
+        </p:spPr>
+        <p:txBody>
+          <a:bodyPr wrap="square" rtlCol="0">
+            <a:noAutofit/>
+          </a:bodyPr>
+          <a:p>
+            <a:pPr algn="ctr"/>
+            <a:r>
+              <a:rPr lang="zh-CN" altLang="en-US" sz="1200" b="1">
+                <a:latin typeface="微软雅黑" charset="0"/>
+                <a:ea typeface="微软雅黑" charset="0"/>
+                <a:cs typeface="微软雅黑" charset="0"/>
+              </a:rPr>
+              <a:t>高层采样为</a:t>
+            </a:r>
+            <a:r>
+              <a:rPr lang="en-US" altLang="zh-CN" sz="1200" b="1">
+                <a:latin typeface="微软雅黑" charset="0"/>
+                <a:ea typeface="微软雅黑" charset="0"/>
+                <a:cs typeface="微软雅黑" charset="0"/>
+              </a:rPr>
+              <a:t>32x32</a:t>
+            </a:r>
+            <a:endParaRPr lang="en-US" altLang="zh-CN" sz="1200" b="1">
+              <a:latin typeface="微软雅黑" charset="0"/>
+              <a:ea typeface="微软雅黑" charset="0"/>
+              <a:cs typeface="微软雅黑" charset="0"/>
+            </a:endParaRPr>
+          </a:p>
+        </p:txBody>
+      </p:sp>
+      <p:sp>
+        <p:nvSpPr>
+          <p:cNvPr id="19" name="文本框 18"/>
+          <p:cNvSpPr txBox="1"/>
+          <p:nvPr>
+            <p:custDataLst>
+              <p:tags r:id="rId18"/>
+            </p:custDataLst>
+          </p:nvPr>
+        </p:nvSpPr>
+        <p:spPr>
+          <a:xfrm>
+            <a:off x="1360170" y="2975610"/>
+            <a:ext cx="8497570" cy="334010"/>
+          </a:xfrm>
+          <a:prstGeom prst="rect">
+            <a:avLst/>
+          </a:prstGeom>
+          <a:noFill/>
+        </p:spPr>
+        <p:txBody>
+          <a:bodyPr wrap="square" rtlCol="0">
+            <a:noAutofit/>
+          </a:bodyPr>
+          <a:p>
+            <a:pPr algn="ctr"/>
+            <a:r>
+              <a:rPr lang="zh-CN" altLang="en-US" b="1">
+                <a:solidFill>
+                  <a:srgbClr val="C00000"/>
+                </a:solidFill>
+                <a:latin typeface="微软雅黑" charset="0"/>
+                <a:ea typeface="微软雅黑" charset="0"/>
+                <a:cs typeface="微软雅黑" charset="0"/>
+              </a:rPr>
+              <a:t>训练模型的潜变量模型后验作为生成图像的潜变量模型先验</a:t>
+            </a:r>
+            <a:endParaRPr lang="zh-CN" altLang="en-US" b="1">
+              <a:solidFill>
+                <a:srgbClr val="C00000"/>
+              </a:solidFill>
+              <a:latin typeface="微软雅黑" charset="0"/>
+              <a:ea typeface="微软雅黑" charset="0"/>
+              <a:cs typeface="微软雅黑" charset="0"/>
+            </a:endParaRPr>
+          </a:p>
+        </p:txBody>
+      </p:sp>
+    </p:spTree>
+  </p:cSld>
+  <p:clrMapOvr>
+    <a:masterClrMapping/>
+  </p:clrMapOvr>
+</p:sld>
+</file>
+
 <file path=ppt/slides/slide2.xml><?xml version="1.0" encoding="utf-8"?>
 <p:sld xmlns:a="http://schemas.openxmlformats.org/drawingml/2006/main" xmlns:r="http://schemas.openxmlformats.org/officeDocument/2006/relationships" xmlns:p="http://schemas.openxmlformats.org/presentationml/2006/main">
   <p:cSld>
@@ -9292,7 +10104,7 @@
       </p:sp>
       <p:sp>
         <p:nvSpPr>
-          <p:cNvPr id="42" name="文本框 41"/>
+          <p:cNvPr id="43" name="文本框 42"/>
           <p:cNvSpPr txBox="1"/>
           <p:nvPr>
             <p:custDataLst>
@@ -9302,159 +10114,7 @@
         </p:nvSpPr>
         <p:spPr>
           <a:xfrm>
-            <a:off x="8627745" y="4206875"/>
-            <a:ext cx="3313430" cy="1315720"/>
-          </a:xfrm>
-          <a:prstGeom prst="rect">
-            <a:avLst/>
-          </a:prstGeom>
-          <a:noFill/>
-        </p:spPr>
-        <p:txBody>
-          <a:bodyPr wrap="square" rtlCol="0">
-            <a:noAutofit/>
-          </a:bodyPr>
-          <a:p>
-            <a:pPr algn="ctr"/>
-            <a:r>
-              <a:rPr lang="en-US" altLang="zh-CN" sz="1400" b="1">
-                <a:latin typeface="微软雅黑" charset="0"/>
-                <a:ea typeface="微软雅黑" charset="0"/>
-                <a:cs typeface="微软雅黑" charset="0"/>
-              </a:rPr>
-              <a:t>Encoder+Decoder</a:t>
-            </a:r>
-            <a:r>
-              <a:rPr lang="zh-CN" altLang="en-US" sz="1400" b="1">
-                <a:latin typeface="微软雅黑" charset="0"/>
-                <a:ea typeface="微软雅黑" charset="0"/>
-                <a:cs typeface="微软雅黑" charset="0"/>
-              </a:rPr>
-              <a:t>训练</a:t>
-            </a:r>
-            <a:br>
-              <a:rPr lang="zh-CN" altLang="en-US" sz="1400" b="1">
-                <a:latin typeface="微软雅黑" charset="0"/>
-                <a:ea typeface="微软雅黑" charset="0"/>
-                <a:cs typeface="微软雅黑" charset="0"/>
-              </a:rPr>
-            </a:br>
-            <a:r>
-              <a:rPr lang="zh-CN" altLang="en-US" sz="1400" b="1">
-                <a:latin typeface="微软雅黑" charset="0"/>
-                <a:ea typeface="微软雅黑" charset="0"/>
-                <a:cs typeface="微软雅黑" charset="0"/>
-              </a:rPr>
-              <a:t>根据初始图像和重建图像的</a:t>
-            </a:r>
-            <a:r>
-              <a:rPr lang="en-US" altLang="zh-CN" sz="1400" b="1">
-                <a:latin typeface="微软雅黑" charset="0"/>
-                <a:ea typeface="微软雅黑" charset="0"/>
-                <a:cs typeface="微软雅黑" charset="0"/>
-              </a:rPr>
-              <a:t>MSE Loss</a:t>
-            </a:r>
-            <a:br>
-              <a:rPr lang="en-US" altLang="zh-CN" sz="1400" b="1">
-                <a:latin typeface="微软雅黑" charset="0"/>
-                <a:ea typeface="微软雅黑" charset="0"/>
-                <a:cs typeface="微软雅黑" charset="0"/>
-              </a:rPr>
-            </a:br>
-            <a:r>
-              <a:rPr lang="en-US" altLang="zh-CN" sz="1400" b="1">
-                <a:latin typeface="微软雅黑" charset="0"/>
-                <a:ea typeface="微软雅黑" charset="0"/>
-                <a:cs typeface="微软雅黑" charset="0"/>
-              </a:rPr>
-              <a:t>codebook</a:t>
-            </a:r>
-            <a:r>
-              <a:rPr lang="zh-CN" altLang="en-US" sz="1400" b="1">
-                <a:latin typeface="微软雅黑" charset="0"/>
-                <a:ea typeface="微软雅黑" charset="0"/>
-                <a:cs typeface="微软雅黑" charset="0"/>
-              </a:rPr>
-              <a:t>训练</a:t>
-            </a:r>
-            <a:endParaRPr lang="zh-CN" altLang="en-US" sz="1400" b="1">
-              <a:latin typeface="微软雅黑" charset="0"/>
-              <a:ea typeface="微软雅黑" charset="0"/>
-              <a:cs typeface="微软雅黑" charset="0"/>
-            </a:endParaRPr>
-          </a:p>
-          <a:p>
-            <a:pPr algn="ctr"/>
-            <a:r>
-              <a:rPr lang="zh-CN" altLang="en-US" sz="1400" b="1">
-                <a:latin typeface="微软雅黑" charset="0"/>
-                <a:ea typeface="微软雅黑" charset="0"/>
-                <a:cs typeface="微软雅黑" charset="0"/>
-              </a:rPr>
-              <a:t>在初始输入特征中，计算和</a:t>
-            </a:r>
-            <a:r>
-              <a:rPr lang="en-US" altLang="zh-CN" sz="1400" b="1">
-                <a:latin typeface="微软雅黑" charset="0"/>
-                <a:ea typeface="微软雅黑" charset="0"/>
-                <a:cs typeface="微软雅黑" charset="0"/>
-              </a:rPr>
-              <a:t>codebook</a:t>
-            </a:r>
-            <a:r>
-              <a:rPr lang="zh-CN" altLang="en-US" sz="1400" b="1">
-                <a:latin typeface="微软雅黑" charset="0"/>
-                <a:ea typeface="微软雅黑" charset="0"/>
-                <a:cs typeface="微软雅黑" charset="0"/>
-              </a:rPr>
-              <a:t>中的距离，离的最近的那个</a:t>
-            </a:r>
-            <a:r>
-              <a:rPr lang="en-US" altLang="zh-CN" sz="1400" b="1">
-                <a:latin typeface="微软雅黑" charset="0"/>
-                <a:ea typeface="微软雅黑" charset="0"/>
-                <a:cs typeface="微软雅黑" charset="0"/>
-              </a:rPr>
-              <a:t>codebook</a:t>
-            </a:r>
-            <a:r>
-              <a:rPr lang="zh-CN" altLang="en-US" sz="1400" b="1">
-                <a:latin typeface="微软雅黑" charset="0"/>
-                <a:ea typeface="微软雅黑" charset="0"/>
-                <a:cs typeface="微软雅黑" charset="0"/>
-              </a:rPr>
-              <a:t>中的特征朝真实的特征方向优化（朝着真实的</a:t>
-            </a:r>
-            <a:r>
-              <a:rPr lang="zh-CN" altLang="en-US" sz="1400" b="1">
-                <a:latin typeface="微软雅黑" charset="0"/>
-                <a:ea typeface="微软雅黑" charset="0"/>
-                <a:cs typeface="微软雅黑" charset="0"/>
-              </a:rPr>
-              <a:t>方向拉一下）</a:t>
-            </a:r>
-            <a:endParaRPr lang="zh-CN" altLang="en-US" sz="1400" b="1">
-              <a:latin typeface="微软雅黑" charset="0"/>
-              <a:ea typeface="微软雅黑" charset="0"/>
-              <a:cs typeface="微软雅黑" charset="0"/>
-            </a:endParaRPr>
-          </a:p>
-        </p:txBody>
-      </p:sp>
-      <p:sp>
-        <p:nvSpPr>
-          <p:cNvPr id="43" name="文本框 42"/>
-          <p:cNvSpPr txBox="1"/>
-          <p:nvPr>
-            <p:custDataLst>
-              <p:tags r:id="rId43"/>
-            </p:custDataLst>
-          </p:nvPr>
-        </p:nvSpPr>
-        <p:spPr>
-          <a:xfrm>
-            <a:off x="4463415" y="4080510"/>
+            <a:off x="6280785" y="3957955"/>
             <a:ext cx="5005070" cy="878205"/>
           </a:xfrm>
           <a:prstGeom prst="rect">
@@ -9574,12 +10234,12 @@
           </p:cNvPicPr>
           <p:nvPr>
             <p:custDataLst>
-              <p:tags r:id="rId44"/>
+              <p:tags r:id="rId43"/>
             </p:custDataLst>
           </p:nvPr>
         </p:nvPicPr>
         <p:blipFill>
-          <a:blip r:embed="rId45"/>
+          <a:blip r:embed="rId44"/>
           <a:stretch>
             <a:fillRect/>
           </a:stretch>
@@ -9600,7 +10260,7 @@
           <p:cNvSpPr txBox="1"/>
           <p:nvPr>
             <p:custDataLst>
-              <p:tags r:id="rId46"/>
+              <p:tags r:id="rId45"/>
             </p:custDataLst>
           </p:nvPr>
         </p:nvSpPr>
@@ -9665,7 +10325,7 @@
           <p:cNvSpPr txBox="1"/>
           <p:nvPr>
             <p:custDataLst>
-              <p:tags r:id="rId47"/>
+              <p:tags r:id="rId46"/>
             </p:custDataLst>
           </p:nvPr>
         </p:nvSpPr>
@@ -9738,7 +10398,7 @@
           <p:cNvSpPr txBox="1"/>
           <p:nvPr>
             <p:custDataLst>
-              <p:tags r:id="rId48"/>
+              <p:tags r:id="rId47"/>
             </p:custDataLst>
           </p:nvPr>
         </p:nvSpPr>
@@ -9803,7 +10463,7 @@
           <p:cNvSpPr txBox="1"/>
           <p:nvPr>
             <p:custDataLst>
-              <p:tags r:id="rId49"/>
+              <p:tags r:id="rId48"/>
             </p:custDataLst>
           </p:nvPr>
         </p:nvSpPr>
@@ -9970,6 +10630,374 @@
               <a:latin typeface="微软雅黑" charset="0"/>
               <a:ea typeface="微软雅黑" charset="0"/>
               <a:cs typeface="微软雅黑" charset="0"/>
+            </a:endParaRPr>
+          </a:p>
+        </p:txBody>
+      </p:sp>
+      <p:sp>
+        <p:nvSpPr>
+          <p:cNvPr id="49" name="矩形: 圆角 36"/>
+          <p:cNvSpPr/>
+          <p:nvPr>
+            <p:custDataLst>
+              <p:tags r:id="rId49"/>
+            </p:custDataLst>
+          </p:nvPr>
+        </p:nvSpPr>
+        <p:spPr>
+          <a:xfrm rot="10800000" flipV="1">
+            <a:off x="0" y="58420"/>
+            <a:ext cx="5620385" cy="3671570"/>
+          </a:xfrm>
+          <a:prstGeom prst="roundRect">
+            <a:avLst>
+              <a:gd name="adj" fmla="val 10039"/>
+            </a:avLst>
+          </a:prstGeom>
+          <a:noFill/>
+          <a:ln w="38100">
+            <a:solidFill>
+              <a:schemeClr val="tx1"/>
+            </a:solidFill>
+            <a:prstDash val="lgDash"/>
+          </a:ln>
+        </p:spPr>
+        <p:style>
+          <a:lnRef idx="2">
+            <a:schemeClr val="accent1">
+              <a:shade val="15000"/>
+            </a:schemeClr>
+          </a:lnRef>
+          <a:fillRef idx="1">
+            <a:schemeClr val="accent1"/>
+          </a:fillRef>
+          <a:effectRef idx="0">
+            <a:schemeClr val="accent1"/>
+          </a:effectRef>
+          <a:fontRef idx="minor">
+            <a:schemeClr val="lt1"/>
+          </a:fontRef>
+        </p:style>
+        <p:txBody>
+          <a:bodyPr rtlCol="0" anchor="ctr"/>
+          <a:p>
+            <a:pPr algn="ctr"/>
+            <a:endParaRPr lang="zh-CN" altLang="en-US"/>
+          </a:p>
+        </p:txBody>
+      </p:sp>
+      <p:sp>
+        <p:nvSpPr>
+          <p:cNvPr id="50" name="文本框 49"/>
+          <p:cNvSpPr txBox="1"/>
+          <p:nvPr>
+            <p:custDataLst>
+              <p:tags r:id="rId50"/>
+            </p:custDataLst>
+          </p:nvPr>
+        </p:nvSpPr>
+        <p:spPr>
+          <a:xfrm>
+            <a:off x="170815" y="135255"/>
+            <a:ext cx="5005070" cy="878205"/>
+          </a:xfrm>
+          <a:prstGeom prst="rect">
+            <a:avLst/>
+          </a:prstGeom>
+          <a:noFill/>
+        </p:spPr>
+        <p:txBody>
+          <a:bodyPr wrap="square" rtlCol="0">
+            <a:noAutofit/>
+          </a:bodyPr>
+          <a:p>
+            <a:pPr algn="ctr"/>
+            <a:r>
+              <a:rPr lang="en-US" altLang="zh-CN" sz="2000" b="1">
+                <a:solidFill>
+                  <a:schemeClr val="tx1"/>
+                </a:solidFill>
+                <a:latin typeface="微软雅黑" charset="0"/>
+                <a:ea typeface="微软雅黑" charset="0"/>
+                <a:cs typeface="微软雅黑" charset="0"/>
+              </a:rPr>
+              <a:t>VAE</a:t>
+            </a:r>
+            <a:r>
+              <a:rPr lang="zh-CN" altLang="en-US" sz="2000" b="1">
+                <a:solidFill>
+                  <a:schemeClr val="tx1"/>
+                </a:solidFill>
+                <a:latin typeface="微软雅黑" charset="0"/>
+                <a:ea typeface="微软雅黑" charset="0"/>
+                <a:cs typeface="微软雅黑" charset="0"/>
+              </a:rPr>
+              <a:t>问题</a:t>
+            </a:r>
+            <a:endParaRPr lang="zh-CN" altLang="en-US" sz="2000" b="1">
+              <a:solidFill>
+                <a:schemeClr val="tx1"/>
+              </a:solidFill>
+              <a:latin typeface="微软雅黑" charset="0"/>
+              <a:ea typeface="微软雅黑" charset="0"/>
+              <a:cs typeface="微软雅黑" charset="0"/>
+            </a:endParaRPr>
+          </a:p>
+        </p:txBody>
+      </p:sp>
+      <p:sp>
+        <p:nvSpPr>
+          <p:cNvPr id="51" name="矩形: 圆角 36"/>
+          <p:cNvSpPr/>
+          <p:nvPr>
+            <p:custDataLst>
+              <p:tags r:id="rId51"/>
+            </p:custDataLst>
+          </p:nvPr>
+        </p:nvSpPr>
+        <p:spPr>
+          <a:xfrm rot="10800000" flipV="1">
+            <a:off x="5969000" y="2021205"/>
+            <a:ext cx="5620385" cy="2545080"/>
+          </a:xfrm>
+          <a:prstGeom prst="roundRect">
+            <a:avLst>
+              <a:gd name="adj" fmla="val 10039"/>
+            </a:avLst>
+          </a:prstGeom>
+          <a:noFill/>
+          <a:ln w="38100">
+            <a:solidFill>
+              <a:schemeClr val="tx1"/>
+            </a:solidFill>
+            <a:prstDash val="lgDash"/>
+          </a:ln>
+        </p:spPr>
+        <p:style>
+          <a:lnRef idx="2">
+            <a:schemeClr val="accent1">
+              <a:shade val="15000"/>
+            </a:schemeClr>
+          </a:lnRef>
+          <a:fillRef idx="1">
+            <a:schemeClr val="accent1"/>
+          </a:fillRef>
+          <a:effectRef idx="0">
+            <a:schemeClr val="accent1"/>
+          </a:effectRef>
+          <a:fontRef idx="minor">
+            <a:schemeClr val="lt1"/>
+          </a:fontRef>
+        </p:style>
+        <p:txBody>
+          <a:bodyPr rtlCol="0" anchor="ctr"/>
+          <a:p>
+            <a:pPr algn="ctr"/>
+            <a:endParaRPr lang="zh-CN" altLang="en-US"/>
+          </a:p>
+        </p:txBody>
+      </p:sp>
+      <p:sp>
+        <p:nvSpPr>
+          <p:cNvPr id="53" name="文本框 52"/>
+          <p:cNvSpPr txBox="1"/>
+          <p:nvPr>
+            <p:custDataLst>
+              <p:tags r:id="rId52"/>
+            </p:custDataLst>
+          </p:nvPr>
+        </p:nvSpPr>
+        <p:spPr>
+          <a:xfrm>
+            <a:off x="6696710" y="4836160"/>
+            <a:ext cx="5121275" cy="1395095"/>
+          </a:xfrm>
+          <a:prstGeom prst="rect">
+            <a:avLst/>
+          </a:prstGeom>
+          <a:noFill/>
+        </p:spPr>
+        <p:txBody>
+          <a:bodyPr wrap="square" rtlCol="0">
+            <a:noAutofit/>
+          </a:bodyPr>
+          <a:p>
+            <a:pPr algn="ctr"/>
+            <a:r>
+              <a:rPr lang="en-US" altLang="zh-CN" sz="1400" b="1">
+                <a:latin typeface="微软雅黑" charset="0"/>
+                <a:ea typeface="微软雅黑" charset="0"/>
+                <a:cs typeface="微软雅黑" charset="0"/>
+              </a:rPr>
+              <a:t>Prior</a:t>
+            </a:r>
+            <a:br>
+              <a:rPr lang="en-US" altLang="zh-CN" sz="1400" b="1">
+                <a:latin typeface="微软雅黑" charset="0"/>
+                <a:ea typeface="微软雅黑" charset="0"/>
+                <a:cs typeface="微软雅黑" charset="0"/>
+              </a:rPr>
+            </a:br>
+            <a:r>
+              <a:rPr lang="zh-CN" altLang="en-US" sz="1400" b="1">
+                <a:latin typeface="微软雅黑" charset="0"/>
+                <a:ea typeface="微软雅黑" charset="0"/>
+                <a:cs typeface="微软雅黑" charset="0"/>
+              </a:rPr>
+              <a:t>前面我们建立好了如何将图片映射到</a:t>
+            </a:r>
+            <a:r>
+              <a:rPr lang="en-US" altLang="zh-CN" sz="1400" b="1">
+                <a:latin typeface="微软雅黑" charset="0"/>
+                <a:ea typeface="微软雅黑" charset="0"/>
+                <a:cs typeface="微软雅黑" charset="0"/>
+              </a:rPr>
+              <a:t>Codebook</a:t>
+            </a:r>
+            <a:r>
+              <a:rPr lang="zh-CN" altLang="en-US" sz="1400" b="1">
+                <a:latin typeface="微软雅黑" charset="0"/>
+                <a:ea typeface="微软雅黑" charset="0"/>
+                <a:cs typeface="微软雅黑" charset="0"/>
+              </a:rPr>
+              <a:t>中</a:t>
+            </a:r>
+            <a:br>
+              <a:rPr lang="zh-CN" altLang="en-US" sz="1400" b="1">
+                <a:latin typeface="微软雅黑" charset="0"/>
+                <a:ea typeface="微软雅黑" charset="0"/>
+                <a:cs typeface="微软雅黑" charset="0"/>
+              </a:rPr>
+            </a:br>
+            <a:r>
+              <a:rPr lang="en-US" altLang="zh-CN" sz="1400" b="1">
+                <a:latin typeface="微软雅黑" charset="0"/>
+                <a:ea typeface="微软雅黑" charset="0"/>
+                <a:cs typeface="微软雅黑" charset="0"/>
+                <a:sym typeface="+mn-ea"/>
+              </a:rPr>
+              <a:t>Prior</a:t>
+            </a:r>
+            <a:r>
+              <a:rPr lang="zh-CN" altLang="en-US" sz="1400" b="1">
+                <a:latin typeface="微软雅黑" charset="0"/>
+                <a:ea typeface="微软雅黑" charset="0"/>
+                <a:cs typeface="微软雅黑" charset="0"/>
+                <a:sym typeface="+mn-ea"/>
+              </a:rPr>
+              <a:t>主要解决生成问题，离散化</a:t>
+            </a:r>
+            <a:r>
+              <a:rPr lang="en-US" altLang="zh-CN" sz="1400" b="1">
+                <a:latin typeface="微软雅黑" charset="0"/>
+                <a:ea typeface="微软雅黑" charset="0"/>
+                <a:cs typeface="微软雅黑" charset="0"/>
+                <a:sym typeface="+mn-ea"/>
+              </a:rPr>
+              <a:t>Codebook</a:t>
+            </a:r>
+            <a:r>
+              <a:rPr lang="zh-CN" altLang="en-US" sz="1400" b="1">
+                <a:latin typeface="微软雅黑" charset="0"/>
+                <a:ea typeface="微软雅黑" charset="0"/>
+                <a:cs typeface="微软雅黑" charset="0"/>
+                <a:sym typeface="+mn-ea"/>
+              </a:rPr>
+              <a:t>无法进行随机</a:t>
+            </a:r>
+            <a:r>
+              <a:rPr lang="zh-CN" altLang="en-US" sz="1400" b="1">
+                <a:latin typeface="微软雅黑" charset="0"/>
+                <a:ea typeface="微软雅黑" charset="0"/>
+                <a:cs typeface="微软雅黑" charset="0"/>
+                <a:sym typeface="+mn-ea"/>
+              </a:rPr>
+              <a:t>采样</a:t>
+            </a:r>
+            <a:br>
+              <a:rPr lang="zh-CN" altLang="en-US" sz="1400" b="1">
+                <a:latin typeface="微软雅黑" charset="0"/>
+                <a:ea typeface="微软雅黑" charset="0"/>
+                <a:cs typeface="微软雅黑" charset="0"/>
+                <a:sym typeface="+mn-ea"/>
+              </a:rPr>
+            </a:br>
+            <a:r>
+              <a:rPr lang="zh-CN" altLang="en-US" sz="1400" b="1">
+                <a:latin typeface="微软雅黑" charset="0"/>
+                <a:ea typeface="微软雅黑" charset="0"/>
+                <a:cs typeface="微软雅黑" charset="0"/>
+                <a:sym typeface="+mn-ea"/>
+              </a:rPr>
+              <a:t>第一个特征：直接从 PixelCNN 学到的 初始分布 随机采样。</a:t>
+            </a:r>
+            <a:endParaRPr lang="zh-CN" altLang="en-US" sz="1400" b="1">
+              <a:latin typeface="微软雅黑" charset="0"/>
+              <a:ea typeface="微软雅黑" charset="0"/>
+              <a:cs typeface="微软雅黑" charset="0"/>
+              <a:sym typeface="+mn-ea"/>
+            </a:endParaRPr>
+          </a:p>
+          <a:p>
+            <a:pPr algn="ctr"/>
+            <a:r>
+              <a:rPr lang="zh-CN" altLang="en-US" sz="1400" b="1">
+                <a:latin typeface="微软雅黑" charset="0"/>
+                <a:ea typeface="微软雅黑" charset="0"/>
+                <a:cs typeface="微软雅黑" charset="0"/>
+                <a:sym typeface="+mn-ea"/>
+              </a:rPr>
+              <a:t>后续特征：PixelCNN 根据 前面已采样出的特征 条件概率分布，推断当前特征的分布，并从中随机采样。</a:t>
+            </a:r>
+            <a:br>
+              <a:rPr lang="zh-CN" altLang="en-US" sz="1400" b="1">
+                <a:latin typeface="微软雅黑" charset="0"/>
+                <a:ea typeface="微软雅黑" charset="0"/>
+                <a:cs typeface="微软雅黑" charset="0"/>
+                <a:sym typeface="+mn-ea"/>
+              </a:rPr>
+            </a:br>
+            <a:r>
+              <a:rPr lang="zh-CN" altLang="en-US" sz="1400" b="1">
+                <a:latin typeface="微软雅黑" charset="0"/>
+                <a:ea typeface="微软雅黑" charset="0"/>
+                <a:cs typeface="微软雅黑" charset="0"/>
+                <a:sym typeface="+mn-ea"/>
+              </a:rPr>
+              <a:t>使用了类似</a:t>
+            </a:r>
+            <a:r>
+              <a:rPr lang="en-US" altLang="zh-CN" sz="1400" b="1">
+                <a:latin typeface="微软雅黑" charset="0"/>
+                <a:ea typeface="微软雅黑" charset="0"/>
+                <a:cs typeface="微软雅黑" charset="0"/>
+                <a:sym typeface="+mn-ea"/>
+              </a:rPr>
+              <a:t>LLM</a:t>
+            </a:r>
+            <a:r>
+              <a:rPr lang="zh-CN" altLang="en-US" sz="1400" b="1">
+                <a:latin typeface="微软雅黑" charset="0"/>
+                <a:ea typeface="微软雅黑" charset="0"/>
+                <a:cs typeface="微软雅黑" charset="0"/>
+                <a:sym typeface="+mn-ea"/>
+              </a:rPr>
+              <a:t>的生成</a:t>
+            </a:r>
+            <a:r>
+              <a:rPr lang="zh-CN" altLang="en-US" sz="1400" b="1">
+                <a:latin typeface="微软雅黑" charset="0"/>
+                <a:ea typeface="微软雅黑" charset="0"/>
+                <a:cs typeface="微软雅黑" charset="0"/>
+                <a:sym typeface="+mn-ea"/>
+              </a:rPr>
+              <a:t>原理</a:t>
+            </a:r>
+            <a:endParaRPr lang="zh-CN" altLang="en-US" sz="1400" b="1">
+              <a:latin typeface="微软雅黑" charset="0"/>
+              <a:ea typeface="微软雅黑" charset="0"/>
+              <a:cs typeface="微软雅黑" charset="0"/>
+              <a:sym typeface="+mn-ea"/>
             </a:endParaRPr>
           </a:p>
         </p:txBody>
@@ -10011,24 +11039,6 @@
               <a:t>GAN</a:t>
             </a:r>
             <a:endParaRPr lang="en-US" altLang="zh-CN"/>
-          </a:p>
-        </p:txBody>
-      </p:sp>
-      <p:sp>
-        <p:nvSpPr>
-          <p:cNvPr id="3" name="副标题 2"/>
-          <p:cNvSpPr>
-            <a:spLocks noGrp="1"/>
-          </p:cNvSpPr>
-          <p:nvPr>
-            <p:ph type="subTitle" idx="1"/>
-          </p:nvPr>
-        </p:nvSpPr>
-        <p:spPr/>
-        <p:txBody>
-          <a:bodyPr/>
-          <a:p>
-            <a:endParaRPr lang="zh-CN" altLang="en-US"/>
           </a:p>
         </p:txBody>
       </p:sp>
@@ -11049,6 +12059,64 @@
 </p:sld>
 </file>
 
+<file path=ppt/slides/slide9.xml><?xml version="1.0" encoding="utf-8"?>
+<p:sld xmlns:a="http://schemas.openxmlformats.org/drawingml/2006/main" xmlns:r="http://schemas.openxmlformats.org/officeDocument/2006/relationships" xmlns:p="http://schemas.openxmlformats.org/presentationml/2006/main">
+  <p:cSld>
+    <p:spTree>
+      <p:nvGrpSpPr>
+        <p:cNvPr id="1" name=""/>
+        <p:cNvGrpSpPr/>
+        <p:nvPr/>
+      </p:nvGrpSpPr>
+      <p:grpSpPr/>
+      <p:sp>
+        <p:nvSpPr>
+          <p:cNvPr id="2" name="标题 1"/>
+          <p:cNvSpPr>
+            <a:spLocks noGrp="1"/>
+          </p:cNvSpPr>
+          <p:nvPr>
+            <p:ph type="ctrTitle"/>
+          </p:nvPr>
+        </p:nvSpPr>
+        <p:spPr/>
+        <p:txBody>
+          <a:bodyPr/>
+          <a:p>
+            <a:r>
+              <a:rPr lang="en-US" altLang="zh-CN"/>
+              <a:t>VQ-VAE2</a:t>
+            </a:r>
+            <a:endParaRPr lang="en-US" altLang="zh-CN"/>
+          </a:p>
+        </p:txBody>
+      </p:sp>
+      <p:sp>
+        <p:nvSpPr>
+          <p:cNvPr id="3" name="副标题 2"/>
+          <p:cNvSpPr>
+            <a:spLocks noGrp="1"/>
+          </p:cNvSpPr>
+          <p:nvPr>
+            <p:ph type="subTitle" idx="1"/>
+          </p:nvPr>
+        </p:nvSpPr>
+        <p:spPr/>
+        <p:txBody>
+          <a:bodyPr/>
+          <a:p>
+            <a:endParaRPr lang="zh-CN" altLang="en-US"/>
+          </a:p>
+        </p:txBody>
+      </p:sp>
+    </p:spTree>
+  </p:cSld>
+  <p:clrMapOvr>
+    <a:masterClrMapping/>
+  </p:clrMapOvr>
+</p:sld>
+</file>
+
 <file path=ppt/tags/tag1.xml><?xml version="1.0" encoding="utf-8"?>
 <p:tagLst xmlns:p="http://schemas.openxmlformats.org/presentationml/2006/main">
   <p:tag name="KSO_WM_BEAUTIFY_FLAG" val=""/>
@@ -11073,13 +12141,127 @@
 </p:tagLst>
 </file>
 
+<file path=ppt/tags/tag102.xml><?xml version="1.0" encoding="utf-8"?>
+<p:tagLst xmlns:p="http://schemas.openxmlformats.org/presentationml/2006/main">
+  <p:tag name="KSO_WM_BEAUTIFY_FLAG" val=""/>
+</p:tagLst>
+</file>
+
+<file path=ppt/tags/tag103.xml><?xml version="1.0" encoding="utf-8"?>
+<p:tagLst xmlns:p="http://schemas.openxmlformats.org/presentationml/2006/main">
+  <p:tag name="KSO_WM_BEAUTIFY_FLAG" val=""/>
+</p:tagLst>
+</file>
+
+<file path=ppt/tags/tag104.xml><?xml version="1.0" encoding="utf-8"?>
+<p:tagLst xmlns:p="http://schemas.openxmlformats.org/presentationml/2006/main">
+  <p:tag name="KSO_WM_BEAUTIFY_FLAG" val=""/>
+</p:tagLst>
+</file>
+
+<file path=ppt/tags/tag105.xml><?xml version="1.0" encoding="utf-8"?>
+<p:tagLst xmlns:p="http://schemas.openxmlformats.org/presentationml/2006/main">
+  <p:tag name="KSO_WM_BEAUTIFY_FLAG" val=""/>
+</p:tagLst>
+</file>
+
+<file path=ppt/tags/tag106.xml><?xml version="1.0" encoding="utf-8"?>
+<p:tagLst xmlns:p="http://schemas.openxmlformats.org/presentationml/2006/main">
+  <p:tag name="KSO_WM_BEAUTIFY_FLAG" val=""/>
+</p:tagLst>
+</file>
+
+<file path=ppt/tags/tag107.xml><?xml version="1.0" encoding="utf-8"?>
+<p:tagLst xmlns:p="http://schemas.openxmlformats.org/presentationml/2006/main">
+  <p:tag name="KSO_WM_BEAUTIFY_FLAG" val=""/>
+</p:tagLst>
+</file>
+
+<file path=ppt/tags/tag108.xml><?xml version="1.0" encoding="utf-8"?>
+<p:tagLst xmlns:p="http://schemas.openxmlformats.org/presentationml/2006/main">
+  <p:tag name="KSO_WM_BEAUTIFY_FLAG" val=""/>
+</p:tagLst>
+</file>
+
+<file path=ppt/tags/tag109.xml><?xml version="1.0" encoding="utf-8"?>
+<p:tagLst xmlns:p="http://schemas.openxmlformats.org/presentationml/2006/main">
+  <p:tag name="KSO_WM_BEAUTIFY_FLAG" val=""/>
+</p:tagLst>
+</file>
+
 <file path=ppt/tags/tag11.xml><?xml version="1.0" encoding="utf-8"?>
 <p:tagLst xmlns:p="http://schemas.openxmlformats.org/presentationml/2006/main">
   <p:tag name="KSO_WM_BEAUTIFY_FLAG" val=""/>
 </p:tagLst>
 </file>
 
+<file path=ppt/tags/tag110.xml><?xml version="1.0" encoding="utf-8"?>
+<p:tagLst xmlns:p="http://schemas.openxmlformats.org/presentationml/2006/main">
+  <p:tag name="KSO_WM_BEAUTIFY_FLAG" val=""/>
+</p:tagLst>
+</file>
+
+<file path=ppt/tags/tag111.xml><?xml version="1.0" encoding="utf-8"?>
+<p:tagLst xmlns:p="http://schemas.openxmlformats.org/presentationml/2006/main">
+  <p:tag name="KSO_WM_BEAUTIFY_FLAG" val=""/>
+</p:tagLst>
+</file>
+
+<file path=ppt/tags/tag112.xml><?xml version="1.0" encoding="utf-8"?>
+<p:tagLst xmlns:p="http://schemas.openxmlformats.org/presentationml/2006/main">
+  <p:tag name="KSO_WM_BEAUTIFY_FLAG" val=""/>
+</p:tagLst>
+</file>
+
+<file path=ppt/tags/tag113.xml><?xml version="1.0" encoding="utf-8"?>
+<p:tagLst xmlns:p="http://schemas.openxmlformats.org/presentationml/2006/main">
+  <p:tag name="KSO_WM_BEAUTIFY_FLAG" val=""/>
+</p:tagLst>
+</file>
+
+<file path=ppt/tags/tag114.xml><?xml version="1.0" encoding="utf-8"?>
+<p:tagLst xmlns:p="http://schemas.openxmlformats.org/presentationml/2006/main">
+  <p:tag name="KSO_WM_BEAUTIFY_FLAG" val=""/>
+</p:tagLst>
+</file>
+
+<file path=ppt/tags/tag115.xml><?xml version="1.0" encoding="utf-8"?>
+<p:tagLst xmlns:p="http://schemas.openxmlformats.org/presentationml/2006/main">
+  <p:tag name="KSO_WM_BEAUTIFY_FLAG" val=""/>
+</p:tagLst>
+</file>
+
+<file path=ppt/tags/tag116.xml><?xml version="1.0" encoding="utf-8"?>
+<p:tagLst xmlns:p="http://schemas.openxmlformats.org/presentationml/2006/main">
+  <p:tag name="KSO_WM_BEAUTIFY_FLAG" val=""/>
+</p:tagLst>
+</file>
+
+<file path=ppt/tags/tag117.xml><?xml version="1.0" encoding="utf-8"?>
+<p:tagLst xmlns:p="http://schemas.openxmlformats.org/presentationml/2006/main">
+  <p:tag name="KSO_WM_BEAUTIFY_FLAG" val=""/>
+</p:tagLst>
+</file>
+
+<file path=ppt/tags/tag118.xml><?xml version="1.0" encoding="utf-8"?>
+<p:tagLst xmlns:p="http://schemas.openxmlformats.org/presentationml/2006/main">
+  <p:tag name="KSO_WM_BEAUTIFY_FLAG" val=""/>
+</p:tagLst>
+</file>
+
+<file path=ppt/tags/tag119.xml><?xml version="1.0" encoding="utf-8"?>
+<p:tagLst xmlns:p="http://schemas.openxmlformats.org/presentationml/2006/main">
+  <p:tag name="KSO_WM_BEAUTIFY_FLAG" val=""/>
+</p:tagLst>
+</file>
+
 <file path=ppt/tags/tag12.xml><?xml version="1.0" encoding="utf-8"?>
+<p:tagLst xmlns:p="http://schemas.openxmlformats.org/presentationml/2006/main">
+  <p:tag name="KSO_WM_BEAUTIFY_FLAG" val=""/>
+</p:tagLst>
+</file>
+
+<file path=ppt/tags/tag120.xml><?xml version="1.0" encoding="utf-8"?>
 <p:tagLst xmlns:p="http://schemas.openxmlformats.org/presentationml/2006/main">
   <p:tag name="KSO_WM_BEAUTIFY_FLAG" val=""/>
 </p:tagLst>

</xml_diff>

<commit_message>
update_Generative Pretraining from Pixels
</commit_message>
<xml_diff>
--- a/Base_Model/GAN+VAE+Diffusion/论文作图.pptx
+++ b/Base_Model/GAN+VAE+Diffusion/论文作图.pptx
@@ -8,7 +8,7 @@
     <p:notesMasterId r:id="rId4"/>
   </p:notesMasterIdLst>
   <p:handoutMasterIdLst>
-    <p:handoutMasterId r:id="rId14"/>
+    <p:handoutMasterId r:id="rId18"/>
   </p:handoutMasterIdLst>
   <p:sldIdLst>
     <p:sldId id="256" r:id="rId3"/>
@@ -21,6 +21,10 @@
     <p:sldId id="263" r:id="rId11"/>
     <p:sldId id="265" r:id="rId12"/>
     <p:sldId id="266" r:id="rId13"/>
+    <p:sldId id="267" r:id="rId14"/>
+    <p:sldId id="268" r:id="rId15"/>
+    <p:sldId id="269" r:id="rId16"/>
+    <p:sldId id="270" r:id="rId17"/>
   </p:sldIdLst>
   <p:sldSz cx="12192000" cy="6858000"/>
   <p:notesSz cx="7103745" cy="10234295"/>
@@ -4391,6 +4395,1101 @@
 </p:sld>
 </file>
 
+<file path=ppt/slides/slide11.xml><?xml version="1.0" encoding="utf-8"?>
+<p:sld xmlns:a="http://schemas.openxmlformats.org/drawingml/2006/main" xmlns:r="http://schemas.openxmlformats.org/officeDocument/2006/relationships" xmlns:p="http://schemas.openxmlformats.org/presentationml/2006/main">
+  <p:cSld>
+    <p:spTree>
+      <p:nvGrpSpPr>
+        <p:cNvPr id="1" name=""/>
+        <p:cNvGrpSpPr/>
+        <p:nvPr/>
+      </p:nvGrpSpPr>
+      <p:grpSpPr/>
+      <p:sp>
+        <p:nvSpPr>
+          <p:cNvPr id="2" name="标题 1"/>
+          <p:cNvSpPr>
+            <a:spLocks noGrp="1"/>
+          </p:cNvSpPr>
+          <p:nvPr>
+            <p:ph type="ctrTitle"/>
+          </p:nvPr>
+        </p:nvSpPr>
+        <p:spPr/>
+        <p:txBody>
+          <a:bodyPr/>
+          <a:p>
+            <a:r>
+              <a:rPr lang="en-US" altLang="zh-CN"/>
+              <a:t>DALL·</a:t>
+            </a:r>
+            <a:r>
+              <a:rPr lang="en-US" altLang="zh-CN"/>
+              <a:t>E</a:t>
+            </a:r>
+            <a:endParaRPr lang="en-US" altLang="zh-CN"/>
+          </a:p>
+        </p:txBody>
+      </p:sp>
+      <p:sp>
+        <p:nvSpPr>
+          <p:cNvPr id="3" name="副标题 2"/>
+          <p:cNvSpPr>
+            <a:spLocks noGrp="1"/>
+          </p:cNvSpPr>
+          <p:nvPr>
+            <p:ph type="subTitle" idx="1"/>
+          </p:nvPr>
+        </p:nvSpPr>
+        <p:spPr/>
+        <p:txBody>
+          <a:bodyPr/>
+          <a:p>
+            <a:endParaRPr lang="zh-CN" altLang="en-US"/>
+          </a:p>
+        </p:txBody>
+      </p:sp>
+    </p:spTree>
+  </p:cSld>
+  <p:clrMapOvr>
+    <a:masterClrMapping/>
+  </p:clrMapOvr>
+</p:sld>
+</file>
+
+<file path=ppt/slides/slide12.xml><?xml version="1.0" encoding="utf-8"?>
+<p:sld xmlns:a="http://schemas.openxmlformats.org/drawingml/2006/main" xmlns:r="http://schemas.openxmlformats.org/officeDocument/2006/relationships" xmlns:p="http://schemas.openxmlformats.org/presentationml/2006/main">
+  <p:cSld>
+    <p:spTree>
+      <p:nvGrpSpPr>
+        <p:cNvPr id="1" name=""/>
+        <p:cNvGrpSpPr/>
+        <p:nvPr/>
+      </p:nvGrpSpPr>
+      <p:grpSpPr/>
+      <p:pic>
+        <p:nvPicPr>
+          <p:cNvPr id="4" name="图片 3"/>
+          <p:cNvPicPr>
+            <a:picLocks noChangeAspect="1"/>
+          </p:cNvPicPr>
+          <p:nvPr>
+            <p:custDataLst>
+              <p:tags r:id="rId1"/>
+            </p:custDataLst>
+          </p:nvPr>
+        </p:nvPicPr>
+        <p:blipFill>
+          <a:blip r:embed="rId2"/>
+          <a:stretch>
+            <a:fillRect/>
+          </a:stretch>
+        </p:blipFill>
+        <p:spPr>
+          <a:xfrm>
+            <a:off x="263525" y="280035"/>
+            <a:ext cx="4869180" cy="2821305"/>
+          </a:xfrm>
+          <a:prstGeom prst="rect">
+            <a:avLst/>
+          </a:prstGeom>
+        </p:spPr>
+      </p:pic>
+      <p:sp>
+        <p:nvSpPr>
+          <p:cNvPr id="13" name="文本框 12"/>
+          <p:cNvSpPr txBox="1"/>
+          <p:nvPr>
+            <p:custDataLst>
+              <p:tags r:id="rId3"/>
+            </p:custDataLst>
+          </p:nvPr>
+        </p:nvSpPr>
+        <p:spPr>
+          <a:xfrm>
+            <a:off x="967105" y="3261995"/>
+            <a:ext cx="2908300" cy="334010"/>
+          </a:xfrm>
+          <a:prstGeom prst="rect">
+            <a:avLst/>
+          </a:prstGeom>
+          <a:noFill/>
+        </p:spPr>
+        <p:txBody>
+          <a:bodyPr wrap="square" rtlCol="0">
+            <a:noAutofit/>
+          </a:bodyPr>
+          <a:p>
+            <a:pPr algn="ctr"/>
+            <a:r>
+              <a:rPr lang="zh-CN" altLang="en-US" sz="1200" b="1">
+                <a:latin typeface="微软雅黑" charset="0"/>
+                <a:ea typeface="微软雅黑" charset="0"/>
+                <a:cs typeface="微软雅黑" charset="0"/>
+              </a:rPr>
+              <a:t>将图像拆分成</a:t>
+            </a:r>
+            <a:r>
+              <a:rPr lang="en-US" altLang="zh-CN" sz="1200" b="1">
+                <a:latin typeface="微软雅黑" charset="0"/>
+                <a:ea typeface="微软雅黑" charset="0"/>
+                <a:cs typeface="微软雅黑" charset="0"/>
+              </a:rPr>
+              <a:t>patch</a:t>
+            </a:r>
+            <a:r>
+              <a:rPr lang="zh-CN" altLang="en-US" sz="1200" b="1">
+                <a:latin typeface="微软雅黑" charset="0"/>
+                <a:ea typeface="微软雅黑" charset="0"/>
+                <a:cs typeface="微软雅黑" charset="0"/>
+              </a:rPr>
+              <a:t>，每个</a:t>
+            </a:r>
+            <a:r>
+              <a:rPr lang="en-US" altLang="zh-CN" sz="1200" b="1">
+                <a:latin typeface="微软雅黑" charset="0"/>
+                <a:ea typeface="微软雅黑" charset="0"/>
+                <a:cs typeface="微软雅黑" charset="0"/>
+              </a:rPr>
+              <a:t>patch</a:t>
+            </a:r>
+            <a:r>
+              <a:rPr lang="zh-CN" altLang="en-US" sz="1200" b="1">
+                <a:latin typeface="微软雅黑" charset="0"/>
+                <a:ea typeface="微软雅黑" charset="0"/>
+                <a:cs typeface="微软雅黑" charset="0"/>
+              </a:rPr>
+              <a:t>根据概率选取最大可能性的潜变量作为</a:t>
+            </a:r>
+            <a:r>
+              <a:rPr lang="zh-CN" altLang="en-US" sz="1200" b="1">
+                <a:latin typeface="微软雅黑" charset="0"/>
+                <a:ea typeface="微软雅黑" charset="0"/>
+                <a:cs typeface="微软雅黑" charset="0"/>
+              </a:rPr>
+              <a:t>输出</a:t>
+            </a:r>
+            <a:endParaRPr lang="zh-CN" altLang="en-US" sz="1200" b="1">
+              <a:latin typeface="微软雅黑" charset="0"/>
+              <a:ea typeface="微软雅黑" charset="0"/>
+              <a:cs typeface="微软雅黑" charset="0"/>
+            </a:endParaRPr>
+          </a:p>
+        </p:txBody>
+      </p:sp>
+      <p:sp>
+        <p:nvSpPr>
+          <p:cNvPr id="5" name="文本框 4"/>
+          <p:cNvSpPr txBox="1"/>
+          <p:nvPr>
+            <p:custDataLst>
+              <p:tags r:id="rId4"/>
+            </p:custDataLst>
+          </p:nvPr>
+        </p:nvSpPr>
+        <p:spPr>
+          <a:xfrm>
+            <a:off x="4777105" y="1483995"/>
+            <a:ext cx="2908300" cy="334010"/>
+          </a:xfrm>
+          <a:prstGeom prst="rect">
+            <a:avLst/>
+          </a:prstGeom>
+          <a:noFill/>
+        </p:spPr>
+        <p:txBody>
+          <a:bodyPr wrap="square" rtlCol="0">
+            <a:noAutofit/>
+          </a:bodyPr>
+          <a:p>
+            <a:pPr algn="ctr"/>
+            <a:r>
+              <a:rPr lang="zh-CN" altLang="en-US" sz="1200" b="1">
+                <a:latin typeface="微软雅黑" charset="0"/>
+                <a:ea typeface="微软雅黑" charset="0"/>
+                <a:cs typeface="微软雅黑" charset="0"/>
+              </a:rPr>
+              <a:t>将图像映射为潜变量</a:t>
+            </a:r>
+            <a:r>
+              <a:rPr lang="zh-CN" altLang="en-US" sz="1200" b="1">
+                <a:latin typeface="微软雅黑" charset="0"/>
+                <a:ea typeface="微软雅黑" charset="0"/>
+                <a:cs typeface="微软雅黑" charset="0"/>
+              </a:rPr>
+              <a:t>序列</a:t>
+            </a:r>
+            <a:endParaRPr lang="zh-CN" altLang="en-US" sz="1200" b="1">
+              <a:latin typeface="微软雅黑" charset="0"/>
+              <a:ea typeface="微软雅黑" charset="0"/>
+              <a:cs typeface="微软雅黑" charset="0"/>
+            </a:endParaRPr>
+          </a:p>
+          <a:p>
+            <a:pPr algn="ctr"/>
+            <a:r>
+              <a:rPr lang="en-US" altLang="zh-CN" sz="1200" b="1">
+                <a:latin typeface="微软雅黑" charset="0"/>
+                <a:ea typeface="微软雅黑" charset="0"/>
+                <a:cs typeface="微软雅黑" charset="0"/>
+              </a:rPr>
+              <a:t>0-&gt;6-&gt;4-&gt;...-&gt;8</a:t>
+            </a:r>
+            <a:endParaRPr lang="en-US" altLang="zh-CN" sz="1200" b="1">
+              <a:latin typeface="微软雅黑" charset="0"/>
+              <a:ea typeface="微软雅黑" charset="0"/>
+              <a:cs typeface="微软雅黑" charset="0"/>
+            </a:endParaRPr>
+          </a:p>
+        </p:txBody>
+      </p:sp>
+      <p:pic>
+        <p:nvPicPr>
+          <p:cNvPr id="6" name="图片 5"/>
+          <p:cNvPicPr>
+            <a:picLocks noChangeAspect="1"/>
+          </p:cNvPicPr>
+          <p:nvPr>
+            <p:custDataLst>
+              <p:tags r:id="rId5"/>
+            </p:custDataLst>
+          </p:nvPr>
+        </p:nvPicPr>
+        <p:blipFill>
+          <a:blip r:embed="rId6"/>
+          <a:stretch>
+            <a:fillRect/>
+          </a:stretch>
+        </p:blipFill>
+        <p:spPr>
+          <a:xfrm>
+            <a:off x="7221220" y="548005"/>
+            <a:ext cx="4868545" cy="2713990"/>
+          </a:xfrm>
+          <a:prstGeom prst="rect">
+            <a:avLst/>
+          </a:prstGeom>
+        </p:spPr>
+      </p:pic>
+      <p:sp>
+        <p:nvSpPr>
+          <p:cNvPr id="7" name="文本框 6"/>
+          <p:cNvSpPr txBox="1"/>
+          <p:nvPr>
+            <p:custDataLst>
+              <p:tags r:id="rId7"/>
+            </p:custDataLst>
+          </p:nvPr>
+        </p:nvSpPr>
+        <p:spPr>
+          <a:xfrm>
+            <a:off x="7825105" y="3261995"/>
+            <a:ext cx="2908300" cy="334010"/>
+          </a:xfrm>
+          <a:prstGeom prst="rect">
+            <a:avLst/>
+          </a:prstGeom>
+          <a:noFill/>
+        </p:spPr>
+        <p:txBody>
+          <a:bodyPr wrap="square" rtlCol="0">
+            <a:noAutofit/>
+          </a:bodyPr>
+          <a:p>
+            <a:pPr algn="ctr"/>
+            <a:r>
+              <a:rPr lang="zh-CN" altLang="en-US" sz="1200" b="1">
+                <a:latin typeface="微软雅黑" charset="0"/>
+                <a:ea typeface="微软雅黑" charset="0"/>
+                <a:cs typeface="微软雅黑" charset="0"/>
+              </a:rPr>
+              <a:t>生成时根据自回归模型，生成一个全新的</a:t>
+            </a:r>
+            <a:r>
+              <a:rPr lang="zh-CN" altLang="en-US" sz="1200" b="1">
+                <a:latin typeface="微软雅黑" charset="0"/>
+                <a:ea typeface="微软雅黑" charset="0"/>
+                <a:cs typeface="微软雅黑" charset="0"/>
+              </a:rPr>
+              <a:t>潜空间序列拼成</a:t>
+            </a:r>
+            <a:r>
+              <a:rPr lang="zh-CN" altLang="en-US" sz="1200" b="1">
+                <a:latin typeface="微软雅黑" charset="0"/>
+                <a:ea typeface="微软雅黑" charset="0"/>
+                <a:cs typeface="微软雅黑" charset="0"/>
+              </a:rPr>
+              <a:t>图</a:t>
+            </a:r>
+            <a:endParaRPr lang="zh-CN" altLang="en-US" sz="1200" b="1">
+              <a:latin typeface="微软雅黑" charset="0"/>
+              <a:ea typeface="微软雅黑" charset="0"/>
+              <a:cs typeface="微软雅黑" charset="0"/>
+            </a:endParaRPr>
+          </a:p>
+        </p:txBody>
+      </p:sp>
+      <p:sp>
+        <p:nvSpPr>
+          <p:cNvPr id="8" name="右箭头 7"/>
+          <p:cNvSpPr/>
+          <p:nvPr/>
+        </p:nvSpPr>
+        <p:spPr>
+          <a:xfrm>
+            <a:off x="5104130" y="1534795"/>
+            <a:ext cx="208280" cy="222250"/>
+          </a:xfrm>
+          <a:prstGeom prst="rightArrow">
+            <a:avLst/>
+          </a:prstGeom>
+        </p:spPr>
+        <p:style>
+          <a:lnRef idx="2">
+            <a:schemeClr val="accent1">
+              <a:lumMod val="75000"/>
+            </a:schemeClr>
+          </a:lnRef>
+          <a:fillRef idx="1">
+            <a:schemeClr val="accent1"/>
+          </a:fillRef>
+          <a:effectRef idx="0">
+            <a:srgbClr val="FFFFFF"/>
+          </a:effectRef>
+          <a:fontRef idx="minor">
+            <a:schemeClr val="lt1"/>
+          </a:fontRef>
+        </p:style>
+        <p:txBody>
+          <a:bodyPr rtlCol="0" anchor="ctr"/>
+          <a:p>
+            <a:pPr algn="ctr"/>
+            <a:endParaRPr lang="zh-CN" altLang="en-US"/>
+          </a:p>
+        </p:txBody>
+      </p:sp>
+      <p:sp>
+        <p:nvSpPr>
+          <p:cNvPr id="9" name="右箭头 8"/>
+          <p:cNvSpPr/>
+          <p:nvPr>
+            <p:custDataLst>
+              <p:tags r:id="rId8"/>
+            </p:custDataLst>
+          </p:nvPr>
+        </p:nvSpPr>
+        <p:spPr>
+          <a:xfrm>
+            <a:off x="7136130" y="1534795"/>
+            <a:ext cx="208280" cy="222250"/>
+          </a:xfrm>
+          <a:prstGeom prst="rightArrow">
+            <a:avLst/>
+          </a:prstGeom>
+        </p:spPr>
+        <p:style>
+          <a:lnRef idx="2">
+            <a:schemeClr val="accent1">
+              <a:lumMod val="75000"/>
+            </a:schemeClr>
+          </a:lnRef>
+          <a:fillRef idx="1">
+            <a:schemeClr val="accent1"/>
+          </a:fillRef>
+          <a:effectRef idx="0">
+            <a:srgbClr val="FFFFFF"/>
+          </a:effectRef>
+          <a:fontRef idx="minor">
+            <a:schemeClr val="lt1"/>
+          </a:fontRef>
+        </p:style>
+        <p:txBody>
+          <a:bodyPr rtlCol="0" anchor="ctr"/>
+          <a:p>
+            <a:pPr algn="ctr"/>
+            <a:endParaRPr lang="zh-CN" altLang="en-US"/>
+          </a:p>
+        </p:txBody>
+      </p:sp>
+    </p:spTree>
+  </p:cSld>
+  <p:clrMapOvr>
+    <a:masterClrMapping/>
+  </p:clrMapOvr>
+</p:sld>
+</file>
+
+<file path=ppt/slides/slide13.xml><?xml version="1.0" encoding="utf-8"?>
+<p:sld xmlns:a="http://schemas.openxmlformats.org/drawingml/2006/main" xmlns:r="http://schemas.openxmlformats.org/officeDocument/2006/relationships" xmlns:p="http://schemas.openxmlformats.org/presentationml/2006/main">
+  <p:cSld>
+    <p:spTree>
+      <p:nvGrpSpPr>
+        <p:cNvPr id="1" name=""/>
+        <p:cNvGrpSpPr/>
+        <p:nvPr/>
+      </p:nvGrpSpPr>
+      <p:grpSpPr/>
+      <p:sp>
+        <p:nvSpPr>
+          <p:cNvPr id="2" name="标题 1"/>
+          <p:cNvSpPr>
+            <a:spLocks noGrp="1"/>
+          </p:cNvSpPr>
+          <p:nvPr>
+            <p:ph type="ctrTitle"/>
+          </p:nvPr>
+        </p:nvSpPr>
+        <p:spPr/>
+        <p:txBody>
+          <a:bodyPr/>
+          <a:p>
+            <a:r>
+              <a:rPr lang="en-US" altLang="zh-CN"/>
+              <a:t>I-GPT</a:t>
+            </a:r>
+            <a:endParaRPr lang="en-US" altLang="zh-CN"/>
+          </a:p>
+        </p:txBody>
+      </p:sp>
+      <p:sp>
+        <p:nvSpPr>
+          <p:cNvPr id="3" name="副标题 2"/>
+          <p:cNvSpPr>
+            <a:spLocks noGrp="1"/>
+          </p:cNvSpPr>
+          <p:nvPr>
+            <p:ph type="subTitle" idx="1"/>
+          </p:nvPr>
+        </p:nvSpPr>
+        <p:spPr/>
+        <p:txBody>
+          <a:bodyPr/>
+          <a:p>
+            <a:endParaRPr lang="zh-CN" altLang="en-US"/>
+          </a:p>
+        </p:txBody>
+      </p:sp>
+    </p:spTree>
+  </p:cSld>
+  <p:clrMapOvr>
+    <a:masterClrMapping/>
+  </p:clrMapOvr>
+</p:sld>
+</file>
+
+<file path=ppt/slides/slide14.xml><?xml version="1.0" encoding="utf-8"?>
+<p:sld xmlns:a="http://schemas.openxmlformats.org/drawingml/2006/main" xmlns:r="http://schemas.openxmlformats.org/officeDocument/2006/relationships" xmlns:p="http://schemas.openxmlformats.org/presentationml/2006/main">
+  <p:cSld>
+    <p:spTree>
+      <p:nvGrpSpPr>
+        <p:cNvPr id="1" name=""/>
+        <p:cNvGrpSpPr/>
+        <p:nvPr/>
+      </p:nvGrpSpPr>
+      <p:grpSpPr/>
+      <p:pic>
+        <p:nvPicPr>
+          <p:cNvPr id="4" name="图片 3"/>
+          <p:cNvPicPr>
+            <a:picLocks noChangeAspect="1"/>
+          </p:cNvPicPr>
+          <p:nvPr>
+            <p:custDataLst>
+              <p:tags r:id="rId1"/>
+            </p:custDataLst>
+          </p:nvPr>
+        </p:nvPicPr>
+        <p:blipFill>
+          <a:blip r:embed="rId2"/>
+          <a:stretch>
+            <a:fillRect/>
+          </a:stretch>
+        </p:blipFill>
+        <p:spPr>
+          <a:xfrm>
+            <a:off x="0" y="151130"/>
+            <a:ext cx="3352800" cy="673100"/>
+          </a:xfrm>
+          <a:prstGeom prst="rect">
+            <a:avLst/>
+          </a:prstGeom>
+        </p:spPr>
+      </p:pic>
+      <p:sp>
+        <p:nvSpPr>
+          <p:cNvPr id="13" name="文本框 12"/>
+          <p:cNvSpPr txBox="1"/>
+          <p:nvPr>
+            <p:custDataLst>
+              <p:tags r:id="rId3"/>
+            </p:custDataLst>
+          </p:nvPr>
+        </p:nvSpPr>
+        <p:spPr>
+          <a:xfrm>
+            <a:off x="3293110" y="236855"/>
+            <a:ext cx="3713480" cy="334010"/>
+          </a:xfrm>
+          <a:prstGeom prst="rect">
+            <a:avLst/>
+          </a:prstGeom>
+          <a:noFill/>
+        </p:spPr>
+        <p:txBody>
+          <a:bodyPr wrap="square" rtlCol="0">
+            <a:noAutofit/>
+          </a:bodyPr>
+          <a:p>
+            <a:pPr algn="ctr"/>
+            <a:r>
+              <a:rPr lang="zh-CN" altLang="en-US" sz="1200" b="1">
+                <a:latin typeface="微软雅黑" charset="0"/>
+                <a:ea typeface="微软雅黑" charset="0"/>
+                <a:cs typeface="微软雅黑" charset="0"/>
+              </a:rPr>
+              <a:t>可以理解为将一个高维的图像</a:t>
+            </a:r>
+            <a:r>
+              <a:rPr lang="en-US" altLang="zh-CN" sz="1200" b="1">
+                <a:latin typeface="微软雅黑" charset="0"/>
+                <a:ea typeface="微软雅黑" charset="0"/>
+                <a:cs typeface="微软雅黑" charset="0"/>
+              </a:rPr>
+              <a:t>x</a:t>
+            </a:r>
+            <a:r>
+              <a:rPr lang="zh-CN" altLang="en-US" sz="1200" b="1">
+                <a:latin typeface="微软雅黑" charset="0"/>
+                <a:ea typeface="微软雅黑" charset="0"/>
+                <a:cs typeface="微软雅黑" charset="0"/>
+              </a:rPr>
+              <a:t>拆分成</a:t>
+            </a:r>
+            <a:r>
+              <a:rPr lang="en-US" altLang="zh-CN" sz="1200" b="1">
+                <a:latin typeface="微软雅黑" charset="0"/>
+                <a:ea typeface="微软雅黑" charset="0"/>
+                <a:cs typeface="微软雅黑" charset="0"/>
+              </a:rPr>
+              <a:t>patch</a:t>
+            </a:r>
+            <a:r>
+              <a:rPr lang="zh-CN" altLang="en-US" sz="1200" b="1">
+                <a:latin typeface="微软雅黑" charset="0"/>
+                <a:ea typeface="微软雅黑" charset="0"/>
+                <a:cs typeface="微软雅黑" charset="0"/>
+              </a:rPr>
+              <a:t>，高维图像的概率等于每个小</a:t>
+            </a:r>
+            <a:r>
+              <a:rPr lang="en-US" altLang="zh-CN" sz="1200" b="1">
+                <a:latin typeface="微软雅黑" charset="0"/>
+                <a:ea typeface="微软雅黑" charset="0"/>
+                <a:cs typeface="微软雅黑" charset="0"/>
+              </a:rPr>
+              <a:t>patch</a:t>
+            </a:r>
+            <a:r>
+              <a:rPr lang="zh-CN" altLang="en-US" sz="1200" b="1">
+                <a:latin typeface="微软雅黑" charset="0"/>
+                <a:ea typeface="微软雅黑" charset="0"/>
+                <a:cs typeface="微软雅黑" charset="0"/>
+              </a:rPr>
+              <a:t>概率的</a:t>
+            </a:r>
+            <a:r>
+              <a:rPr lang="zh-CN" altLang="en-US" sz="1200" b="1">
+                <a:latin typeface="微软雅黑" charset="0"/>
+                <a:ea typeface="微软雅黑" charset="0"/>
+                <a:cs typeface="微软雅黑" charset="0"/>
+              </a:rPr>
+              <a:t>乘积</a:t>
+            </a:r>
+            <a:endParaRPr lang="zh-CN" altLang="en-US" sz="1200" b="1">
+              <a:latin typeface="微软雅黑" charset="0"/>
+              <a:ea typeface="微软雅黑" charset="0"/>
+              <a:cs typeface="微软雅黑" charset="0"/>
+            </a:endParaRPr>
+          </a:p>
+        </p:txBody>
+      </p:sp>
+      <p:pic>
+        <p:nvPicPr>
+          <p:cNvPr id="5" name="图片 4"/>
+          <p:cNvPicPr>
+            <a:picLocks noChangeAspect="1"/>
+          </p:cNvPicPr>
+          <p:nvPr>
+            <p:custDataLst>
+              <p:tags r:id="rId4"/>
+            </p:custDataLst>
+          </p:nvPr>
+        </p:nvPicPr>
+        <p:blipFill>
+          <a:blip r:embed="rId5"/>
+          <a:stretch>
+            <a:fillRect/>
+          </a:stretch>
+        </p:blipFill>
+        <p:spPr>
+          <a:xfrm>
+            <a:off x="7054850" y="236855"/>
+            <a:ext cx="2425700" cy="520700"/>
+          </a:xfrm>
+          <a:prstGeom prst="rect">
+            <a:avLst/>
+          </a:prstGeom>
+        </p:spPr>
+      </p:pic>
+      <p:sp>
+        <p:nvSpPr>
+          <p:cNvPr id="6" name="文本框 5"/>
+          <p:cNvSpPr txBox="1"/>
+          <p:nvPr>
+            <p:custDataLst>
+              <p:tags r:id="rId6"/>
+            </p:custDataLst>
+          </p:nvPr>
+        </p:nvSpPr>
+        <p:spPr>
+          <a:xfrm>
+            <a:off x="9344660" y="109855"/>
+            <a:ext cx="2847340" cy="334010"/>
+          </a:xfrm>
+          <a:prstGeom prst="rect">
+            <a:avLst/>
+          </a:prstGeom>
+          <a:noFill/>
+        </p:spPr>
+        <p:txBody>
+          <a:bodyPr wrap="square" rtlCol="0">
+            <a:noAutofit/>
+          </a:bodyPr>
+          <a:p>
+            <a:pPr algn="ctr"/>
+            <a:r>
+              <a:rPr lang="zh-CN" altLang="en-US" sz="1200" b="1">
+                <a:latin typeface="微软雅黑" charset="0"/>
+                <a:ea typeface="微软雅黑" charset="0"/>
+                <a:cs typeface="微软雅黑" charset="0"/>
+              </a:rPr>
+              <a:t>最小化负对数似然损失来优化模型</a:t>
+            </a:r>
+            <a:br>
+              <a:rPr lang="zh-CN" altLang="en-US" sz="1200" b="1">
+                <a:latin typeface="微软雅黑" charset="0"/>
+                <a:ea typeface="微软雅黑" charset="0"/>
+                <a:cs typeface="微软雅黑" charset="0"/>
+              </a:rPr>
+            </a:br>
+            <a:r>
+              <a:rPr lang="zh-CN" altLang="en-US" sz="1200" b="1">
+                <a:latin typeface="微软雅黑" charset="0"/>
+                <a:ea typeface="微软雅黑" charset="0"/>
+                <a:cs typeface="微软雅黑" charset="0"/>
+              </a:rPr>
+              <a:t>让模型生成整个图像的序列概率</a:t>
+            </a:r>
+            <a:r>
+              <a:rPr lang="zh-CN" altLang="en-US" sz="1200" b="1">
+                <a:latin typeface="微软雅黑" charset="0"/>
+                <a:ea typeface="微软雅黑" charset="0"/>
+                <a:cs typeface="微软雅黑" charset="0"/>
+              </a:rPr>
+              <a:t>最大化</a:t>
+            </a:r>
+            <a:br>
+              <a:rPr lang="zh-CN" altLang="en-US" sz="1200" b="1">
+                <a:latin typeface="微软雅黑" charset="0"/>
+                <a:ea typeface="微软雅黑" charset="0"/>
+                <a:cs typeface="微软雅黑" charset="0"/>
+              </a:rPr>
+            </a:br>
+            <a:r>
+              <a:rPr lang="zh-CN" altLang="en-US" sz="1200" b="1">
+                <a:latin typeface="微软雅黑" charset="0"/>
+                <a:ea typeface="微软雅黑" charset="0"/>
+                <a:cs typeface="微软雅黑" charset="0"/>
+              </a:rPr>
+              <a:t>我们这里的优化不是让恢复的图像靠近原图，而是让生成图像的patch序列拟合原图patch的序列</a:t>
+            </a:r>
+            <a:endParaRPr lang="zh-CN" altLang="en-US" sz="1200" b="1">
+              <a:latin typeface="微软雅黑" charset="0"/>
+              <a:ea typeface="微软雅黑" charset="0"/>
+              <a:cs typeface="微软雅黑" charset="0"/>
+            </a:endParaRPr>
+          </a:p>
+        </p:txBody>
+      </p:sp>
+      <p:pic>
+        <p:nvPicPr>
+          <p:cNvPr id="7" name="图片 6"/>
+          <p:cNvPicPr>
+            <a:picLocks noChangeAspect="1"/>
+          </p:cNvPicPr>
+          <p:nvPr>
+            <p:custDataLst>
+              <p:tags r:id="rId7"/>
+            </p:custDataLst>
+          </p:nvPr>
+        </p:nvPicPr>
+        <p:blipFill>
+          <a:blip r:embed="rId8"/>
+          <a:stretch>
+            <a:fillRect/>
+          </a:stretch>
+        </p:blipFill>
+        <p:spPr>
+          <a:xfrm>
+            <a:off x="0" y="1421130"/>
+            <a:ext cx="4305300" cy="685800"/>
+          </a:xfrm>
+          <a:prstGeom prst="rect">
+            <a:avLst/>
+          </a:prstGeom>
+        </p:spPr>
+      </p:pic>
+      <p:sp>
+        <p:nvSpPr>
+          <p:cNvPr id="8" name="文本框 7"/>
+          <p:cNvSpPr txBox="1"/>
+          <p:nvPr>
+            <p:custDataLst>
+              <p:tags r:id="rId9"/>
+            </p:custDataLst>
+          </p:nvPr>
+        </p:nvSpPr>
+        <p:spPr>
+          <a:xfrm>
+            <a:off x="4563110" y="1506855"/>
+            <a:ext cx="7125970" cy="334010"/>
+          </a:xfrm>
+          <a:prstGeom prst="rect">
+            <a:avLst/>
+          </a:prstGeom>
+          <a:noFill/>
+        </p:spPr>
+        <p:txBody>
+          <a:bodyPr wrap="square" rtlCol="0">
+            <a:noAutofit/>
+          </a:bodyPr>
+          <a:p>
+            <a:pPr algn="ctr"/>
+            <a:r>
+              <a:rPr sz="1200" b="1">
+                <a:latin typeface="微软雅黑" charset="0"/>
+                <a:ea typeface="微软雅黑" charset="0"/>
+                <a:cs typeface="微软雅黑" charset="0"/>
+              </a:rPr>
+              <a:t>随机 mask 出一部分 patch ，然后训练模型去预测被 mask 的 patch </a:t>
+            </a:r>
+            <a:br>
+              <a:rPr sz="1200" b="1">
+                <a:latin typeface="微软雅黑" charset="0"/>
+                <a:ea typeface="微软雅黑" charset="0"/>
+                <a:cs typeface="微软雅黑" charset="0"/>
+              </a:rPr>
+            </a:br>
+            <a:r>
+              <a:rPr sz="1200" b="1">
+                <a:latin typeface="微软雅黑" charset="0"/>
+                <a:ea typeface="微软雅黑" charset="0"/>
+                <a:cs typeface="微软雅黑" charset="0"/>
+              </a:rPr>
+              <a:t>让模型在看到部分信息的情况下，去补全被 mask 掉的部分 patch，从而学到更丰富、更全面的图像潜在分布信息。</a:t>
+            </a:r>
+            <a:endParaRPr sz="1200" b="1">
+              <a:latin typeface="微软雅黑" charset="0"/>
+              <a:ea typeface="微软雅黑" charset="0"/>
+              <a:cs typeface="微软雅黑" charset="0"/>
+            </a:endParaRPr>
+          </a:p>
+        </p:txBody>
+      </p:sp>
+      <p:pic>
+        <p:nvPicPr>
+          <p:cNvPr id="9" name="图片 8"/>
+          <p:cNvPicPr>
+            <a:picLocks noChangeAspect="1"/>
+          </p:cNvPicPr>
+          <p:nvPr>
+            <p:custDataLst>
+              <p:tags r:id="rId10"/>
+            </p:custDataLst>
+          </p:nvPr>
+        </p:nvPicPr>
+        <p:blipFill>
+          <a:blip r:embed="rId11"/>
+          <a:stretch>
+            <a:fillRect/>
+          </a:stretch>
+        </p:blipFill>
+        <p:spPr>
+          <a:xfrm>
+            <a:off x="1444625" y="3867785"/>
+            <a:ext cx="9785985" cy="2529840"/>
+          </a:xfrm>
+          <a:prstGeom prst="rect">
+            <a:avLst/>
+          </a:prstGeom>
+        </p:spPr>
+      </p:pic>
+      <p:sp>
+        <p:nvSpPr>
+          <p:cNvPr id="10" name="文本框 9"/>
+          <p:cNvSpPr txBox="1"/>
+          <p:nvPr>
+            <p:custDataLst>
+              <p:tags r:id="rId12"/>
+            </p:custDataLst>
+          </p:nvPr>
+        </p:nvSpPr>
+        <p:spPr>
+          <a:xfrm>
+            <a:off x="-252730" y="4617085"/>
+            <a:ext cx="2672715" cy="334010"/>
+          </a:xfrm>
+          <a:prstGeom prst="rect">
+            <a:avLst/>
+          </a:prstGeom>
+          <a:noFill/>
+        </p:spPr>
+        <p:txBody>
+          <a:bodyPr wrap="square" rtlCol="0">
+            <a:noAutofit/>
+          </a:bodyPr>
+          <a:p>
+            <a:pPr algn="ctr"/>
+            <a:r>
+              <a:rPr lang="zh-CN" sz="1200" b="1">
+                <a:latin typeface="微软雅黑" charset="0"/>
+                <a:ea typeface="微软雅黑" charset="0"/>
+                <a:cs typeface="微软雅黑" charset="0"/>
+              </a:rPr>
+              <a:t>将图像转化为较低</a:t>
+            </a:r>
+            <a:r>
+              <a:rPr lang="zh-CN" sz="1200" b="1">
+                <a:latin typeface="微软雅黑" charset="0"/>
+                <a:ea typeface="微软雅黑" charset="0"/>
+                <a:cs typeface="微软雅黑" charset="0"/>
+              </a:rPr>
+              <a:t>分辨率</a:t>
+            </a:r>
+            <a:endParaRPr lang="zh-CN" sz="1200" b="1">
+              <a:latin typeface="微软雅黑" charset="0"/>
+              <a:ea typeface="微软雅黑" charset="0"/>
+              <a:cs typeface="微软雅黑" charset="0"/>
+            </a:endParaRPr>
+          </a:p>
+        </p:txBody>
+      </p:sp>
+      <p:sp>
+        <p:nvSpPr>
+          <p:cNvPr id="11" name="文本框 10"/>
+          <p:cNvSpPr txBox="1"/>
+          <p:nvPr>
+            <p:custDataLst>
+              <p:tags r:id="rId13"/>
+            </p:custDataLst>
+          </p:nvPr>
+        </p:nvSpPr>
+        <p:spPr>
+          <a:xfrm>
+            <a:off x="-252730" y="5633085"/>
+            <a:ext cx="2672715" cy="334010"/>
+          </a:xfrm>
+          <a:prstGeom prst="rect">
+            <a:avLst/>
+          </a:prstGeom>
+          <a:noFill/>
+        </p:spPr>
+        <p:txBody>
+          <a:bodyPr wrap="square" rtlCol="0">
+            <a:noAutofit/>
+          </a:bodyPr>
+          <a:p>
+            <a:pPr algn="ctr"/>
+            <a:r>
+              <a:rPr lang="zh-CN" sz="1200" b="1">
+                <a:latin typeface="微软雅黑" charset="0"/>
+                <a:ea typeface="微软雅黑" charset="0"/>
+                <a:cs typeface="微软雅黑" charset="0"/>
+              </a:rPr>
+              <a:t>将低分辨率图像转化为一维</a:t>
+            </a:r>
+            <a:r>
+              <a:rPr lang="zh-CN" sz="1200" b="1">
+                <a:latin typeface="微软雅黑" charset="0"/>
+                <a:ea typeface="微软雅黑" charset="0"/>
+                <a:cs typeface="微软雅黑" charset="0"/>
+              </a:rPr>
+              <a:t>序列</a:t>
+            </a:r>
+            <a:endParaRPr lang="zh-CN" sz="1200" b="1">
+              <a:latin typeface="微软雅黑" charset="0"/>
+              <a:ea typeface="微软雅黑" charset="0"/>
+              <a:cs typeface="微软雅黑" charset="0"/>
+            </a:endParaRPr>
+          </a:p>
+        </p:txBody>
+      </p:sp>
+      <p:sp>
+        <p:nvSpPr>
+          <p:cNvPr id="12" name="文本框 11"/>
+          <p:cNvSpPr txBox="1"/>
+          <p:nvPr>
+            <p:custDataLst>
+              <p:tags r:id="rId14"/>
+            </p:custDataLst>
+          </p:nvPr>
+        </p:nvSpPr>
+        <p:spPr>
+          <a:xfrm>
+            <a:off x="3904615" y="3601085"/>
+            <a:ext cx="1978660" cy="520700"/>
+          </a:xfrm>
+          <a:prstGeom prst="rect">
+            <a:avLst/>
+          </a:prstGeom>
+          <a:noFill/>
+        </p:spPr>
+        <p:txBody>
+          <a:bodyPr wrap="square" rtlCol="0">
+            <a:noAutofit/>
+          </a:bodyPr>
+          <a:p>
+            <a:pPr algn="ctr"/>
+            <a:r>
+              <a:rPr lang="zh-CN" sz="1200" b="1">
+                <a:latin typeface="微软雅黑" charset="0"/>
+                <a:ea typeface="微软雅黑" charset="0"/>
+                <a:cs typeface="微软雅黑" charset="0"/>
+              </a:rPr>
+              <a:t>让模型预测</a:t>
+            </a:r>
+            <a:r>
+              <a:rPr lang="en-US" altLang="zh-CN" sz="1200" b="1">
+                <a:latin typeface="微软雅黑" charset="0"/>
+                <a:ea typeface="微软雅黑" charset="0"/>
+                <a:cs typeface="微软雅黑" charset="0"/>
+              </a:rPr>
+              <a:t>patch</a:t>
+            </a:r>
+            <a:r>
+              <a:rPr lang="zh-CN" altLang="en-US" sz="1200" b="1">
+                <a:latin typeface="微软雅黑" charset="0"/>
+                <a:ea typeface="微软雅黑" charset="0"/>
+                <a:cs typeface="微软雅黑" charset="0"/>
+              </a:rPr>
+              <a:t>序列，与初始序列进行对比</a:t>
+            </a:r>
+            <a:r>
+              <a:rPr lang="zh-CN" altLang="en-US" sz="1200" b="1">
+                <a:latin typeface="微软雅黑" charset="0"/>
+                <a:ea typeface="微软雅黑" charset="0"/>
+                <a:cs typeface="微软雅黑" charset="0"/>
+              </a:rPr>
+              <a:t>优化</a:t>
+            </a:r>
+            <a:endParaRPr lang="zh-CN" altLang="en-US" sz="1200" b="1">
+              <a:latin typeface="微软雅黑" charset="0"/>
+              <a:ea typeface="微软雅黑" charset="0"/>
+              <a:cs typeface="微软雅黑" charset="0"/>
+            </a:endParaRPr>
+          </a:p>
+        </p:txBody>
+      </p:sp>
+      <p:sp>
+        <p:nvSpPr>
+          <p:cNvPr id="14" name="文本框 13"/>
+          <p:cNvSpPr txBox="1"/>
+          <p:nvPr>
+            <p:custDataLst>
+              <p:tags r:id="rId15"/>
+            </p:custDataLst>
+          </p:nvPr>
+        </p:nvSpPr>
+        <p:spPr>
+          <a:xfrm>
+            <a:off x="6090920" y="3601085"/>
+            <a:ext cx="1924050" cy="520700"/>
+          </a:xfrm>
+          <a:prstGeom prst="rect">
+            <a:avLst/>
+          </a:prstGeom>
+          <a:noFill/>
+        </p:spPr>
+        <p:txBody>
+          <a:bodyPr wrap="square" rtlCol="0">
+            <a:noAutofit/>
+          </a:bodyPr>
+          <a:p>
+            <a:pPr algn="ctr"/>
+            <a:r>
+              <a:rPr lang="zh-CN" altLang="en-US" sz="1200" b="1">
+                <a:latin typeface="微软雅黑" charset="0"/>
+                <a:ea typeface="微软雅黑" charset="0"/>
+                <a:cs typeface="微软雅黑" charset="0"/>
+              </a:rPr>
+              <a:t>输入</a:t>
+            </a:r>
+            <a:r>
+              <a:rPr lang="en-US" altLang="zh-CN" sz="1200" b="1">
+                <a:latin typeface="微软雅黑" charset="0"/>
+                <a:ea typeface="微软雅黑" charset="0"/>
+                <a:cs typeface="微软雅黑" charset="0"/>
+              </a:rPr>
+              <a:t>mask</a:t>
+            </a:r>
+            <a:r>
+              <a:rPr lang="zh-CN" altLang="en-US" sz="1200" b="1">
+                <a:latin typeface="微软雅黑" charset="0"/>
+                <a:ea typeface="微软雅黑" charset="0"/>
+                <a:cs typeface="微软雅黑" charset="0"/>
+              </a:rPr>
+              <a:t>后的序列，让模型预测被</a:t>
+            </a:r>
+            <a:r>
+              <a:rPr lang="en-US" altLang="zh-CN" sz="1200" b="1">
+                <a:latin typeface="微软雅黑" charset="0"/>
+                <a:ea typeface="微软雅黑" charset="0"/>
+                <a:cs typeface="微软雅黑" charset="0"/>
+              </a:rPr>
+              <a:t>mask</a:t>
+            </a:r>
+            <a:r>
+              <a:rPr lang="zh-CN" altLang="en-US" sz="1200" b="1">
+                <a:latin typeface="微软雅黑" charset="0"/>
+                <a:ea typeface="微软雅黑" charset="0"/>
+                <a:cs typeface="微软雅黑" charset="0"/>
+              </a:rPr>
+              <a:t>的</a:t>
+            </a:r>
+            <a:r>
+              <a:rPr lang="zh-CN" altLang="en-US" sz="1200" b="1">
+                <a:latin typeface="微软雅黑" charset="0"/>
+                <a:ea typeface="微软雅黑" charset="0"/>
+                <a:cs typeface="微软雅黑" charset="0"/>
+              </a:rPr>
+              <a:t>序列</a:t>
+            </a:r>
+            <a:endParaRPr lang="zh-CN" altLang="en-US" sz="1200" b="1">
+              <a:latin typeface="微软雅黑" charset="0"/>
+              <a:ea typeface="微软雅黑" charset="0"/>
+              <a:cs typeface="微软雅黑" charset="0"/>
+            </a:endParaRPr>
+          </a:p>
+        </p:txBody>
+      </p:sp>
+    </p:spTree>
+  </p:cSld>
+  <p:clrMapOvr>
+    <a:masterClrMapping/>
+  </p:clrMapOvr>
+</p:sld>
+</file>
+
 <file path=ppt/slides/slide2.xml><?xml version="1.0" encoding="utf-8"?>
 <p:sld xmlns:a="http://schemas.openxmlformats.org/drawingml/2006/main" xmlns:r="http://schemas.openxmlformats.org/officeDocument/2006/relationships" xmlns:p="http://schemas.openxmlformats.org/presentationml/2006/main">
   <p:cSld>
@@ -12267,7 +13366,109 @@
 </p:tagLst>
 </file>
 
+<file path=ppt/tags/tag121.xml><?xml version="1.0" encoding="utf-8"?>
+<p:tagLst xmlns:p="http://schemas.openxmlformats.org/presentationml/2006/main">
+  <p:tag name="KSO_WM_BEAUTIFY_FLAG" val=""/>
+</p:tagLst>
+</file>
+
+<file path=ppt/tags/tag122.xml><?xml version="1.0" encoding="utf-8"?>
+<p:tagLst xmlns:p="http://schemas.openxmlformats.org/presentationml/2006/main">
+  <p:tag name="KSO_WM_BEAUTIFY_FLAG" val=""/>
+</p:tagLst>
+</file>
+
+<file path=ppt/tags/tag123.xml><?xml version="1.0" encoding="utf-8"?>
+<p:tagLst xmlns:p="http://schemas.openxmlformats.org/presentationml/2006/main">
+  <p:tag name="KSO_WM_BEAUTIFY_FLAG" val=""/>
+</p:tagLst>
+</file>
+
+<file path=ppt/tags/tag124.xml><?xml version="1.0" encoding="utf-8"?>
+<p:tagLst xmlns:p="http://schemas.openxmlformats.org/presentationml/2006/main">
+  <p:tag name="KSO_WM_BEAUTIFY_FLAG" val=""/>
+</p:tagLst>
+</file>
+
+<file path=ppt/tags/tag125.xml><?xml version="1.0" encoding="utf-8"?>
+<p:tagLst xmlns:p="http://schemas.openxmlformats.org/presentationml/2006/main">
+  <p:tag name="KSO_WM_BEAUTIFY_FLAG" val=""/>
+</p:tagLst>
+</file>
+
+<file path=ppt/tags/tag126.xml><?xml version="1.0" encoding="utf-8"?>
+<p:tagLst xmlns:p="http://schemas.openxmlformats.org/presentationml/2006/main">
+  <p:tag name="KSO_WM_BEAUTIFY_FLAG" val=""/>
+</p:tagLst>
+</file>
+
+<file path=ppt/tags/tag127.xml><?xml version="1.0" encoding="utf-8"?>
+<p:tagLst xmlns:p="http://schemas.openxmlformats.org/presentationml/2006/main">
+  <p:tag name="KSO_WM_BEAUTIFY_FLAG" val=""/>
+</p:tagLst>
+</file>
+
+<file path=ppt/tags/tag128.xml><?xml version="1.0" encoding="utf-8"?>
+<p:tagLst xmlns:p="http://schemas.openxmlformats.org/presentationml/2006/main">
+  <p:tag name="KSO_WM_BEAUTIFY_FLAG" val=""/>
+</p:tagLst>
+</file>
+
+<file path=ppt/tags/tag129.xml><?xml version="1.0" encoding="utf-8"?>
+<p:tagLst xmlns:p="http://schemas.openxmlformats.org/presentationml/2006/main">
+  <p:tag name="KSO_WM_BEAUTIFY_FLAG" val=""/>
+</p:tagLst>
+</file>
+
 <file path=ppt/tags/tag13.xml><?xml version="1.0" encoding="utf-8"?>
+<p:tagLst xmlns:p="http://schemas.openxmlformats.org/presentationml/2006/main">
+  <p:tag name="KSO_WM_BEAUTIFY_FLAG" val=""/>
+</p:tagLst>
+</file>
+
+<file path=ppt/tags/tag130.xml><?xml version="1.0" encoding="utf-8"?>
+<p:tagLst xmlns:p="http://schemas.openxmlformats.org/presentationml/2006/main">
+  <p:tag name="KSO_WM_BEAUTIFY_FLAG" val=""/>
+</p:tagLst>
+</file>
+
+<file path=ppt/tags/tag131.xml><?xml version="1.0" encoding="utf-8"?>
+<p:tagLst xmlns:p="http://schemas.openxmlformats.org/presentationml/2006/main">
+  <p:tag name="KSO_WM_BEAUTIFY_FLAG" val=""/>
+</p:tagLst>
+</file>
+
+<file path=ppt/tags/tag132.xml><?xml version="1.0" encoding="utf-8"?>
+<p:tagLst xmlns:p="http://schemas.openxmlformats.org/presentationml/2006/main">
+  <p:tag name="KSO_WM_BEAUTIFY_FLAG" val=""/>
+</p:tagLst>
+</file>
+
+<file path=ppt/tags/tag133.xml><?xml version="1.0" encoding="utf-8"?>
+<p:tagLst xmlns:p="http://schemas.openxmlformats.org/presentationml/2006/main">
+  <p:tag name="KSO_WM_BEAUTIFY_FLAG" val=""/>
+</p:tagLst>
+</file>
+
+<file path=ppt/tags/tag134.xml><?xml version="1.0" encoding="utf-8"?>
+<p:tagLst xmlns:p="http://schemas.openxmlformats.org/presentationml/2006/main">
+  <p:tag name="KSO_WM_BEAUTIFY_FLAG" val=""/>
+</p:tagLst>
+</file>
+
+<file path=ppt/tags/tag135.xml><?xml version="1.0" encoding="utf-8"?>
+<p:tagLst xmlns:p="http://schemas.openxmlformats.org/presentationml/2006/main">
+  <p:tag name="KSO_WM_BEAUTIFY_FLAG" val=""/>
+</p:tagLst>
+</file>
+
+<file path=ppt/tags/tag136.xml><?xml version="1.0" encoding="utf-8"?>
+<p:tagLst xmlns:p="http://schemas.openxmlformats.org/presentationml/2006/main">
+  <p:tag name="KSO_WM_BEAUTIFY_FLAG" val=""/>
+</p:tagLst>
+</file>
+
+<file path=ppt/tags/tag137.xml><?xml version="1.0" encoding="utf-8"?>
 <p:tagLst xmlns:p="http://schemas.openxmlformats.org/presentationml/2006/main">
   <p:tag name="KSO_WM_BEAUTIFY_FLAG" val=""/>
 </p:tagLst>

</xml_diff>

<commit_message>
update_Deep Unsupervised Learning using Nonequilibrium Thermodynamics
</commit_message>
<xml_diff>
--- a/Base_Model/GAN+VAE+Diffusion/论文作图.pptx
+++ b/Base_Model/GAN+VAE+Diffusion/论文作图.pptx
@@ -8,7 +8,7 @@
     <p:notesMasterId r:id="rId4"/>
   </p:notesMasterIdLst>
   <p:handoutMasterIdLst>
-    <p:handoutMasterId r:id="rId18"/>
+    <p:handoutMasterId r:id="rId20"/>
   </p:handoutMasterIdLst>
   <p:sldIdLst>
     <p:sldId id="256" r:id="rId3"/>
@@ -25,6 +25,8 @@
     <p:sldId id="268" r:id="rId15"/>
     <p:sldId id="269" r:id="rId16"/>
     <p:sldId id="270" r:id="rId17"/>
+    <p:sldId id="271" r:id="rId18"/>
+    <p:sldId id="272" r:id="rId19"/>
   </p:sldIdLst>
   <p:sldSz cx="12192000" cy="6858000"/>
   <p:notesSz cx="7103745" cy="10234295"/>
@@ -7204,6 +7206,930 @@
 </p:sld>
 </file>
 
+<file path=ppt/slides/slide15.xml><?xml version="1.0" encoding="utf-8"?>
+<p:sld xmlns:a="http://schemas.openxmlformats.org/drawingml/2006/main" xmlns:r="http://schemas.openxmlformats.org/officeDocument/2006/relationships" xmlns:p="http://schemas.openxmlformats.org/presentationml/2006/main">
+  <p:cSld>
+    <p:spTree>
+      <p:nvGrpSpPr>
+        <p:cNvPr id="1" name=""/>
+        <p:cNvGrpSpPr/>
+        <p:nvPr/>
+      </p:nvGrpSpPr>
+      <p:grpSpPr/>
+      <p:sp>
+        <p:nvSpPr>
+          <p:cNvPr id="2" name="标题 1"/>
+          <p:cNvSpPr>
+            <a:spLocks noGrp="1"/>
+          </p:cNvSpPr>
+          <p:nvPr>
+            <p:ph type="ctrTitle"/>
+          </p:nvPr>
+        </p:nvSpPr>
+        <p:spPr/>
+        <p:txBody>
+          <a:bodyPr/>
+          <a:p>
+            <a:r>
+              <a:rPr lang="en-US" altLang="zh-CN"/>
+              <a:t>Diffusion </a:t>
+            </a:r>
+            <a:r>
+              <a:rPr lang="en-US" altLang="zh-CN"/>
+              <a:t>Model</a:t>
+            </a:r>
+            <a:endParaRPr lang="en-US" altLang="zh-CN"/>
+          </a:p>
+        </p:txBody>
+      </p:sp>
+      <p:sp>
+        <p:nvSpPr>
+          <p:cNvPr id="3" name="副标题 2"/>
+          <p:cNvSpPr>
+            <a:spLocks noGrp="1"/>
+          </p:cNvSpPr>
+          <p:nvPr>
+            <p:ph type="subTitle" idx="1"/>
+          </p:nvPr>
+        </p:nvSpPr>
+        <p:spPr/>
+        <p:txBody>
+          <a:bodyPr/>
+          <a:p>
+            <a:endParaRPr lang="zh-CN" altLang="en-US"/>
+          </a:p>
+        </p:txBody>
+      </p:sp>
+    </p:spTree>
+  </p:cSld>
+  <p:clrMapOvr>
+    <a:masterClrMapping/>
+  </p:clrMapOvr>
+</p:sld>
+</file>
+
+<file path=ppt/slides/slide16.xml><?xml version="1.0" encoding="utf-8"?>
+<p:sld xmlns:a="http://schemas.openxmlformats.org/drawingml/2006/main" xmlns:r="http://schemas.openxmlformats.org/officeDocument/2006/relationships" xmlns:p="http://schemas.openxmlformats.org/presentationml/2006/main">
+  <p:cSld>
+    <p:spTree>
+      <p:nvGrpSpPr>
+        <p:cNvPr id="1" name=""/>
+        <p:cNvGrpSpPr/>
+        <p:nvPr/>
+      </p:nvGrpSpPr>
+      <p:grpSpPr/>
+      <p:pic>
+        <p:nvPicPr>
+          <p:cNvPr id="5" name="图片 4"/>
+          <p:cNvPicPr>
+            <a:picLocks noChangeAspect="1"/>
+          </p:cNvPicPr>
+          <p:nvPr>
+            <p:custDataLst>
+              <p:tags r:id="rId1"/>
+            </p:custDataLst>
+          </p:nvPr>
+        </p:nvPicPr>
+        <p:blipFill>
+          <a:blip r:embed="rId2"/>
+          <a:stretch>
+            <a:fillRect/>
+          </a:stretch>
+        </p:blipFill>
+        <p:spPr>
+          <a:xfrm>
+            <a:off x="3779520" y="0"/>
+            <a:ext cx="4410710" cy="3221990"/>
+          </a:xfrm>
+          <a:prstGeom prst="rect">
+            <a:avLst/>
+          </a:prstGeom>
+        </p:spPr>
+      </p:pic>
+      <p:pic>
+        <p:nvPicPr>
+          <p:cNvPr id="6" name="图片 5"/>
+          <p:cNvPicPr>
+            <a:picLocks noChangeAspect="1"/>
+          </p:cNvPicPr>
+          <p:nvPr>
+            <p:custDataLst>
+              <p:tags r:id="rId3"/>
+            </p:custDataLst>
+          </p:nvPr>
+        </p:nvPicPr>
+        <p:blipFill>
+          <a:blip r:embed="rId4"/>
+          <a:stretch>
+            <a:fillRect/>
+          </a:stretch>
+        </p:blipFill>
+        <p:spPr>
+          <a:xfrm>
+            <a:off x="0" y="3818890"/>
+            <a:ext cx="3067685" cy="689610"/>
+          </a:xfrm>
+          <a:prstGeom prst="rect">
+            <a:avLst/>
+          </a:prstGeom>
+        </p:spPr>
+      </p:pic>
+      <p:sp>
+        <p:nvSpPr>
+          <p:cNvPr id="10" name="文本框 9"/>
+          <p:cNvSpPr txBox="1"/>
+          <p:nvPr>
+            <p:custDataLst>
+              <p:tags r:id="rId5"/>
+            </p:custDataLst>
+          </p:nvPr>
+        </p:nvSpPr>
+        <p:spPr>
+          <a:xfrm>
+            <a:off x="0" y="3357880"/>
+            <a:ext cx="3459480" cy="334010"/>
+          </a:xfrm>
+          <a:prstGeom prst="rect">
+            <a:avLst/>
+          </a:prstGeom>
+          <a:noFill/>
+        </p:spPr>
+        <p:txBody>
+          <a:bodyPr wrap="square" rtlCol="0">
+            <a:noAutofit/>
+          </a:bodyPr>
+          <a:p>
+            <a:pPr algn="ctr"/>
+            <a:r>
+              <a:rPr lang="zh-CN" sz="1200" b="1">
+                <a:latin typeface="微软雅黑" charset="0"/>
+                <a:ea typeface="微软雅黑" charset="0"/>
+                <a:cs typeface="微软雅黑" charset="0"/>
+              </a:rPr>
+              <a:t>初始图像通过相同的加噪一步一步变成高斯分布</a:t>
+            </a:r>
+            <a:br>
+              <a:rPr lang="zh-CN" sz="1200" b="1">
+                <a:latin typeface="微软雅黑" charset="0"/>
+                <a:ea typeface="微软雅黑" charset="0"/>
+                <a:cs typeface="微软雅黑" charset="0"/>
+              </a:rPr>
+            </a:br>
+            <a:r>
+              <a:rPr lang="zh-CN" sz="1200" b="1">
+                <a:latin typeface="微软雅黑" charset="0"/>
+                <a:ea typeface="微软雅黑" charset="0"/>
+                <a:cs typeface="微软雅黑" charset="0"/>
+              </a:rPr>
+              <a:t>𝛽</a:t>
+            </a:r>
+            <a:r>
+              <a:rPr lang="en-US" altLang="zh-CN" sz="1200" b="1">
+                <a:latin typeface="微软雅黑" charset="0"/>
+                <a:ea typeface="微软雅黑" charset="0"/>
+                <a:cs typeface="微软雅黑" charset="0"/>
+              </a:rPr>
+              <a:t> </a:t>
+            </a:r>
+            <a:r>
+              <a:rPr lang="zh-CN" altLang="en-US" sz="1200" b="1">
+                <a:latin typeface="微软雅黑" charset="0"/>
+                <a:ea typeface="微软雅黑" charset="0"/>
+                <a:cs typeface="微软雅黑" charset="0"/>
+              </a:rPr>
+              <a:t>为步长，</a:t>
+            </a:r>
+            <a:r>
+              <a:rPr lang="zh-CN" altLang="en-US" sz="1200" b="1">
+                <a:latin typeface="微软雅黑" charset="0"/>
+                <a:ea typeface="微软雅黑" charset="0"/>
+                <a:cs typeface="微软雅黑" charset="0"/>
+              </a:rPr>
+              <a:t>可调节</a:t>
+            </a:r>
+            <a:endParaRPr lang="zh-CN" altLang="en-US" sz="1200" b="1">
+              <a:latin typeface="微软雅黑" charset="0"/>
+              <a:ea typeface="微软雅黑" charset="0"/>
+              <a:cs typeface="微软雅黑" charset="0"/>
+            </a:endParaRPr>
+          </a:p>
+        </p:txBody>
+      </p:sp>
+      <p:pic>
+        <p:nvPicPr>
+          <p:cNvPr id="7" name="图片 6"/>
+          <p:cNvPicPr>
+            <a:picLocks noChangeAspect="1"/>
+          </p:cNvPicPr>
+          <p:nvPr>
+            <p:custDataLst>
+              <p:tags r:id="rId6"/>
+            </p:custDataLst>
+          </p:nvPr>
+        </p:nvPicPr>
+        <p:blipFill>
+          <a:blip r:embed="rId7"/>
+          <a:stretch>
+            <a:fillRect/>
+          </a:stretch>
+        </p:blipFill>
+        <p:spPr>
+          <a:xfrm>
+            <a:off x="0" y="5347970"/>
+            <a:ext cx="3459480" cy="737870"/>
+          </a:xfrm>
+          <a:prstGeom prst="rect">
+            <a:avLst/>
+          </a:prstGeom>
+        </p:spPr>
+      </p:pic>
+      <p:sp>
+        <p:nvSpPr>
+          <p:cNvPr id="8" name="文本框 7"/>
+          <p:cNvSpPr txBox="1"/>
+          <p:nvPr>
+            <p:custDataLst>
+              <p:tags r:id="rId8"/>
+            </p:custDataLst>
+          </p:nvPr>
+        </p:nvSpPr>
+        <p:spPr>
+          <a:xfrm>
+            <a:off x="0" y="5008880"/>
+            <a:ext cx="3459480" cy="334010"/>
+          </a:xfrm>
+          <a:prstGeom prst="rect">
+            <a:avLst/>
+          </a:prstGeom>
+          <a:noFill/>
+        </p:spPr>
+        <p:txBody>
+          <a:bodyPr wrap="square" rtlCol="0">
+            <a:noAutofit/>
+          </a:bodyPr>
+          <a:p>
+            <a:pPr algn="ctr"/>
+            <a:r>
+              <a:rPr lang="zh-CN" altLang="en-US" sz="1200" b="1">
+                <a:latin typeface="微软雅黑" charset="0"/>
+                <a:ea typeface="微软雅黑" charset="0"/>
+                <a:cs typeface="微软雅黑" charset="0"/>
+              </a:rPr>
+              <a:t>当前步的概率等于初始的图像连乘加噪条件</a:t>
+            </a:r>
+            <a:r>
+              <a:rPr lang="zh-CN" altLang="en-US" sz="1200" b="1">
+                <a:latin typeface="微软雅黑" charset="0"/>
+                <a:ea typeface="微软雅黑" charset="0"/>
+                <a:cs typeface="微软雅黑" charset="0"/>
+              </a:rPr>
+              <a:t>概率</a:t>
+            </a:r>
+            <a:endParaRPr lang="zh-CN" altLang="en-US" sz="1200" b="1">
+              <a:latin typeface="微软雅黑" charset="0"/>
+              <a:ea typeface="微软雅黑" charset="0"/>
+              <a:cs typeface="微软雅黑" charset="0"/>
+            </a:endParaRPr>
+          </a:p>
+        </p:txBody>
+      </p:sp>
+      <p:pic>
+        <p:nvPicPr>
+          <p:cNvPr id="9" name="图片 8"/>
+          <p:cNvPicPr>
+            <a:picLocks noChangeAspect="1"/>
+          </p:cNvPicPr>
+          <p:nvPr>
+            <p:custDataLst>
+              <p:tags r:id="rId9"/>
+            </p:custDataLst>
+          </p:nvPr>
+        </p:nvPicPr>
+        <p:blipFill>
+          <a:blip r:embed="rId10"/>
+          <a:stretch>
+            <a:fillRect/>
+          </a:stretch>
+        </p:blipFill>
+        <p:spPr>
+          <a:xfrm>
+            <a:off x="8808085" y="3945890"/>
+            <a:ext cx="2928620" cy="743585"/>
+          </a:xfrm>
+          <a:prstGeom prst="rect">
+            <a:avLst/>
+          </a:prstGeom>
+        </p:spPr>
+      </p:pic>
+      <p:sp>
+        <p:nvSpPr>
+          <p:cNvPr id="11" name="文本框 10"/>
+          <p:cNvSpPr txBox="1"/>
+          <p:nvPr>
+            <p:custDataLst>
+              <p:tags r:id="rId11"/>
+            </p:custDataLst>
+          </p:nvPr>
+        </p:nvSpPr>
+        <p:spPr>
+          <a:xfrm>
+            <a:off x="8636000" y="3357880"/>
+            <a:ext cx="3459480" cy="334010"/>
+          </a:xfrm>
+          <a:prstGeom prst="rect">
+            <a:avLst/>
+          </a:prstGeom>
+          <a:noFill/>
+        </p:spPr>
+        <p:txBody>
+          <a:bodyPr wrap="square" rtlCol="0">
+            <a:noAutofit/>
+          </a:bodyPr>
+          <a:p>
+            <a:pPr algn="ctr"/>
+            <a:r>
+              <a:rPr lang="zh-CN" altLang="en-US" sz="1200" b="1">
+                <a:latin typeface="微软雅黑" charset="0"/>
+                <a:ea typeface="微软雅黑" charset="0"/>
+                <a:cs typeface="微软雅黑" charset="0"/>
+              </a:rPr>
+              <a:t>将高斯噪声分布作为初始概率分布额</a:t>
+            </a:r>
+            <a:br>
+              <a:rPr lang="zh-CN" altLang="en-US" sz="1200" b="1">
+                <a:latin typeface="微软雅黑" charset="0"/>
+                <a:ea typeface="微软雅黑" charset="0"/>
+                <a:cs typeface="微软雅黑" charset="0"/>
+              </a:rPr>
+            </a:br>
+            <a:r>
+              <a:rPr lang="zh-CN" altLang="en-US" sz="1200" b="1">
+                <a:latin typeface="微软雅黑" charset="0"/>
+                <a:ea typeface="微软雅黑" charset="0"/>
+                <a:cs typeface="微软雅黑" charset="0"/>
+              </a:rPr>
+              <a:t>逆马尔科夫</a:t>
+            </a:r>
+            <a:r>
+              <a:rPr lang="zh-CN" altLang="en-US" sz="1200" b="1">
+                <a:latin typeface="微软雅黑" charset="0"/>
+                <a:ea typeface="微软雅黑" charset="0"/>
+                <a:cs typeface="微软雅黑" charset="0"/>
+              </a:rPr>
+              <a:t>链</a:t>
+            </a:r>
+            <a:endParaRPr lang="zh-CN" altLang="en-US" sz="1200" b="1">
+              <a:latin typeface="微软雅黑" charset="0"/>
+              <a:ea typeface="微软雅黑" charset="0"/>
+              <a:cs typeface="微软雅黑" charset="0"/>
+            </a:endParaRPr>
+          </a:p>
+        </p:txBody>
+      </p:sp>
+      <p:pic>
+        <p:nvPicPr>
+          <p:cNvPr id="12" name="图片 11"/>
+          <p:cNvPicPr>
+            <a:picLocks noChangeAspect="1"/>
+          </p:cNvPicPr>
+          <p:nvPr>
+            <p:custDataLst>
+              <p:tags r:id="rId12"/>
+            </p:custDataLst>
+          </p:nvPr>
+        </p:nvPicPr>
+        <p:blipFill>
+          <a:blip r:embed="rId13"/>
+          <a:stretch>
+            <a:fillRect/>
+          </a:stretch>
+        </p:blipFill>
+        <p:spPr>
+          <a:xfrm>
+            <a:off x="4596130" y="3495040"/>
+            <a:ext cx="3251200" cy="1513840"/>
+          </a:xfrm>
+          <a:prstGeom prst="rect">
+            <a:avLst/>
+          </a:prstGeom>
+        </p:spPr>
+      </p:pic>
+      <p:pic>
+        <p:nvPicPr>
+          <p:cNvPr id="13" name="图片 12"/>
+          <p:cNvPicPr>
+            <a:picLocks noChangeAspect="1"/>
+          </p:cNvPicPr>
+          <p:nvPr>
+            <p:custDataLst>
+              <p:tags r:id="rId14"/>
+            </p:custDataLst>
+          </p:nvPr>
+        </p:nvPicPr>
+        <p:blipFill>
+          <a:blip r:embed="rId15"/>
+          <a:stretch>
+            <a:fillRect/>
+          </a:stretch>
+        </p:blipFill>
+        <p:spPr>
+          <a:xfrm>
+            <a:off x="4431030" y="5528945"/>
+            <a:ext cx="3492500" cy="812800"/>
+          </a:xfrm>
+          <a:prstGeom prst="rect">
+            <a:avLst/>
+          </a:prstGeom>
+        </p:spPr>
+      </p:pic>
+      <p:sp>
+        <p:nvSpPr>
+          <p:cNvPr id="14" name="文本框 13"/>
+          <p:cNvSpPr txBox="1"/>
+          <p:nvPr>
+            <p:custDataLst>
+              <p:tags r:id="rId16"/>
+            </p:custDataLst>
+          </p:nvPr>
+        </p:nvSpPr>
+        <p:spPr>
+          <a:xfrm>
+            <a:off x="4572000" y="3103880"/>
+            <a:ext cx="3459480" cy="334010"/>
+          </a:xfrm>
+          <a:prstGeom prst="rect">
+            <a:avLst/>
+          </a:prstGeom>
+          <a:noFill/>
+        </p:spPr>
+        <p:txBody>
+          <a:bodyPr wrap="square" rtlCol="0">
+            <a:noAutofit/>
+          </a:bodyPr>
+          <a:p>
+            <a:pPr algn="ctr"/>
+            <a:r>
+              <a:rPr lang="zh-CN" altLang="en-US" sz="1200" b="1">
+                <a:latin typeface="微软雅黑" charset="0"/>
+                <a:ea typeface="微软雅黑" charset="0"/>
+                <a:cs typeface="微软雅黑" charset="0"/>
+              </a:rPr>
+              <a:t>第一项</a:t>
+            </a:r>
+            <a:r>
+              <a:rPr lang="en-US" altLang="zh-CN" sz="1200" b="1">
+                <a:latin typeface="微软雅黑" charset="0"/>
+                <a:ea typeface="微软雅黑" charset="0"/>
+                <a:cs typeface="微软雅黑" charset="0"/>
+              </a:rPr>
+              <a:t>KL</a:t>
+            </a:r>
+            <a:r>
+              <a:rPr lang="zh-CN" altLang="en-US" sz="1200" b="1">
+                <a:latin typeface="微软雅黑" charset="0"/>
+                <a:ea typeface="微软雅黑" charset="0"/>
+                <a:cs typeface="微软雅黑" charset="0"/>
+              </a:rPr>
+              <a:t>散度</a:t>
+            </a:r>
+            <a:br>
+              <a:rPr lang="zh-CN" altLang="en-US" sz="1200" b="1">
+                <a:latin typeface="微软雅黑" charset="0"/>
+                <a:ea typeface="微软雅黑" charset="0"/>
+                <a:cs typeface="微软雅黑" charset="0"/>
+              </a:rPr>
+            </a:br>
+            <a:r>
+              <a:rPr lang="zh-CN" altLang="en-US" sz="1200" b="1">
+                <a:latin typeface="微软雅黑" charset="0"/>
+                <a:ea typeface="微软雅黑" charset="0"/>
+                <a:cs typeface="微软雅黑" charset="0"/>
+              </a:rPr>
+              <a:t>用神经网络计算的每一步概率拟合正向过程每一步的</a:t>
+            </a:r>
+            <a:r>
+              <a:rPr lang="zh-CN" altLang="en-US" sz="1200" b="1">
+                <a:latin typeface="微软雅黑" charset="0"/>
+                <a:ea typeface="微软雅黑" charset="0"/>
+                <a:cs typeface="微软雅黑" charset="0"/>
+              </a:rPr>
+              <a:t>后验概率</a:t>
+            </a:r>
+            <a:endParaRPr lang="zh-CN" altLang="en-US" sz="1200" b="1">
+              <a:latin typeface="微软雅黑" charset="0"/>
+              <a:ea typeface="微软雅黑" charset="0"/>
+              <a:cs typeface="微软雅黑" charset="0"/>
+            </a:endParaRPr>
+          </a:p>
+        </p:txBody>
+      </p:sp>
+      <p:sp>
+        <p:nvSpPr>
+          <p:cNvPr id="15" name="文本框 14"/>
+          <p:cNvSpPr txBox="1"/>
+          <p:nvPr>
+            <p:custDataLst>
+              <p:tags r:id="rId17"/>
+            </p:custDataLst>
+          </p:nvPr>
+        </p:nvSpPr>
+        <p:spPr>
+          <a:xfrm>
+            <a:off x="4572000" y="4881880"/>
+            <a:ext cx="3459480" cy="334010"/>
+          </a:xfrm>
+          <a:prstGeom prst="rect">
+            <a:avLst/>
+          </a:prstGeom>
+          <a:noFill/>
+        </p:spPr>
+        <p:txBody>
+          <a:bodyPr wrap="square" rtlCol="0">
+            <a:noAutofit/>
+          </a:bodyPr>
+          <a:p>
+            <a:pPr algn="ctr"/>
+            <a:r>
+              <a:rPr lang="zh-CN" altLang="en-US" sz="1200" b="1">
+                <a:latin typeface="微软雅黑" charset="0"/>
+                <a:ea typeface="微软雅黑" charset="0"/>
+                <a:cs typeface="微软雅黑" charset="0"/>
+              </a:rPr>
+              <a:t>第二项熵项</a:t>
+            </a:r>
+            <a:br>
+              <a:rPr lang="zh-CN" altLang="en-US" sz="1200" b="1">
+                <a:latin typeface="微软雅黑" charset="0"/>
+                <a:ea typeface="微软雅黑" charset="0"/>
+                <a:cs typeface="微软雅黑" charset="0"/>
+              </a:rPr>
+            </a:br>
+            <a:r>
+              <a:rPr lang="zh-CN" altLang="en-US" sz="1200" b="1">
+                <a:latin typeface="微软雅黑" charset="0"/>
+                <a:ea typeface="微软雅黑" charset="0"/>
+                <a:cs typeface="微软雅黑" charset="0"/>
+              </a:rPr>
+              <a:t>不参与学习，主要用于配平</a:t>
+            </a:r>
+            <a:r>
+              <a:rPr lang="zh-CN" altLang="en-US" sz="1200" b="1">
+                <a:latin typeface="微软雅黑" charset="0"/>
+                <a:ea typeface="微软雅黑" charset="0"/>
+                <a:cs typeface="微软雅黑" charset="0"/>
+              </a:rPr>
+              <a:t>公式</a:t>
+            </a:r>
+            <a:endParaRPr lang="zh-CN" altLang="en-US" sz="1200" b="1">
+              <a:latin typeface="微软雅黑" charset="0"/>
+              <a:ea typeface="微软雅黑" charset="0"/>
+              <a:cs typeface="微软雅黑" charset="0"/>
+            </a:endParaRPr>
+          </a:p>
+        </p:txBody>
+      </p:sp>
+      <p:sp>
+        <p:nvSpPr>
+          <p:cNvPr id="16" name="文本框 15"/>
+          <p:cNvSpPr txBox="1"/>
+          <p:nvPr>
+            <p:custDataLst>
+              <p:tags r:id="rId18"/>
+            </p:custDataLst>
+          </p:nvPr>
+        </p:nvSpPr>
+        <p:spPr>
+          <a:xfrm>
+            <a:off x="4572000" y="6278880"/>
+            <a:ext cx="3459480" cy="334010"/>
+          </a:xfrm>
+          <a:prstGeom prst="rect">
+            <a:avLst/>
+          </a:prstGeom>
+          <a:noFill/>
+        </p:spPr>
+        <p:txBody>
+          <a:bodyPr wrap="square" rtlCol="0">
+            <a:noAutofit/>
+          </a:bodyPr>
+          <a:p>
+            <a:pPr algn="ctr"/>
+            <a:r>
+              <a:rPr lang="zh-CN" altLang="en-US" sz="1200" b="1">
+                <a:latin typeface="微软雅黑" charset="0"/>
+                <a:ea typeface="微软雅黑" charset="0"/>
+                <a:cs typeface="微软雅黑" charset="0"/>
+              </a:rPr>
+              <a:t>反向过程的每一步最大化</a:t>
+            </a:r>
+            <a:r>
+              <a:rPr lang="en-US" altLang="zh-CN" sz="1200" b="1">
+                <a:latin typeface="微软雅黑" charset="0"/>
+                <a:ea typeface="微软雅黑" charset="0"/>
+                <a:cs typeface="微软雅黑" charset="0"/>
+              </a:rPr>
+              <a:t>K</a:t>
+            </a:r>
+            <a:endParaRPr lang="en-US" altLang="zh-CN" sz="1200" b="1">
+              <a:latin typeface="微软雅黑" charset="0"/>
+              <a:ea typeface="微软雅黑" charset="0"/>
+              <a:cs typeface="微软雅黑" charset="0"/>
+            </a:endParaRPr>
+          </a:p>
+        </p:txBody>
+      </p:sp>
+      <p:sp>
+        <p:nvSpPr>
+          <p:cNvPr id="38" name="矩形: 圆角 36"/>
+          <p:cNvSpPr/>
+          <p:nvPr>
+            <p:custDataLst>
+              <p:tags r:id="rId19"/>
+            </p:custDataLst>
+          </p:nvPr>
+        </p:nvSpPr>
+        <p:spPr>
+          <a:xfrm rot="10800000" flipV="1">
+            <a:off x="635" y="3221990"/>
+            <a:ext cx="3458845" cy="3546475"/>
+          </a:xfrm>
+          <a:prstGeom prst="roundRect">
+            <a:avLst>
+              <a:gd name="adj" fmla="val 10039"/>
+            </a:avLst>
+          </a:prstGeom>
+          <a:noFill/>
+          <a:ln w="38100">
+            <a:solidFill>
+              <a:schemeClr val="tx1"/>
+            </a:solidFill>
+            <a:prstDash val="lgDash"/>
+          </a:ln>
+        </p:spPr>
+        <p:style>
+          <a:lnRef idx="2">
+            <a:schemeClr val="accent1">
+              <a:shade val="15000"/>
+            </a:schemeClr>
+          </a:lnRef>
+          <a:fillRef idx="1">
+            <a:schemeClr val="accent1"/>
+          </a:fillRef>
+          <a:effectRef idx="0">
+            <a:schemeClr val="accent1"/>
+          </a:effectRef>
+          <a:fontRef idx="minor">
+            <a:schemeClr val="lt1"/>
+          </a:fontRef>
+        </p:style>
+        <p:txBody>
+          <a:bodyPr rtlCol="0" anchor="ctr"/>
+          <a:p>
+            <a:pPr algn="ctr"/>
+            <a:endParaRPr lang="zh-CN" altLang="en-US"/>
+          </a:p>
+        </p:txBody>
+      </p:sp>
+      <p:sp>
+        <p:nvSpPr>
+          <p:cNvPr id="17" name="矩形: 圆角 36"/>
+          <p:cNvSpPr/>
+          <p:nvPr>
+            <p:custDataLst>
+              <p:tags r:id="rId20"/>
+            </p:custDataLst>
+          </p:nvPr>
+        </p:nvSpPr>
+        <p:spPr>
+          <a:xfrm rot="10800000" flipV="1">
+            <a:off x="8636635" y="3221990"/>
+            <a:ext cx="3458845" cy="3546475"/>
+          </a:xfrm>
+          <a:prstGeom prst="roundRect">
+            <a:avLst>
+              <a:gd name="adj" fmla="val 10039"/>
+            </a:avLst>
+          </a:prstGeom>
+          <a:noFill/>
+          <a:ln w="38100">
+            <a:solidFill>
+              <a:schemeClr val="tx1"/>
+            </a:solidFill>
+            <a:prstDash val="lgDash"/>
+          </a:ln>
+        </p:spPr>
+        <p:style>
+          <a:lnRef idx="2">
+            <a:schemeClr val="accent1">
+              <a:shade val="15000"/>
+            </a:schemeClr>
+          </a:lnRef>
+          <a:fillRef idx="1">
+            <a:schemeClr val="accent1"/>
+          </a:fillRef>
+          <a:effectRef idx="0">
+            <a:schemeClr val="accent1"/>
+          </a:effectRef>
+          <a:fontRef idx="minor">
+            <a:schemeClr val="lt1"/>
+          </a:fontRef>
+        </p:style>
+        <p:txBody>
+          <a:bodyPr rtlCol="0" anchor="ctr"/>
+          <a:p>
+            <a:pPr algn="ctr"/>
+            <a:endParaRPr lang="zh-CN" altLang="en-US"/>
+          </a:p>
+        </p:txBody>
+      </p:sp>
+      <p:sp>
+        <p:nvSpPr>
+          <p:cNvPr id="18" name="矩形: 圆角 36"/>
+          <p:cNvSpPr/>
+          <p:nvPr>
+            <p:custDataLst>
+              <p:tags r:id="rId21"/>
+            </p:custDataLst>
+          </p:nvPr>
+        </p:nvSpPr>
+        <p:spPr>
+          <a:xfrm rot="10800000" flipV="1">
+            <a:off x="4699635" y="3103880"/>
+            <a:ext cx="3458845" cy="3664585"/>
+          </a:xfrm>
+          <a:prstGeom prst="roundRect">
+            <a:avLst>
+              <a:gd name="adj" fmla="val 10039"/>
+            </a:avLst>
+          </a:prstGeom>
+          <a:noFill/>
+          <a:ln w="38100">
+            <a:solidFill>
+              <a:schemeClr val="tx1"/>
+            </a:solidFill>
+            <a:prstDash val="lgDash"/>
+          </a:ln>
+        </p:spPr>
+        <p:style>
+          <a:lnRef idx="2">
+            <a:schemeClr val="accent1">
+              <a:shade val="15000"/>
+            </a:schemeClr>
+          </a:lnRef>
+          <a:fillRef idx="1">
+            <a:schemeClr val="accent1"/>
+          </a:fillRef>
+          <a:effectRef idx="0">
+            <a:schemeClr val="accent1"/>
+          </a:effectRef>
+          <a:fontRef idx="minor">
+            <a:schemeClr val="lt1"/>
+          </a:fontRef>
+        </p:style>
+        <p:txBody>
+          <a:bodyPr rtlCol="0" anchor="ctr"/>
+          <a:p>
+            <a:pPr algn="ctr"/>
+            <a:endParaRPr lang="zh-CN" altLang="en-US"/>
+          </a:p>
+        </p:txBody>
+      </p:sp>
+      <p:sp>
+        <p:nvSpPr>
+          <p:cNvPr id="19" name="文本框 18"/>
+          <p:cNvSpPr txBox="1"/>
+          <p:nvPr>
+            <p:custDataLst>
+              <p:tags r:id="rId22"/>
+            </p:custDataLst>
+          </p:nvPr>
+        </p:nvSpPr>
+        <p:spPr>
+          <a:xfrm>
+            <a:off x="0" y="6278880"/>
+            <a:ext cx="3459480" cy="334010"/>
+          </a:xfrm>
+          <a:prstGeom prst="rect">
+            <a:avLst/>
+          </a:prstGeom>
+          <a:noFill/>
+        </p:spPr>
+        <p:txBody>
+          <a:bodyPr wrap="square" rtlCol="0">
+            <a:noAutofit/>
+          </a:bodyPr>
+          <a:p>
+            <a:pPr algn="ctr"/>
+            <a:r>
+              <a:rPr lang="zh-CN" altLang="en-US" sz="2000" b="1">
+                <a:latin typeface="微软雅黑" charset="0"/>
+                <a:ea typeface="微软雅黑" charset="0"/>
+                <a:cs typeface="微软雅黑" charset="0"/>
+                <a:sym typeface="+mn-ea"/>
+              </a:rPr>
+              <a:t>正向过程</a:t>
+            </a:r>
+            <a:endParaRPr lang="zh-CN" altLang="en-US" sz="2000" b="1">
+              <a:latin typeface="微软雅黑" charset="0"/>
+              <a:ea typeface="微软雅黑" charset="0"/>
+              <a:cs typeface="微软雅黑" charset="0"/>
+            </a:endParaRPr>
+          </a:p>
+        </p:txBody>
+      </p:sp>
+      <p:sp>
+        <p:nvSpPr>
+          <p:cNvPr id="20" name="文本框 19"/>
+          <p:cNvSpPr txBox="1"/>
+          <p:nvPr>
+            <p:custDataLst>
+              <p:tags r:id="rId23"/>
+            </p:custDataLst>
+          </p:nvPr>
+        </p:nvSpPr>
+        <p:spPr>
+          <a:xfrm>
+            <a:off x="8636000" y="6278880"/>
+            <a:ext cx="3459480" cy="334010"/>
+          </a:xfrm>
+          <a:prstGeom prst="rect">
+            <a:avLst/>
+          </a:prstGeom>
+          <a:noFill/>
+        </p:spPr>
+        <p:txBody>
+          <a:bodyPr wrap="square" rtlCol="0">
+            <a:noAutofit/>
+          </a:bodyPr>
+          <a:p>
+            <a:pPr algn="ctr"/>
+            <a:r>
+              <a:rPr lang="zh-CN" altLang="en-US" sz="2000" b="1">
+                <a:latin typeface="微软雅黑" charset="0"/>
+                <a:ea typeface="微软雅黑" charset="0"/>
+                <a:cs typeface="微软雅黑" charset="0"/>
+                <a:sym typeface="+mn-ea"/>
+              </a:rPr>
+              <a:t>反向过程</a:t>
+            </a:r>
+            <a:endParaRPr lang="zh-CN" altLang="en-US" sz="2000" b="1">
+              <a:latin typeface="微软雅黑" charset="0"/>
+              <a:ea typeface="微软雅黑" charset="0"/>
+              <a:cs typeface="微软雅黑" charset="0"/>
+            </a:endParaRPr>
+          </a:p>
+        </p:txBody>
+      </p:sp>
+      <p:sp>
+        <p:nvSpPr>
+          <p:cNvPr id="21" name="文本框 20"/>
+          <p:cNvSpPr txBox="1"/>
+          <p:nvPr>
+            <p:custDataLst>
+              <p:tags r:id="rId24"/>
+            </p:custDataLst>
+          </p:nvPr>
+        </p:nvSpPr>
+        <p:spPr>
+          <a:xfrm>
+            <a:off x="4699000" y="6405880"/>
+            <a:ext cx="3459480" cy="334010"/>
+          </a:xfrm>
+          <a:prstGeom prst="rect">
+            <a:avLst/>
+          </a:prstGeom>
+          <a:noFill/>
+        </p:spPr>
+        <p:txBody>
+          <a:bodyPr wrap="square" rtlCol="0">
+            <a:noAutofit/>
+          </a:bodyPr>
+          <a:p>
+            <a:pPr algn="ctr"/>
+            <a:r>
+              <a:rPr lang="zh-CN" altLang="en-US" sz="2000" b="1">
+                <a:latin typeface="微软雅黑" charset="0"/>
+                <a:ea typeface="微软雅黑" charset="0"/>
+                <a:cs typeface="微软雅黑" charset="0"/>
+              </a:rPr>
+              <a:t>优化目标</a:t>
+            </a:r>
+            <a:endParaRPr lang="zh-CN" altLang="en-US" sz="2000" b="1">
+              <a:latin typeface="微软雅黑" charset="0"/>
+              <a:ea typeface="微软雅黑" charset="0"/>
+              <a:cs typeface="微软雅黑" charset="0"/>
+            </a:endParaRPr>
+          </a:p>
+        </p:txBody>
+      </p:sp>
+    </p:spTree>
+  </p:cSld>
+  <p:clrMapOvr>
+    <a:masterClrMapping/>
+  </p:clrMapOvr>
+</p:sld>
+</file>
+
 <file path=ppt/slides/slide2.xml><?xml version="1.0" encoding="utf-8"?>
 <p:sld xmlns:a="http://schemas.openxmlformats.org/drawingml/2006/main" xmlns:r="http://schemas.openxmlformats.org/officeDocument/2006/relationships" xmlns:p="http://schemas.openxmlformats.org/presentationml/2006/main">
   <p:cSld>
@@ -15496,13 +16422,121 @@
 </p:tagLst>
 </file>
 
+<file path=ppt/tags/tag158.xml><?xml version="1.0" encoding="utf-8"?>
+<p:tagLst xmlns:p="http://schemas.openxmlformats.org/presentationml/2006/main">
+  <p:tag name="KSO_WM_BEAUTIFY_FLAG" val=""/>
+</p:tagLst>
+</file>
+
+<file path=ppt/tags/tag159.xml><?xml version="1.0" encoding="utf-8"?>
+<p:tagLst xmlns:p="http://schemas.openxmlformats.org/presentationml/2006/main">
+  <p:tag name="KSO_WM_BEAUTIFY_FLAG" val=""/>
+</p:tagLst>
+</file>
+
 <file path=ppt/tags/tag16.xml><?xml version="1.0" encoding="utf-8"?>
 <p:tagLst xmlns:p="http://schemas.openxmlformats.org/presentationml/2006/main">
   <p:tag name="KSO_WM_BEAUTIFY_FLAG" val=""/>
 </p:tagLst>
 </file>
 
+<file path=ppt/tags/tag160.xml><?xml version="1.0" encoding="utf-8"?>
+<p:tagLst xmlns:p="http://schemas.openxmlformats.org/presentationml/2006/main">
+  <p:tag name="KSO_WM_BEAUTIFY_FLAG" val=""/>
+</p:tagLst>
+</file>
+
+<file path=ppt/tags/tag161.xml><?xml version="1.0" encoding="utf-8"?>
+<p:tagLst xmlns:p="http://schemas.openxmlformats.org/presentationml/2006/main">
+  <p:tag name="KSO_WM_BEAUTIFY_FLAG" val=""/>
+</p:tagLst>
+</file>
+
+<file path=ppt/tags/tag162.xml><?xml version="1.0" encoding="utf-8"?>
+<p:tagLst xmlns:p="http://schemas.openxmlformats.org/presentationml/2006/main">
+  <p:tag name="KSO_WM_BEAUTIFY_FLAG" val=""/>
+</p:tagLst>
+</file>
+
+<file path=ppt/tags/tag163.xml><?xml version="1.0" encoding="utf-8"?>
+<p:tagLst xmlns:p="http://schemas.openxmlformats.org/presentationml/2006/main">
+  <p:tag name="KSO_WM_BEAUTIFY_FLAG" val=""/>
+</p:tagLst>
+</file>
+
+<file path=ppt/tags/tag164.xml><?xml version="1.0" encoding="utf-8"?>
+<p:tagLst xmlns:p="http://schemas.openxmlformats.org/presentationml/2006/main">
+  <p:tag name="KSO_WM_BEAUTIFY_FLAG" val=""/>
+</p:tagLst>
+</file>
+
+<file path=ppt/tags/tag165.xml><?xml version="1.0" encoding="utf-8"?>
+<p:tagLst xmlns:p="http://schemas.openxmlformats.org/presentationml/2006/main">
+  <p:tag name="KSO_WM_BEAUTIFY_FLAG" val=""/>
+</p:tagLst>
+</file>
+
+<file path=ppt/tags/tag166.xml><?xml version="1.0" encoding="utf-8"?>
+<p:tagLst xmlns:p="http://schemas.openxmlformats.org/presentationml/2006/main">
+  <p:tag name="KSO_WM_BEAUTIFY_FLAG" val=""/>
+</p:tagLst>
+</file>
+
+<file path=ppt/tags/tag167.xml><?xml version="1.0" encoding="utf-8"?>
+<p:tagLst xmlns:p="http://schemas.openxmlformats.org/presentationml/2006/main">
+  <p:tag name="KSO_WM_BEAUTIFY_FLAG" val=""/>
+</p:tagLst>
+</file>
+
+<file path=ppt/tags/tag168.xml><?xml version="1.0" encoding="utf-8"?>
+<p:tagLst xmlns:p="http://schemas.openxmlformats.org/presentationml/2006/main">
+  <p:tag name="KSO_WM_BEAUTIFY_FLAG" val=""/>
+</p:tagLst>
+</file>
+
+<file path=ppt/tags/tag169.xml><?xml version="1.0" encoding="utf-8"?>
+<p:tagLst xmlns:p="http://schemas.openxmlformats.org/presentationml/2006/main">
+  <p:tag name="KSO_WM_BEAUTIFY_FLAG" val=""/>
+</p:tagLst>
+</file>
+
 <file path=ppt/tags/tag17.xml><?xml version="1.0" encoding="utf-8"?>
+<p:tagLst xmlns:p="http://schemas.openxmlformats.org/presentationml/2006/main">
+  <p:tag name="KSO_WM_BEAUTIFY_FLAG" val=""/>
+</p:tagLst>
+</file>
+
+<file path=ppt/tags/tag170.xml><?xml version="1.0" encoding="utf-8"?>
+<p:tagLst xmlns:p="http://schemas.openxmlformats.org/presentationml/2006/main">
+  <p:tag name="KSO_WM_BEAUTIFY_FLAG" val=""/>
+</p:tagLst>
+</file>
+
+<file path=ppt/tags/tag171.xml><?xml version="1.0" encoding="utf-8"?>
+<p:tagLst xmlns:p="http://schemas.openxmlformats.org/presentationml/2006/main">
+  <p:tag name="KSO_WM_BEAUTIFY_FLAG" val=""/>
+</p:tagLst>
+</file>
+
+<file path=ppt/tags/tag172.xml><?xml version="1.0" encoding="utf-8"?>
+<p:tagLst xmlns:p="http://schemas.openxmlformats.org/presentationml/2006/main">
+  <p:tag name="KSO_WM_BEAUTIFY_FLAG" val=""/>
+</p:tagLst>
+</file>
+
+<file path=ppt/tags/tag173.xml><?xml version="1.0" encoding="utf-8"?>
+<p:tagLst xmlns:p="http://schemas.openxmlformats.org/presentationml/2006/main">
+  <p:tag name="KSO_WM_BEAUTIFY_FLAG" val=""/>
+</p:tagLst>
+</file>
+
+<file path=ppt/tags/tag174.xml><?xml version="1.0" encoding="utf-8"?>
+<p:tagLst xmlns:p="http://schemas.openxmlformats.org/presentationml/2006/main">
+  <p:tag name="KSO_WM_BEAUTIFY_FLAG" val=""/>
+</p:tagLst>
+</file>
+
+<file path=ppt/tags/tag175.xml><?xml version="1.0" encoding="utf-8"?>
 <p:tagLst xmlns:p="http://schemas.openxmlformats.org/presentationml/2006/main">
   <p:tag name="KSO_WM_BEAUTIFY_FLAG" val=""/>
 </p:tagLst>

</xml_diff>

<commit_message>
update_Denoising Diffusion Probabilistic Models
</commit_message>
<xml_diff>
--- a/Base_Model/GAN+VAE+Diffusion/论文作图.pptx
+++ b/Base_Model/GAN+VAE+Diffusion/论文作图.pptx
@@ -8,7 +8,7 @@
     <p:notesMasterId r:id="rId4"/>
   </p:notesMasterIdLst>
   <p:handoutMasterIdLst>
-    <p:handoutMasterId r:id="rId20"/>
+    <p:handoutMasterId r:id="rId22"/>
   </p:handoutMasterIdLst>
   <p:sldIdLst>
     <p:sldId id="256" r:id="rId3"/>
@@ -27,6 +27,8 @@
     <p:sldId id="270" r:id="rId17"/>
     <p:sldId id="271" r:id="rId18"/>
     <p:sldId id="272" r:id="rId19"/>
+    <p:sldId id="273" r:id="rId20"/>
+    <p:sldId id="274" r:id="rId21"/>
   </p:sldIdLst>
   <p:sldSz cx="12192000" cy="6858000"/>
   <p:notesSz cx="7103745" cy="10234295"/>
@@ -128,7 +130,7 @@
   <p:extLst>
     <p:ext uri="{EFAFB233-063F-42B5-8137-9DF3F51BA10A}">
       <p15:sldGuideLst xmlns:p15="http://schemas.microsoft.com/office/powerpoint/2012/main">
-        <p15:guide id="1" orient="horz" pos="2191" userDrawn="1">
+        <p15:guide id="1" orient="horz" pos="2195" userDrawn="1">
           <p15:clr>
             <a:srgbClr val="A4A3A4"/>
           </p15:clr>
@@ -8130,6 +8132,835 @@
 </p:sld>
 </file>
 
+<file path=ppt/slides/slide17.xml><?xml version="1.0" encoding="utf-8"?>
+<p:sld xmlns:a="http://schemas.openxmlformats.org/drawingml/2006/main" xmlns:r="http://schemas.openxmlformats.org/officeDocument/2006/relationships" xmlns:p="http://schemas.openxmlformats.org/presentationml/2006/main">
+  <p:cSld>
+    <p:spTree>
+      <p:nvGrpSpPr>
+        <p:cNvPr id="1" name=""/>
+        <p:cNvGrpSpPr/>
+        <p:nvPr/>
+      </p:nvGrpSpPr>
+      <p:grpSpPr/>
+      <p:sp>
+        <p:nvSpPr>
+          <p:cNvPr id="2" name="标题 1"/>
+          <p:cNvSpPr>
+            <a:spLocks noGrp="1"/>
+          </p:cNvSpPr>
+          <p:nvPr>
+            <p:ph type="ctrTitle"/>
+          </p:nvPr>
+        </p:nvSpPr>
+        <p:spPr/>
+        <p:txBody>
+          <a:bodyPr/>
+          <a:p>
+            <a:r>
+              <a:rPr lang="en-US" altLang="zh-CN"/>
+              <a:t>DDPM</a:t>
+            </a:r>
+            <a:endParaRPr lang="en-US" altLang="zh-CN"/>
+          </a:p>
+        </p:txBody>
+      </p:sp>
+      <p:sp>
+        <p:nvSpPr>
+          <p:cNvPr id="3" name="副标题 2"/>
+          <p:cNvSpPr>
+            <a:spLocks noGrp="1"/>
+          </p:cNvSpPr>
+          <p:nvPr>
+            <p:ph type="subTitle" idx="1"/>
+          </p:nvPr>
+        </p:nvSpPr>
+        <p:spPr/>
+        <p:txBody>
+          <a:bodyPr/>
+          <a:p>
+            <a:endParaRPr lang="zh-CN" altLang="en-US"/>
+          </a:p>
+        </p:txBody>
+      </p:sp>
+    </p:spTree>
+  </p:cSld>
+  <p:clrMapOvr>
+    <a:masterClrMapping/>
+  </p:clrMapOvr>
+</p:sld>
+</file>
+
+<file path=ppt/slides/slide18.xml><?xml version="1.0" encoding="utf-8"?>
+<p:sld xmlns:a="http://schemas.openxmlformats.org/drawingml/2006/main" xmlns:r="http://schemas.openxmlformats.org/officeDocument/2006/relationships" xmlns:p="http://schemas.openxmlformats.org/presentationml/2006/main">
+  <p:cSld>
+    <p:spTree>
+      <p:nvGrpSpPr>
+        <p:cNvPr id="1" name=""/>
+        <p:cNvGrpSpPr/>
+        <p:nvPr/>
+      </p:nvGrpSpPr>
+      <p:grpSpPr/>
+      <p:pic>
+        <p:nvPicPr>
+          <p:cNvPr id="4" name="图片 3"/>
+          <p:cNvPicPr>
+            <a:picLocks noChangeAspect="1"/>
+          </p:cNvPicPr>
+          <p:nvPr>
+            <p:custDataLst>
+              <p:tags r:id="rId1"/>
+            </p:custDataLst>
+          </p:nvPr>
+        </p:nvPicPr>
+        <p:blipFill>
+          <a:blip r:embed="rId2"/>
+          <a:stretch>
+            <a:fillRect/>
+          </a:stretch>
+        </p:blipFill>
+        <p:spPr>
+          <a:xfrm>
+            <a:off x="0" y="70485"/>
+            <a:ext cx="5554345" cy="1462405"/>
+          </a:xfrm>
+          <a:prstGeom prst="rect">
+            <a:avLst/>
+          </a:prstGeom>
+        </p:spPr>
+      </p:pic>
+      <p:pic>
+        <p:nvPicPr>
+          <p:cNvPr id="5" name="图片 4"/>
+          <p:cNvPicPr>
+            <a:picLocks noChangeAspect="1"/>
+          </p:cNvPicPr>
+          <p:nvPr>
+            <p:custDataLst>
+              <p:tags r:id="rId3"/>
+            </p:custDataLst>
+          </p:nvPr>
+        </p:nvPicPr>
+        <p:blipFill>
+          <a:blip r:embed="rId4"/>
+          <a:stretch>
+            <a:fillRect/>
+          </a:stretch>
+        </p:blipFill>
+        <p:spPr>
+          <a:xfrm>
+            <a:off x="87630" y="3746500"/>
+            <a:ext cx="4775200" cy="635000"/>
+          </a:xfrm>
+          <a:prstGeom prst="rect">
+            <a:avLst/>
+          </a:prstGeom>
+        </p:spPr>
+      </p:pic>
+      <p:sp>
+        <p:nvSpPr>
+          <p:cNvPr id="14" name="文本框 13"/>
+          <p:cNvSpPr txBox="1"/>
+          <p:nvPr>
+            <p:custDataLst>
+              <p:tags r:id="rId5"/>
+            </p:custDataLst>
+          </p:nvPr>
+        </p:nvSpPr>
+        <p:spPr>
+          <a:xfrm>
+            <a:off x="1755140" y="4373880"/>
+            <a:ext cx="1209675" cy="334010"/>
+          </a:xfrm>
+          <a:prstGeom prst="rect">
+            <a:avLst/>
+          </a:prstGeom>
+          <a:noFill/>
+        </p:spPr>
+        <p:txBody>
+          <a:bodyPr wrap="square" rtlCol="0">
+            <a:noAutofit/>
+          </a:bodyPr>
+          <a:p>
+            <a:pPr algn="ctr"/>
+            <a:r>
+              <a:rPr lang="zh-CN" altLang="en-US" sz="1200" b="1">
+                <a:latin typeface="微软雅黑" charset="0"/>
+                <a:ea typeface="微软雅黑" charset="0"/>
+                <a:cs typeface="微软雅黑" charset="0"/>
+              </a:rPr>
+              <a:t>正向过程噪声的真实</a:t>
+            </a:r>
+            <a:r>
+              <a:rPr lang="zh-CN" altLang="en-US" sz="1200" b="1">
+                <a:latin typeface="微软雅黑" charset="0"/>
+                <a:ea typeface="微软雅黑" charset="0"/>
+                <a:cs typeface="微软雅黑" charset="0"/>
+              </a:rPr>
+              <a:t>均值</a:t>
+            </a:r>
+            <a:endParaRPr lang="zh-CN" altLang="en-US" sz="1200" b="1">
+              <a:latin typeface="微软雅黑" charset="0"/>
+              <a:ea typeface="微软雅黑" charset="0"/>
+              <a:cs typeface="微软雅黑" charset="0"/>
+            </a:endParaRPr>
+          </a:p>
+        </p:txBody>
+      </p:sp>
+      <p:sp>
+        <p:nvSpPr>
+          <p:cNvPr id="6" name="文本框 5"/>
+          <p:cNvSpPr txBox="1"/>
+          <p:nvPr>
+            <p:custDataLst>
+              <p:tags r:id="rId6"/>
+            </p:custDataLst>
+          </p:nvPr>
+        </p:nvSpPr>
+        <p:spPr>
+          <a:xfrm>
+            <a:off x="3025140" y="4373880"/>
+            <a:ext cx="1209675" cy="334010"/>
+          </a:xfrm>
+          <a:prstGeom prst="rect">
+            <a:avLst/>
+          </a:prstGeom>
+          <a:noFill/>
+        </p:spPr>
+        <p:txBody>
+          <a:bodyPr wrap="square" rtlCol="0">
+            <a:noAutofit/>
+          </a:bodyPr>
+          <a:p>
+            <a:pPr algn="ctr"/>
+            <a:r>
+              <a:rPr lang="zh-CN" altLang="en-US" sz="1200" b="1">
+                <a:latin typeface="微软雅黑" charset="0"/>
+                <a:ea typeface="微软雅黑" charset="0"/>
+                <a:cs typeface="微软雅黑" charset="0"/>
+              </a:rPr>
+              <a:t>反向过程模型预测的</a:t>
+            </a:r>
+            <a:r>
+              <a:rPr lang="zh-CN" altLang="en-US" sz="1200" b="1">
+                <a:latin typeface="微软雅黑" charset="0"/>
+                <a:ea typeface="微软雅黑" charset="0"/>
+                <a:cs typeface="微软雅黑" charset="0"/>
+              </a:rPr>
+              <a:t>均值</a:t>
+            </a:r>
+            <a:endParaRPr lang="zh-CN" altLang="en-US" sz="1200" b="1">
+              <a:latin typeface="微软雅黑" charset="0"/>
+              <a:ea typeface="微软雅黑" charset="0"/>
+              <a:cs typeface="微软雅黑" charset="0"/>
+            </a:endParaRPr>
+          </a:p>
+        </p:txBody>
+      </p:sp>
+      <p:sp>
+        <p:nvSpPr>
+          <p:cNvPr id="7" name="文本框 6"/>
+          <p:cNvSpPr txBox="1"/>
+          <p:nvPr>
+            <p:custDataLst>
+              <p:tags r:id="rId7"/>
+            </p:custDataLst>
+          </p:nvPr>
+        </p:nvSpPr>
+        <p:spPr>
+          <a:xfrm>
+            <a:off x="1687195" y="4881880"/>
+            <a:ext cx="2616200" cy="334010"/>
+          </a:xfrm>
+          <a:prstGeom prst="rect">
+            <a:avLst/>
+          </a:prstGeom>
+          <a:noFill/>
+        </p:spPr>
+        <p:txBody>
+          <a:bodyPr wrap="square" rtlCol="0">
+            <a:noAutofit/>
+          </a:bodyPr>
+          <a:p>
+            <a:pPr algn="ctr"/>
+            <a:r>
+              <a:rPr lang="zh-CN" altLang="en-US" sz="1200" b="1">
+                <a:latin typeface="微软雅黑" charset="0"/>
+                <a:ea typeface="微软雅黑" charset="0"/>
+                <a:cs typeface="微软雅黑" charset="0"/>
+              </a:rPr>
+              <a:t>最小化两个噪声之间的欧式</a:t>
+            </a:r>
+            <a:r>
+              <a:rPr lang="zh-CN" altLang="en-US" sz="1200" b="1">
+                <a:latin typeface="微软雅黑" charset="0"/>
+                <a:ea typeface="微软雅黑" charset="0"/>
+                <a:cs typeface="微软雅黑" charset="0"/>
+              </a:rPr>
+              <a:t>距离</a:t>
+            </a:r>
+            <a:endParaRPr lang="zh-CN" altLang="en-US" sz="1200" b="1">
+              <a:latin typeface="微软雅黑" charset="0"/>
+              <a:ea typeface="微软雅黑" charset="0"/>
+              <a:cs typeface="微软雅黑" charset="0"/>
+            </a:endParaRPr>
+          </a:p>
+        </p:txBody>
+      </p:sp>
+      <p:sp>
+        <p:nvSpPr>
+          <p:cNvPr id="8" name="文本框 7"/>
+          <p:cNvSpPr txBox="1"/>
+          <p:nvPr>
+            <p:custDataLst>
+              <p:tags r:id="rId8"/>
+            </p:custDataLst>
+          </p:nvPr>
+        </p:nvSpPr>
+        <p:spPr>
+          <a:xfrm>
+            <a:off x="400685" y="3230880"/>
+            <a:ext cx="3526790" cy="334010"/>
+          </a:xfrm>
+          <a:prstGeom prst="rect">
+            <a:avLst/>
+          </a:prstGeom>
+          <a:noFill/>
+        </p:spPr>
+        <p:txBody>
+          <a:bodyPr wrap="square" rtlCol="0">
+            <a:noAutofit/>
+          </a:bodyPr>
+          <a:p>
+            <a:pPr algn="ctr"/>
+            <a:r>
+              <a:rPr lang="zh-CN" altLang="en-US" sz="1200" b="1">
+                <a:latin typeface="微软雅黑" charset="0"/>
+                <a:ea typeface="微软雅黑" charset="0"/>
+                <a:cs typeface="微软雅黑" charset="0"/>
+              </a:rPr>
+              <a:t>固定噪声方差，只学习均值</a:t>
+            </a:r>
+            <a:br>
+              <a:rPr lang="zh-CN" altLang="en-US" sz="1200" b="1">
+                <a:latin typeface="微软雅黑" charset="0"/>
+                <a:ea typeface="微软雅黑" charset="0"/>
+                <a:cs typeface="微软雅黑" charset="0"/>
+              </a:rPr>
+            </a:br>
+            <a:r>
+              <a:rPr lang="zh-CN" altLang="en-US" sz="1200" b="1">
+                <a:latin typeface="微软雅黑" charset="0"/>
+                <a:ea typeface="微软雅黑" charset="0"/>
+                <a:cs typeface="微软雅黑" charset="0"/>
+              </a:rPr>
+              <a:t>引入方差会有更复杂的情况，导致训练不稳定</a:t>
+            </a:r>
+            <a:br>
+              <a:rPr lang="zh-CN" altLang="en-US" sz="1200" b="1">
+                <a:latin typeface="微软雅黑" charset="0"/>
+                <a:ea typeface="微软雅黑" charset="0"/>
+                <a:cs typeface="微软雅黑" charset="0"/>
+              </a:rPr>
+            </a:br>
+            <a:r>
+              <a:rPr lang="zh-CN" altLang="en-US" sz="1200" b="1">
+                <a:latin typeface="微软雅黑" charset="0"/>
+                <a:ea typeface="微软雅黑" charset="0"/>
+                <a:cs typeface="微软雅黑" charset="0"/>
+              </a:rPr>
+              <a:t>仅训练均值也能达到很好的</a:t>
+            </a:r>
+            <a:r>
+              <a:rPr lang="zh-CN" altLang="en-US" sz="1200" b="1">
+                <a:latin typeface="微软雅黑" charset="0"/>
+                <a:ea typeface="微软雅黑" charset="0"/>
+                <a:cs typeface="微软雅黑" charset="0"/>
+              </a:rPr>
+              <a:t>效果</a:t>
+            </a:r>
+            <a:endParaRPr lang="zh-CN" altLang="en-US" sz="1200" b="1">
+              <a:latin typeface="微软雅黑" charset="0"/>
+              <a:ea typeface="微软雅黑" charset="0"/>
+              <a:cs typeface="微软雅黑" charset="0"/>
+            </a:endParaRPr>
+          </a:p>
+        </p:txBody>
+      </p:sp>
+      <p:pic>
+        <p:nvPicPr>
+          <p:cNvPr id="9" name="图片 8"/>
+          <p:cNvPicPr>
+            <a:picLocks noChangeAspect="1"/>
+          </p:cNvPicPr>
+          <p:nvPr>
+            <p:custDataLst>
+              <p:tags r:id="rId9"/>
+            </p:custDataLst>
+          </p:nvPr>
+        </p:nvPicPr>
+        <p:blipFill>
+          <a:blip r:embed="rId10"/>
+          <a:stretch>
+            <a:fillRect/>
+          </a:stretch>
+        </p:blipFill>
+        <p:spPr>
+          <a:xfrm>
+            <a:off x="80645" y="5262880"/>
+            <a:ext cx="6212205" cy="1325245"/>
+          </a:xfrm>
+          <a:prstGeom prst="rect">
+            <a:avLst/>
+          </a:prstGeom>
+        </p:spPr>
+      </p:pic>
+      <p:sp>
+        <p:nvSpPr>
+          <p:cNvPr id="11" name="文本框 10"/>
+          <p:cNvSpPr txBox="1"/>
+          <p:nvPr>
+            <p:custDataLst>
+              <p:tags r:id="rId11"/>
+            </p:custDataLst>
+          </p:nvPr>
+        </p:nvSpPr>
+        <p:spPr>
+          <a:xfrm>
+            <a:off x="7610475" y="429260"/>
+            <a:ext cx="3526790" cy="334010"/>
+          </a:xfrm>
+          <a:prstGeom prst="rect">
+            <a:avLst/>
+          </a:prstGeom>
+          <a:noFill/>
+        </p:spPr>
+        <p:txBody>
+          <a:bodyPr wrap="square" rtlCol="0">
+            <a:noAutofit/>
+          </a:bodyPr>
+          <a:p>
+            <a:pPr algn="ctr"/>
+            <a:r>
+              <a:rPr lang="zh-CN" altLang="en-US" sz="1200" b="1">
+                <a:latin typeface="微软雅黑" charset="0"/>
+                <a:ea typeface="微软雅黑" charset="0"/>
+                <a:cs typeface="微软雅黑" charset="0"/>
+              </a:rPr>
+              <a:t>虽然整个过程只使用了一个噪声，通过调节比值来加噪和和去噪，实际上每一步比值不同都会生成全新的均值供模型进行学习</a:t>
+            </a:r>
+            <a:endParaRPr lang="zh-CN" altLang="en-US" sz="1200" b="1">
+              <a:latin typeface="微软雅黑" charset="0"/>
+              <a:ea typeface="微软雅黑" charset="0"/>
+              <a:cs typeface="微软雅黑" charset="0"/>
+            </a:endParaRPr>
+          </a:p>
+        </p:txBody>
+      </p:sp>
+      <p:pic>
+        <p:nvPicPr>
+          <p:cNvPr id="13" name="图片 12"/>
+          <p:cNvPicPr>
+            <a:picLocks noChangeAspect="1"/>
+          </p:cNvPicPr>
+          <p:nvPr>
+            <p:custDataLst>
+              <p:tags r:id="rId12"/>
+            </p:custDataLst>
+          </p:nvPr>
+        </p:nvPicPr>
+        <p:blipFill>
+          <a:blip r:embed="rId13"/>
+          <a:stretch>
+            <a:fillRect/>
+          </a:stretch>
+        </p:blipFill>
+        <p:spPr>
+          <a:xfrm>
+            <a:off x="2881630" y="1611630"/>
+            <a:ext cx="6603365" cy="1619250"/>
+          </a:xfrm>
+          <a:prstGeom prst="rect">
+            <a:avLst/>
+          </a:prstGeom>
+        </p:spPr>
+      </p:pic>
+      <p:sp>
+        <p:nvSpPr>
+          <p:cNvPr id="15" name="文本框 14"/>
+          <p:cNvSpPr txBox="1"/>
+          <p:nvPr>
+            <p:custDataLst>
+              <p:tags r:id="rId14"/>
+            </p:custDataLst>
+          </p:nvPr>
+        </p:nvSpPr>
+        <p:spPr>
+          <a:xfrm>
+            <a:off x="-12700" y="1826260"/>
+            <a:ext cx="2977515" cy="830580"/>
+          </a:xfrm>
+          <a:prstGeom prst="rect">
+            <a:avLst/>
+          </a:prstGeom>
+          <a:noFill/>
+        </p:spPr>
+        <p:txBody>
+          <a:bodyPr wrap="square" rtlCol="0">
+            <a:noAutofit/>
+          </a:bodyPr>
+          <a:p>
+            <a:pPr algn="l"/>
+            <a:r>
+              <a:rPr lang="en-US" altLang="zh-CN" sz="1200" b="1">
+                <a:latin typeface="微软雅黑" charset="0"/>
+                <a:ea typeface="微软雅黑" charset="0"/>
+                <a:cs typeface="微软雅黑" charset="0"/>
+              </a:rPr>
+              <a:t>2. </a:t>
+            </a:r>
+            <a:r>
+              <a:rPr lang="zh-CN" altLang="en-US" sz="1200" b="1">
+                <a:latin typeface="微软雅黑" charset="0"/>
+                <a:ea typeface="微软雅黑" charset="0"/>
+                <a:cs typeface="微软雅黑" charset="0"/>
+              </a:rPr>
+              <a:t>从分布中随机采样图像</a:t>
+            </a:r>
+            <a:br>
+              <a:rPr lang="zh-CN" altLang="en-US" sz="1200" b="1">
+                <a:latin typeface="微软雅黑" charset="0"/>
+                <a:ea typeface="微软雅黑" charset="0"/>
+                <a:cs typeface="微软雅黑" charset="0"/>
+              </a:rPr>
+            </a:br>
+            <a:r>
+              <a:rPr lang="en-US" altLang="zh-CN" sz="1200" b="1">
+                <a:latin typeface="微软雅黑" charset="0"/>
+                <a:ea typeface="微软雅黑" charset="0"/>
+                <a:cs typeface="微软雅黑" charset="0"/>
+              </a:rPr>
+              <a:t>3. </a:t>
+            </a:r>
+            <a:r>
+              <a:rPr lang="zh-CN" altLang="en-US" sz="1200" b="1">
+                <a:latin typeface="微软雅黑" charset="0"/>
+                <a:ea typeface="微软雅黑" charset="0"/>
+                <a:cs typeface="微软雅黑" charset="0"/>
+              </a:rPr>
+              <a:t>随机采样一个</a:t>
+            </a:r>
+            <a:r>
+              <a:rPr lang="zh-CN" altLang="en-US" sz="1200" b="1">
+                <a:latin typeface="微软雅黑" charset="0"/>
+                <a:ea typeface="微软雅黑" charset="0"/>
+                <a:cs typeface="微软雅黑" charset="0"/>
+              </a:rPr>
+              <a:t>时间步</a:t>
+            </a:r>
+            <a:endParaRPr lang="zh-CN" altLang="en-US" sz="1200" b="1">
+              <a:latin typeface="微软雅黑" charset="0"/>
+              <a:ea typeface="微软雅黑" charset="0"/>
+              <a:cs typeface="微软雅黑" charset="0"/>
+            </a:endParaRPr>
+          </a:p>
+          <a:p>
+            <a:pPr algn="l"/>
+            <a:r>
+              <a:rPr lang="en-US" altLang="zh-CN" sz="1200" b="1">
+                <a:latin typeface="微软雅黑" charset="0"/>
+                <a:ea typeface="微软雅黑" charset="0"/>
+                <a:cs typeface="微软雅黑" charset="0"/>
+              </a:rPr>
+              <a:t>4. </a:t>
+            </a:r>
+            <a:r>
+              <a:rPr lang="zh-CN" altLang="en-US" sz="1200" b="1">
+                <a:latin typeface="微软雅黑" charset="0"/>
+                <a:ea typeface="微软雅黑" charset="0"/>
+                <a:cs typeface="微软雅黑" charset="0"/>
+              </a:rPr>
+              <a:t>从标准高斯采样噪声</a:t>
+            </a:r>
+            <a:r>
+              <a:rPr lang="en-US" altLang="zh-CN" sz="1200" b="1">
+                <a:latin typeface="微软雅黑" charset="0"/>
+                <a:ea typeface="微软雅黑" charset="0"/>
+                <a:cs typeface="微软雅黑" charset="0"/>
+              </a:rPr>
+              <a:t>(</a:t>
+            </a:r>
+            <a:r>
+              <a:rPr lang="zh-CN" altLang="en-US" sz="1200" b="1">
+                <a:latin typeface="微软雅黑" charset="0"/>
+                <a:ea typeface="微软雅黑" charset="0"/>
+                <a:cs typeface="微软雅黑" charset="0"/>
+              </a:rPr>
+              <a:t>用于原图上添加</a:t>
+            </a:r>
+            <a:r>
+              <a:rPr lang="en-US" altLang="zh-CN" sz="1200" b="1">
+                <a:latin typeface="微软雅黑" charset="0"/>
+                <a:ea typeface="微软雅黑" charset="0"/>
+                <a:cs typeface="微软雅黑" charset="0"/>
+              </a:rPr>
+              <a:t>)</a:t>
+            </a:r>
+            <a:br>
+              <a:rPr lang="zh-CN" altLang="en-US" sz="1200" b="1">
+                <a:latin typeface="微软雅黑" charset="0"/>
+                <a:ea typeface="微软雅黑" charset="0"/>
+                <a:cs typeface="微软雅黑" charset="0"/>
+              </a:rPr>
+            </a:br>
+            <a:r>
+              <a:rPr lang="en-US" altLang="zh-CN" sz="1200" b="1">
+                <a:latin typeface="微软雅黑" charset="0"/>
+                <a:ea typeface="微软雅黑" charset="0"/>
+                <a:cs typeface="微软雅黑" charset="0"/>
+              </a:rPr>
+              <a:t>5. </a:t>
+            </a:r>
+            <a:r>
+              <a:rPr lang="zh-CN" altLang="en-US" sz="1200" b="1">
+                <a:latin typeface="微软雅黑" charset="0"/>
+                <a:ea typeface="微软雅黑" charset="0"/>
+                <a:cs typeface="微软雅黑" charset="0"/>
+              </a:rPr>
+              <a:t>最小化模型预测噪声和时间步</a:t>
+            </a:r>
+            <a:r>
+              <a:rPr lang="en-US" altLang="zh-CN" sz="1200" b="1">
+                <a:latin typeface="微软雅黑" charset="0"/>
+                <a:ea typeface="微软雅黑" charset="0"/>
+                <a:cs typeface="微软雅黑" charset="0"/>
+              </a:rPr>
+              <a:t>t</a:t>
+            </a:r>
+            <a:r>
+              <a:rPr lang="zh-CN" altLang="en-US" sz="1200" b="1">
+                <a:latin typeface="微软雅黑" charset="0"/>
+                <a:ea typeface="微软雅黑" charset="0"/>
+                <a:cs typeface="微软雅黑" charset="0"/>
+              </a:rPr>
+              <a:t>对应的噪声</a:t>
+            </a:r>
+            <a:r>
+              <a:rPr lang="zh-CN" altLang="en-US" sz="1200" b="1">
+                <a:latin typeface="微软雅黑" charset="0"/>
+                <a:ea typeface="微软雅黑" charset="0"/>
+                <a:cs typeface="微软雅黑" charset="0"/>
+              </a:rPr>
+              <a:t>的平方误差</a:t>
+            </a:r>
+            <a:endParaRPr lang="zh-CN" altLang="en-US" sz="1200" b="1">
+              <a:latin typeface="微软雅黑" charset="0"/>
+              <a:ea typeface="微软雅黑" charset="0"/>
+              <a:cs typeface="微软雅黑" charset="0"/>
+            </a:endParaRPr>
+          </a:p>
+        </p:txBody>
+      </p:sp>
+      <p:sp>
+        <p:nvSpPr>
+          <p:cNvPr id="16" name="文本框 15"/>
+          <p:cNvSpPr txBox="1"/>
+          <p:nvPr>
+            <p:custDataLst>
+              <p:tags r:id="rId15"/>
+            </p:custDataLst>
+          </p:nvPr>
+        </p:nvSpPr>
+        <p:spPr>
+          <a:xfrm>
+            <a:off x="9258300" y="1826260"/>
+            <a:ext cx="2977515" cy="1403985"/>
+          </a:xfrm>
+          <a:prstGeom prst="rect">
+            <a:avLst/>
+          </a:prstGeom>
+          <a:noFill/>
+        </p:spPr>
+        <p:txBody>
+          <a:bodyPr wrap="square" rtlCol="0">
+            <a:noAutofit/>
+          </a:bodyPr>
+          <a:p>
+            <a:pPr algn="l"/>
+            <a:r>
+              <a:rPr lang="en-US" altLang="zh-CN" sz="1200" b="1">
+                <a:latin typeface="微软雅黑" charset="0"/>
+                <a:ea typeface="微软雅黑" charset="0"/>
+                <a:cs typeface="微软雅黑" charset="0"/>
+              </a:rPr>
+              <a:t>1. </a:t>
+            </a:r>
+            <a:r>
+              <a:rPr lang="zh-CN" altLang="en-US" sz="1200" b="1">
+                <a:latin typeface="微软雅黑" charset="0"/>
+                <a:ea typeface="微软雅黑" charset="0"/>
+                <a:cs typeface="微软雅黑" charset="0"/>
+              </a:rPr>
+              <a:t>初始化随机</a:t>
+            </a:r>
+            <a:r>
+              <a:rPr lang="zh-CN" altLang="en-US" sz="1200" b="1">
+                <a:latin typeface="微软雅黑" charset="0"/>
+                <a:ea typeface="微软雅黑" charset="0"/>
+                <a:cs typeface="微软雅黑" charset="0"/>
+              </a:rPr>
+              <a:t>噪声</a:t>
+            </a:r>
+            <a:endParaRPr lang="zh-CN" altLang="en-US" sz="1200" b="1">
+              <a:latin typeface="微软雅黑" charset="0"/>
+              <a:ea typeface="微软雅黑" charset="0"/>
+              <a:cs typeface="微软雅黑" charset="0"/>
+            </a:endParaRPr>
+          </a:p>
+          <a:p>
+            <a:pPr algn="l"/>
+            <a:r>
+              <a:rPr lang="en-US" altLang="zh-CN" sz="1200" b="1">
+                <a:latin typeface="微软雅黑" charset="0"/>
+                <a:ea typeface="微软雅黑" charset="0"/>
+                <a:cs typeface="微软雅黑" charset="0"/>
+              </a:rPr>
+              <a:t>2.</a:t>
+            </a:r>
+            <a:r>
+              <a:rPr lang="zh-CN" altLang="en-US" sz="1200" b="1">
+                <a:latin typeface="微软雅黑" charset="0"/>
+                <a:ea typeface="微软雅黑" charset="0"/>
+                <a:cs typeface="微软雅黑" charset="0"/>
+              </a:rPr>
+              <a:t>迭代</a:t>
+            </a:r>
+            <a:endParaRPr lang="zh-CN" altLang="en-US" sz="1200" b="1">
+              <a:latin typeface="微软雅黑" charset="0"/>
+              <a:ea typeface="微软雅黑" charset="0"/>
+              <a:cs typeface="微软雅黑" charset="0"/>
+            </a:endParaRPr>
+          </a:p>
+          <a:p>
+            <a:pPr algn="l"/>
+            <a:r>
+              <a:rPr lang="en-US" altLang="zh-CN" sz="1200" b="1">
+                <a:latin typeface="微软雅黑" charset="0"/>
+                <a:ea typeface="微软雅黑" charset="0"/>
+                <a:cs typeface="微软雅黑" charset="0"/>
+              </a:rPr>
+              <a:t>3.</a:t>
+            </a:r>
+            <a:r>
+              <a:rPr lang="zh-CN" altLang="en-US" sz="1200" b="1">
+                <a:latin typeface="微软雅黑" charset="0"/>
+                <a:ea typeface="微软雅黑" charset="0"/>
+                <a:cs typeface="微软雅黑" charset="0"/>
+              </a:rPr>
+              <a:t>除了第一步外的每一步随机采样一个高斯噪声</a:t>
+            </a:r>
+            <a:r>
+              <a:rPr lang="en-US" altLang="zh-CN" sz="1200" b="1">
+                <a:latin typeface="微软雅黑" charset="0"/>
+                <a:ea typeface="微软雅黑" charset="0"/>
+                <a:cs typeface="微软雅黑" charset="0"/>
+              </a:rPr>
+              <a:t>z</a:t>
+            </a:r>
+            <a:br>
+              <a:rPr lang="en-US" altLang="zh-CN" sz="1200" b="1">
+                <a:latin typeface="微软雅黑" charset="0"/>
+                <a:ea typeface="微软雅黑" charset="0"/>
+                <a:cs typeface="微软雅黑" charset="0"/>
+              </a:rPr>
+            </a:br>
+            <a:r>
+              <a:rPr lang="en-US" altLang="zh-CN" sz="1200" b="1">
+                <a:latin typeface="微软雅黑" charset="0"/>
+                <a:ea typeface="微软雅黑" charset="0"/>
+                <a:cs typeface="微软雅黑" charset="0"/>
+              </a:rPr>
+              <a:t>4. </a:t>
+            </a:r>
+            <a:r>
+              <a:rPr lang="zh-CN" altLang="en-US" sz="1200" b="1">
+                <a:latin typeface="微软雅黑" charset="0"/>
+                <a:ea typeface="微软雅黑" charset="0"/>
+                <a:cs typeface="微软雅黑" charset="0"/>
+              </a:rPr>
+              <a:t>对模型第</a:t>
+            </a:r>
+            <a:r>
+              <a:rPr lang="en-US" altLang="zh-CN" sz="1200" b="1">
+                <a:latin typeface="微软雅黑" charset="0"/>
+                <a:ea typeface="微软雅黑" charset="0"/>
+                <a:cs typeface="微软雅黑" charset="0"/>
+              </a:rPr>
+              <a:t>T</a:t>
+            </a:r>
+            <a:r>
+              <a:rPr lang="zh-CN" altLang="en-US" sz="1200" b="1">
+                <a:latin typeface="微软雅黑" charset="0"/>
+                <a:ea typeface="微软雅黑" charset="0"/>
+                <a:cs typeface="微软雅黑" charset="0"/>
+              </a:rPr>
+              <a:t>步，预测需要减去的噪声恢复到</a:t>
+            </a:r>
+            <a:r>
+              <a:rPr lang="en-US" altLang="zh-CN" sz="1200" b="1">
+                <a:latin typeface="微软雅黑" charset="0"/>
+                <a:ea typeface="微软雅黑" charset="0"/>
+                <a:cs typeface="微软雅黑" charset="0"/>
+              </a:rPr>
+              <a:t>T-1</a:t>
+            </a:r>
+            <a:r>
+              <a:rPr lang="zh-CN" altLang="en-US" sz="1200" b="1">
+                <a:latin typeface="微软雅黑" charset="0"/>
+                <a:ea typeface="微软雅黑" charset="0"/>
+                <a:cs typeface="微软雅黑" charset="0"/>
+              </a:rPr>
+              <a:t>步，然后加上</a:t>
+            </a:r>
+            <a:r>
+              <a:rPr lang="en-US" altLang="zh-CN" sz="1200" b="1">
+                <a:latin typeface="微软雅黑" charset="0"/>
+                <a:ea typeface="微软雅黑" charset="0"/>
+                <a:cs typeface="微软雅黑" charset="0"/>
+              </a:rPr>
+              <a:t>z</a:t>
+            </a:r>
+            <a:r>
+              <a:rPr lang="zh-CN" altLang="en-US" sz="1200" b="1">
+                <a:latin typeface="微软雅黑" charset="0"/>
+                <a:ea typeface="微软雅黑" charset="0"/>
+                <a:cs typeface="微软雅黑" charset="0"/>
+              </a:rPr>
+              <a:t>来确保样本</a:t>
+            </a:r>
+            <a:r>
+              <a:rPr lang="zh-CN" altLang="en-US" sz="1200" b="1">
+                <a:latin typeface="微软雅黑" charset="0"/>
+                <a:ea typeface="微软雅黑" charset="0"/>
+                <a:cs typeface="微软雅黑" charset="0"/>
+              </a:rPr>
+              <a:t>多样性</a:t>
+            </a:r>
+            <a:endParaRPr lang="zh-CN" altLang="en-US" sz="1200" b="1">
+              <a:latin typeface="微软雅黑" charset="0"/>
+              <a:ea typeface="微软雅黑" charset="0"/>
+              <a:cs typeface="微软雅黑" charset="0"/>
+            </a:endParaRPr>
+          </a:p>
+        </p:txBody>
+      </p:sp>
+    </p:spTree>
+  </p:cSld>
+  <p:clrMapOvr>
+    <a:masterClrMapping/>
+  </p:clrMapOvr>
+</p:sld>
+</file>
+
 <file path=ppt/slides/slide2.xml><?xml version="1.0" encoding="utf-8"?>
 <p:sld xmlns:a="http://schemas.openxmlformats.org/drawingml/2006/main" xmlns:r="http://schemas.openxmlformats.org/officeDocument/2006/relationships" xmlns:p="http://schemas.openxmlformats.org/presentationml/2006/main">
   <p:cSld>
@@ -16542,7 +17373,73 @@
 </p:tagLst>
 </file>
 
+<file path=ppt/tags/tag176.xml><?xml version="1.0" encoding="utf-8"?>
+<p:tagLst xmlns:p="http://schemas.openxmlformats.org/presentationml/2006/main">
+  <p:tag name="KSO_WM_BEAUTIFY_FLAG" val=""/>
+</p:tagLst>
+</file>
+
+<file path=ppt/tags/tag177.xml><?xml version="1.0" encoding="utf-8"?>
+<p:tagLst xmlns:p="http://schemas.openxmlformats.org/presentationml/2006/main">
+  <p:tag name="KSO_WM_BEAUTIFY_FLAG" val=""/>
+</p:tagLst>
+</file>
+
+<file path=ppt/tags/tag178.xml><?xml version="1.0" encoding="utf-8"?>
+<p:tagLst xmlns:p="http://schemas.openxmlformats.org/presentationml/2006/main">
+  <p:tag name="KSO_WM_BEAUTIFY_FLAG" val=""/>
+</p:tagLst>
+</file>
+
+<file path=ppt/tags/tag179.xml><?xml version="1.0" encoding="utf-8"?>
+<p:tagLst xmlns:p="http://schemas.openxmlformats.org/presentationml/2006/main">
+  <p:tag name="KSO_WM_BEAUTIFY_FLAG" val=""/>
+</p:tagLst>
+</file>
+
 <file path=ppt/tags/tag18.xml><?xml version="1.0" encoding="utf-8"?>
+<p:tagLst xmlns:p="http://schemas.openxmlformats.org/presentationml/2006/main">
+  <p:tag name="KSO_WM_BEAUTIFY_FLAG" val=""/>
+</p:tagLst>
+</file>
+
+<file path=ppt/tags/tag180.xml><?xml version="1.0" encoding="utf-8"?>
+<p:tagLst xmlns:p="http://schemas.openxmlformats.org/presentationml/2006/main">
+  <p:tag name="KSO_WM_BEAUTIFY_FLAG" val=""/>
+</p:tagLst>
+</file>
+
+<file path=ppt/tags/tag181.xml><?xml version="1.0" encoding="utf-8"?>
+<p:tagLst xmlns:p="http://schemas.openxmlformats.org/presentationml/2006/main">
+  <p:tag name="KSO_WM_BEAUTIFY_FLAG" val=""/>
+</p:tagLst>
+</file>
+
+<file path=ppt/tags/tag182.xml><?xml version="1.0" encoding="utf-8"?>
+<p:tagLst xmlns:p="http://schemas.openxmlformats.org/presentationml/2006/main">
+  <p:tag name="KSO_WM_BEAUTIFY_FLAG" val=""/>
+</p:tagLst>
+</file>
+
+<file path=ppt/tags/tag183.xml><?xml version="1.0" encoding="utf-8"?>
+<p:tagLst xmlns:p="http://schemas.openxmlformats.org/presentationml/2006/main">
+  <p:tag name="KSO_WM_BEAUTIFY_FLAG" val=""/>
+</p:tagLst>
+</file>
+
+<file path=ppt/tags/tag184.xml><?xml version="1.0" encoding="utf-8"?>
+<p:tagLst xmlns:p="http://schemas.openxmlformats.org/presentationml/2006/main">
+  <p:tag name="KSO_WM_BEAUTIFY_FLAG" val=""/>
+</p:tagLst>
+</file>
+
+<file path=ppt/tags/tag185.xml><?xml version="1.0" encoding="utf-8"?>
+<p:tagLst xmlns:p="http://schemas.openxmlformats.org/presentationml/2006/main">
+  <p:tag name="KSO_WM_BEAUTIFY_FLAG" val=""/>
+</p:tagLst>
+</file>
+
+<file path=ppt/tags/tag186.xml><?xml version="1.0" encoding="utf-8"?>
 <p:tagLst xmlns:p="http://schemas.openxmlformats.org/presentationml/2006/main">
   <p:tag name="KSO_WM_BEAUTIFY_FLAG" val=""/>
 </p:tagLst>

</xml_diff>

<commit_message>
update_Denoising Diffusion Implicit Models
</commit_message>
<xml_diff>
--- a/Base_Model/GAN+VAE+Diffusion/论文作图.pptx
+++ b/Base_Model/GAN+VAE+Diffusion/论文作图.pptx
@@ -8,7 +8,7 @@
     <p:notesMasterId r:id="rId4"/>
   </p:notesMasterIdLst>
   <p:handoutMasterIdLst>
-    <p:handoutMasterId r:id="rId22"/>
+    <p:handoutMasterId r:id="rId24"/>
   </p:handoutMasterIdLst>
   <p:sldIdLst>
     <p:sldId id="256" r:id="rId3"/>
@@ -29,6 +29,8 @@
     <p:sldId id="272" r:id="rId19"/>
     <p:sldId id="273" r:id="rId20"/>
     <p:sldId id="274" r:id="rId21"/>
+    <p:sldId id="275" r:id="rId22"/>
+    <p:sldId id="276" r:id="rId23"/>
   </p:sldIdLst>
   <p:sldSz cx="12192000" cy="6858000"/>
   <p:notesSz cx="7103745" cy="10234295"/>
@@ -8576,7 +8578,7 @@
         </p:blipFill>
         <p:spPr>
           <a:xfrm>
-            <a:off x="2881630" y="1611630"/>
+            <a:off x="2828290" y="1611630"/>
             <a:ext cx="6603365" cy="1619250"/>
           </a:xfrm>
           <a:prstGeom prst="rect">
@@ -8950,6 +8952,68 @@
               <a:ea typeface="微软雅黑" charset="0"/>
               <a:cs typeface="微软雅黑" charset="0"/>
             </a:endParaRPr>
+          </a:p>
+        </p:txBody>
+      </p:sp>
+    </p:spTree>
+  </p:cSld>
+  <p:clrMapOvr>
+    <a:masterClrMapping/>
+  </p:clrMapOvr>
+</p:sld>
+</file>
+
+<file path=ppt/slides/slide19.xml><?xml version="1.0" encoding="utf-8"?>
+<p:sld xmlns:a="http://schemas.openxmlformats.org/drawingml/2006/main" xmlns:r="http://schemas.openxmlformats.org/officeDocument/2006/relationships" xmlns:p="http://schemas.openxmlformats.org/presentationml/2006/main">
+  <p:cSld>
+    <p:spTree>
+      <p:nvGrpSpPr>
+        <p:cNvPr id="1" name=""/>
+        <p:cNvGrpSpPr/>
+        <p:nvPr/>
+      </p:nvGrpSpPr>
+      <p:grpSpPr/>
+      <p:sp>
+        <p:nvSpPr>
+          <p:cNvPr id="2" name="标题 1"/>
+          <p:cNvSpPr>
+            <a:spLocks noGrp="1"/>
+          </p:cNvSpPr>
+          <p:nvPr>
+            <p:ph type="ctrTitle"/>
+          </p:nvPr>
+        </p:nvSpPr>
+        <p:spPr/>
+        <p:txBody>
+          <a:bodyPr/>
+          <a:p>
+            <a:r>
+              <a:rPr lang="en-US" altLang="zh-CN"/>
+              <a:t>DD</a:t>
+            </a:r>
+            <a:r>
+              <a:rPr lang="en-US" altLang="zh-CN"/>
+              <a:t>IM</a:t>
+            </a:r>
+            <a:endParaRPr lang="en-US" altLang="zh-CN"/>
+          </a:p>
+        </p:txBody>
+      </p:sp>
+      <p:sp>
+        <p:nvSpPr>
+          <p:cNvPr id="3" name="副标题 2"/>
+          <p:cNvSpPr>
+            <a:spLocks noGrp="1"/>
+          </p:cNvSpPr>
+          <p:nvPr>
+            <p:ph type="subTitle" idx="1"/>
+          </p:nvPr>
+        </p:nvSpPr>
+        <p:spPr/>
+        <p:txBody>
+          <a:bodyPr/>
+          <a:p>
+            <a:endParaRPr lang="zh-CN" altLang="en-US"/>
           </a:p>
         </p:txBody>
       </p:sp>
@@ -9316,6 +9380,258 @@
           <a:p>
             <a:pPr algn="ctr"/>
             <a:endParaRPr lang="zh-CN" altLang="en-US"/>
+          </a:p>
+        </p:txBody>
+      </p:sp>
+    </p:spTree>
+  </p:cSld>
+  <p:clrMapOvr>
+    <a:masterClrMapping/>
+  </p:clrMapOvr>
+</p:sld>
+</file>
+
+<file path=ppt/slides/slide20.xml><?xml version="1.0" encoding="utf-8"?>
+<p:sld xmlns:a="http://schemas.openxmlformats.org/drawingml/2006/main" xmlns:r="http://schemas.openxmlformats.org/officeDocument/2006/relationships" xmlns:p="http://schemas.openxmlformats.org/presentationml/2006/main">
+  <p:cSld>
+    <p:spTree>
+      <p:nvGrpSpPr>
+        <p:cNvPr id="1" name=""/>
+        <p:cNvGrpSpPr/>
+        <p:nvPr/>
+      </p:nvGrpSpPr>
+      <p:grpSpPr/>
+      <p:pic>
+        <p:nvPicPr>
+          <p:cNvPr id="4" name="图片 3"/>
+          <p:cNvPicPr>
+            <a:picLocks noChangeAspect="1"/>
+          </p:cNvPicPr>
+          <p:nvPr>
+            <p:custDataLst>
+              <p:tags r:id="rId1"/>
+            </p:custDataLst>
+          </p:nvPr>
+        </p:nvPicPr>
+        <p:blipFill>
+          <a:blip r:embed="rId2"/>
+          <a:stretch>
+            <a:fillRect/>
+          </a:stretch>
+        </p:blipFill>
+        <p:spPr>
+          <a:xfrm>
+            <a:off x="133350" y="3062605"/>
+            <a:ext cx="4521200" cy="762000"/>
+          </a:xfrm>
+          <a:prstGeom prst="rect">
+            <a:avLst/>
+          </a:prstGeom>
+        </p:spPr>
+      </p:pic>
+      <p:sp>
+        <p:nvSpPr>
+          <p:cNvPr id="8" name="文本框 7"/>
+          <p:cNvSpPr txBox="1"/>
+          <p:nvPr>
+            <p:custDataLst>
+              <p:tags r:id="rId3"/>
+            </p:custDataLst>
+          </p:nvPr>
+        </p:nvSpPr>
+        <p:spPr>
+          <a:xfrm>
+            <a:off x="133350" y="2186940"/>
+            <a:ext cx="4521200" cy="541655"/>
+          </a:xfrm>
+          <a:prstGeom prst="rect">
+            <a:avLst/>
+          </a:prstGeom>
+          <a:noFill/>
+        </p:spPr>
+        <p:txBody>
+          <a:bodyPr wrap="square" rtlCol="0">
+            <a:noAutofit/>
+          </a:bodyPr>
+          <a:p>
+            <a:pPr algn="ctr"/>
+            <a:r>
+              <a:rPr lang="zh-CN" altLang="en-US" sz="1200" b="1">
+                <a:latin typeface="微软雅黑" charset="0"/>
+                <a:ea typeface="微软雅黑" charset="0"/>
+                <a:cs typeface="微软雅黑" charset="0"/>
+              </a:rPr>
+              <a:t>我们如果想知道模型从</a:t>
+            </a:r>
+            <a:r>
+              <a:rPr lang="en-US" altLang="zh-CN" sz="1200" b="1">
+                <a:latin typeface="微软雅黑" charset="0"/>
+                <a:ea typeface="微软雅黑" charset="0"/>
+                <a:cs typeface="微软雅黑" charset="0"/>
+              </a:rPr>
+              <a:t>x0</a:t>
+            </a:r>
+            <a:r>
+              <a:rPr lang="zh-CN" altLang="en-US" sz="1200" b="1">
+                <a:latin typeface="微软雅黑" charset="0"/>
+                <a:ea typeface="微软雅黑" charset="0"/>
+                <a:cs typeface="微软雅黑" charset="0"/>
+              </a:rPr>
+              <a:t>生成中间时刻的概率，只需要知道模型从</a:t>
+            </a:r>
+            <a:r>
+              <a:rPr lang="en-US" altLang="zh-CN" sz="1200" b="1">
+                <a:latin typeface="微软雅黑" charset="0"/>
+                <a:ea typeface="微软雅黑" charset="0"/>
+                <a:cs typeface="微软雅黑" charset="0"/>
+              </a:rPr>
+              <a:t>x0</a:t>
+            </a:r>
+            <a:r>
+              <a:rPr lang="zh-CN" altLang="en-US" sz="1200" b="1">
+                <a:latin typeface="微软雅黑" charset="0"/>
+                <a:ea typeface="微软雅黑" charset="0"/>
+                <a:cs typeface="微软雅黑" charset="0"/>
+              </a:rPr>
+              <a:t>生成最终时刻</a:t>
+            </a:r>
+            <a:r>
+              <a:rPr lang="en-US" altLang="zh-CN" sz="1200" b="1">
+                <a:latin typeface="微软雅黑" charset="0"/>
+                <a:ea typeface="微软雅黑" charset="0"/>
+                <a:cs typeface="微软雅黑" charset="0"/>
+              </a:rPr>
+              <a:t>XT</a:t>
+            </a:r>
+            <a:r>
+              <a:rPr lang="zh-CN" altLang="en-US" sz="1200" b="1">
+                <a:latin typeface="微软雅黑" charset="0"/>
+                <a:ea typeface="微软雅黑" charset="0"/>
+                <a:cs typeface="微软雅黑" charset="0"/>
+              </a:rPr>
+              <a:t>的概率与</a:t>
+            </a:r>
+            <a:r>
+              <a:rPr lang="en-US" altLang="zh-CN" sz="1200" b="1">
+                <a:latin typeface="微软雅黑" charset="0"/>
+                <a:ea typeface="微软雅黑" charset="0"/>
+                <a:cs typeface="微软雅黑" charset="0"/>
+              </a:rPr>
+              <a:t>XT</a:t>
+            </a:r>
+            <a:r>
+              <a:rPr lang="zh-CN" altLang="en-US" sz="1200" b="1">
+                <a:latin typeface="微软雅黑" charset="0"/>
+                <a:ea typeface="微软雅黑" charset="0"/>
+                <a:cs typeface="微软雅黑" charset="0"/>
+              </a:rPr>
+              <a:t>回退到中间时刻的概率的</a:t>
+            </a:r>
+            <a:r>
+              <a:rPr lang="zh-CN" altLang="en-US" sz="1200" b="1">
+                <a:latin typeface="微软雅黑" charset="0"/>
+                <a:ea typeface="微软雅黑" charset="0"/>
+                <a:cs typeface="微软雅黑" charset="0"/>
+              </a:rPr>
+              <a:t>连乘</a:t>
+            </a:r>
+            <a:endParaRPr lang="zh-CN" altLang="en-US" sz="1200" b="1">
+              <a:latin typeface="微软雅黑" charset="0"/>
+              <a:ea typeface="微软雅黑" charset="0"/>
+              <a:cs typeface="微软雅黑" charset="0"/>
+            </a:endParaRPr>
+          </a:p>
+        </p:txBody>
+      </p:sp>
+      <p:pic>
+        <p:nvPicPr>
+          <p:cNvPr id="5" name="图片 4"/>
+          <p:cNvPicPr>
+            <a:picLocks noChangeAspect="1"/>
+          </p:cNvPicPr>
+          <p:nvPr>
+            <p:custDataLst>
+              <p:tags r:id="rId4"/>
+            </p:custDataLst>
+          </p:nvPr>
+        </p:nvPicPr>
+        <p:blipFill>
+          <a:blip r:embed="rId5"/>
+          <a:stretch>
+            <a:fillRect/>
+          </a:stretch>
+        </p:blipFill>
+        <p:spPr>
+          <a:xfrm>
+            <a:off x="5063490" y="3062605"/>
+            <a:ext cx="6858000" cy="647700"/>
+          </a:xfrm>
+          <a:prstGeom prst="rect">
+            <a:avLst/>
+          </a:prstGeom>
+        </p:spPr>
+      </p:pic>
+      <p:sp>
+        <p:nvSpPr>
+          <p:cNvPr id="6" name="文本框 5"/>
+          <p:cNvSpPr txBox="1"/>
+          <p:nvPr>
+            <p:custDataLst>
+              <p:tags r:id="rId6"/>
+            </p:custDataLst>
+          </p:nvPr>
+        </p:nvSpPr>
+        <p:spPr>
+          <a:xfrm>
+            <a:off x="6206490" y="2186940"/>
+            <a:ext cx="5074920" cy="541655"/>
+          </a:xfrm>
+          <a:prstGeom prst="rect">
+            <a:avLst/>
+          </a:prstGeom>
+          <a:noFill/>
+        </p:spPr>
+        <p:txBody>
+          <a:bodyPr wrap="square" rtlCol="0">
+            <a:noAutofit/>
+          </a:bodyPr>
+          <a:p>
+            <a:pPr algn="ctr"/>
+            <a:r>
+              <a:rPr sz="1200" b="1">
+                <a:latin typeface="微软雅黑" charset="0"/>
+                <a:ea typeface="微软雅黑" charset="0"/>
+                <a:cs typeface="微软雅黑" charset="0"/>
+              </a:rPr>
+              <a:t>解释了模型如何根据xt和x0得到xt-1的概率</a:t>
+            </a:r>
+            <a:br>
+              <a:rPr sz="1200" b="1">
+                <a:latin typeface="微软雅黑" charset="0"/>
+                <a:ea typeface="微软雅黑" charset="0"/>
+                <a:cs typeface="微软雅黑" charset="0"/>
+              </a:rPr>
+            </a:br>
+            <a:r>
+              <a:rPr sz="1200" b="1">
+                <a:latin typeface="微软雅黑" charset="0"/>
+                <a:ea typeface="微软雅黑" charset="0"/>
+                <a:cs typeface="微软雅黑" charset="0"/>
+              </a:rPr>
+              <a:t>只需要知道x0和xt的均值和方差，就可以推导任何中间步骤的概率</a:t>
+            </a:r>
+            <a:br>
+              <a:rPr sz="1200" b="1">
+                <a:latin typeface="微软雅黑" charset="0"/>
+                <a:ea typeface="微软雅黑" charset="0"/>
+                <a:cs typeface="微软雅黑" charset="0"/>
+              </a:rPr>
+            </a:br>
+            <a:endParaRPr sz="1200" b="1">
+              <a:latin typeface="微软雅黑" charset="0"/>
+              <a:ea typeface="微软雅黑" charset="0"/>
+              <a:cs typeface="微软雅黑" charset="0"/>
+            </a:endParaRPr>
           </a:p>
         </p:txBody>
       </p:sp>
@@ -17445,7 +17761,31 @@
 </p:tagLst>
 </file>
 
+<file path=ppt/tags/tag187.xml><?xml version="1.0" encoding="utf-8"?>
+<p:tagLst xmlns:p="http://schemas.openxmlformats.org/presentationml/2006/main">
+  <p:tag name="KSO_WM_BEAUTIFY_FLAG" val=""/>
+</p:tagLst>
+</file>
+
+<file path=ppt/tags/tag188.xml><?xml version="1.0" encoding="utf-8"?>
+<p:tagLst xmlns:p="http://schemas.openxmlformats.org/presentationml/2006/main">
+  <p:tag name="KSO_WM_BEAUTIFY_FLAG" val=""/>
+</p:tagLst>
+</file>
+
+<file path=ppt/tags/tag189.xml><?xml version="1.0" encoding="utf-8"?>
+<p:tagLst xmlns:p="http://schemas.openxmlformats.org/presentationml/2006/main">
+  <p:tag name="KSO_WM_BEAUTIFY_FLAG" val=""/>
+</p:tagLst>
+</file>
+
 <file path=ppt/tags/tag19.xml><?xml version="1.0" encoding="utf-8"?>
+<p:tagLst xmlns:p="http://schemas.openxmlformats.org/presentationml/2006/main">
+  <p:tag name="KSO_WM_BEAUTIFY_FLAG" val=""/>
+</p:tagLst>
+</file>
+
+<file path=ppt/tags/tag190.xml><?xml version="1.0" encoding="utf-8"?>
 <p:tagLst xmlns:p="http://schemas.openxmlformats.org/presentationml/2006/main">
   <p:tag name="KSO_WM_BEAUTIFY_FLAG" val=""/>
 </p:tagLst>

</xml_diff>

<commit_message>
update_Diffusion Models Beat GANs on Image Synthesis
</commit_message>
<xml_diff>
--- a/Base_Model/GAN+VAE+Diffusion/论文作图.pptx
+++ b/Base_Model/GAN+VAE+Diffusion/论文作图.pptx
@@ -8,7 +8,7 @@
     <p:notesMasterId r:id="rId4"/>
   </p:notesMasterIdLst>
   <p:handoutMasterIdLst>
-    <p:handoutMasterId r:id="rId24"/>
+    <p:handoutMasterId r:id="rId26"/>
   </p:handoutMasterIdLst>
   <p:sldIdLst>
     <p:sldId id="256" r:id="rId3"/>
@@ -31,6 +31,8 @@
     <p:sldId id="274" r:id="rId21"/>
     <p:sldId id="275" r:id="rId22"/>
     <p:sldId id="276" r:id="rId23"/>
+    <p:sldId id="277" r:id="rId24"/>
+    <p:sldId id="278" r:id="rId25"/>
   </p:sldIdLst>
   <p:sldSz cx="12192000" cy="6858000"/>
   <p:notesSz cx="7103745" cy="10234295"/>
@@ -9643,6 +9645,502 @@
 </p:sld>
 </file>
 
+<file path=ppt/slides/slide21.xml><?xml version="1.0" encoding="utf-8"?>
+<p:sld xmlns:a="http://schemas.openxmlformats.org/drawingml/2006/main" xmlns:r="http://schemas.openxmlformats.org/officeDocument/2006/relationships" xmlns:p="http://schemas.openxmlformats.org/presentationml/2006/main">
+  <p:cSld>
+    <p:spTree>
+      <p:nvGrpSpPr>
+        <p:cNvPr id="1" name=""/>
+        <p:cNvGrpSpPr/>
+        <p:nvPr/>
+      </p:nvGrpSpPr>
+      <p:grpSpPr/>
+      <p:sp>
+        <p:nvSpPr>
+          <p:cNvPr id="2" name="标题 1"/>
+          <p:cNvSpPr>
+            <a:spLocks noGrp="1"/>
+          </p:cNvSpPr>
+          <p:nvPr>
+            <p:ph type="ctrTitle"/>
+          </p:nvPr>
+        </p:nvSpPr>
+        <p:spPr/>
+        <p:txBody>
+          <a:bodyPr/>
+          <a:p>
+            <a:r>
+              <a:rPr lang="en-US" altLang="zh-CN"/>
+              <a:t>Diffusion Beat </a:t>
+            </a:r>
+            <a:r>
+              <a:rPr lang="en-US" altLang="zh-CN"/>
+              <a:t>GANs</a:t>
+            </a:r>
+            <a:endParaRPr lang="en-US" altLang="zh-CN"/>
+          </a:p>
+        </p:txBody>
+      </p:sp>
+      <p:sp>
+        <p:nvSpPr>
+          <p:cNvPr id="3" name="副标题 2"/>
+          <p:cNvSpPr>
+            <a:spLocks noGrp="1"/>
+          </p:cNvSpPr>
+          <p:nvPr>
+            <p:ph type="subTitle" idx="1"/>
+          </p:nvPr>
+        </p:nvSpPr>
+        <p:spPr/>
+        <p:txBody>
+          <a:bodyPr/>
+          <a:p>
+            <a:endParaRPr lang="zh-CN" altLang="en-US"/>
+          </a:p>
+        </p:txBody>
+      </p:sp>
+    </p:spTree>
+  </p:cSld>
+  <p:clrMapOvr>
+    <a:masterClrMapping/>
+  </p:clrMapOvr>
+</p:sld>
+</file>
+
+<file path=ppt/slides/slide22.xml><?xml version="1.0" encoding="utf-8"?>
+<p:sld xmlns:a="http://schemas.openxmlformats.org/drawingml/2006/main" xmlns:r="http://schemas.openxmlformats.org/officeDocument/2006/relationships" xmlns:p="http://schemas.openxmlformats.org/presentationml/2006/main">
+  <p:cSld>
+    <p:spTree>
+      <p:nvGrpSpPr>
+        <p:cNvPr id="1" name=""/>
+        <p:cNvGrpSpPr/>
+        <p:nvPr/>
+      </p:nvGrpSpPr>
+      <p:grpSpPr/>
+      <p:pic>
+        <p:nvPicPr>
+          <p:cNvPr id="4" name="图片 3"/>
+          <p:cNvPicPr>
+            <a:picLocks noChangeAspect="1"/>
+          </p:cNvPicPr>
+          <p:nvPr>
+            <p:custDataLst>
+              <p:tags r:id="rId1"/>
+            </p:custDataLst>
+          </p:nvPr>
+        </p:nvPicPr>
+        <p:blipFill>
+          <a:blip r:embed="rId2"/>
+          <a:stretch>
+            <a:fillRect/>
+          </a:stretch>
+        </p:blipFill>
+        <p:spPr>
+          <a:xfrm>
+            <a:off x="264160" y="501650"/>
+            <a:ext cx="4127500" cy="2387600"/>
+          </a:xfrm>
+          <a:prstGeom prst="rect">
+            <a:avLst/>
+          </a:prstGeom>
+        </p:spPr>
+      </p:pic>
+      <p:sp>
+        <p:nvSpPr>
+          <p:cNvPr id="8" name="文本框 7"/>
+          <p:cNvSpPr txBox="1"/>
+          <p:nvPr>
+            <p:custDataLst>
+              <p:tags r:id="rId3"/>
+            </p:custDataLst>
+          </p:nvPr>
+        </p:nvSpPr>
+        <p:spPr>
+          <a:xfrm>
+            <a:off x="166370" y="92710"/>
+            <a:ext cx="4521200" cy="541655"/>
+          </a:xfrm>
+          <a:prstGeom prst="rect">
+            <a:avLst/>
+          </a:prstGeom>
+          <a:noFill/>
+        </p:spPr>
+        <p:txBody>
+          <a:bodyPr wrap="square" rtlCol="0">
+            <a:noAutofit/>
+          </a:bodyPr>
+          <a:p>
+            <a:pPr algn="ctr"/>
+            <a:r>
+              <a:rPr lang="zh-CN" altLang="en-US" sz="1200" b="1">
+                <a:latin typeface="微软雅黑" charset="0"/>
+                <a:ea typeface="微软雅黑" charset="0"/>
+                <a:cs typeface="微软雅黑" charset="0"/>
+              </a:rPr>
+              <a:t>固定每个注意力头的通道数，增加注意力头数，从 1 增加到 8</a:t>
+            </a:r>
+            <a:br>
+              <a:rPr lang="zh-CN" altLang="en-US" sz="1200" b="1">
+                <a:latin typeface="微软雅黑" charset="0"/>
+                <a:ea typeface="微软雅黑" charset="0"/>
+                <a:cs typeface="微软雅黑" charset="0"/>
+              </a:rPr>
+            </a:br>
+            <a:r>
+              <a:rPr lang="zh-CN" altLang="en-US" sz="1200" b="1">
+                <a:latin typeface="微软雅黑" charset="0"/>
+                <a:ea typeface="微软雅黑" charset="0"/>
+                <a:cs typeface="微软雅黑" charset="0"/>
+              </a:rPr>
+              <a:t>固定注意力头数量，调整每个头的通道数，从 32 增加到 128</a:t>
+            </a:r>
+            <a:endParaRPr lang="zh-CN" altLang="en-US" sz="1200" b="1">
+              <a:latin typeface="微软雅黑" charset="0"/>
+              <a:ea typeface="微软雅黑" charset="0"/>
+              <a:cs typeface="微软雅黑" charset="0"/>
+            </a:endParaRPr>
+          </a:p>
+        </p:txBody>
+      </p:sp>
+      <p:sp>
+        <p:nvSpPr>
+          <p:cNvPr id="5" name="文本框 4"/>
+          <p:cNvSpPr txBox="1"/>
+          <p:nvPr>
+            <p:custDataLst>
+              <p:tags r:id="rId4"/>
+            </p:custDataLst>
+          </p:nvPr>
+        </p:nvSpPr>
+        <p:spPr>
+          <a:xfrm>
+            <a:off x="3468370" y="219710"/>
+            <a:ext cx="4521200" cy="541655"/>
+          </a:xfrm>
+          <a:prstGeom prst="rect">
+            <a:avLst/>
+          </a:prstGeom>
+          <a:noFill/>
+        </p:spPr>
+        <p:txBody>
+          <a:bodyPr wrap="square" rtlCol="0">
+            <a:noAutofit/>
+          </a:bodyPr>
+          <a:p>
+            <a:pPr algn="ctr"/>
+            <a:r>
+              <a:rPr lang="en-US" sz="2000" b="1">
+                <a:latin typeface="微软雅黑" charset="0"/>
+                <a:ea typeface="微软雅黑" charset="0"/>
+                <a:cs typeface="微软雅黑" charset="0"/>
+              </a:rPr>
+              <a:t>FID</a:t>
+            </a:r>
+            <a:r>
+              <a:rPr lang="zh-CN" altLang="en-US" sz="2000" b="1">
+                <a:latin typeface="微软雅黑" charset="0"/>
+                <a:ea typeface="微软雅黑" charset="0"/>
+                <a:cs typeface="微软雅黑" charset="0"/>
+              </a:rPr>
+              <a:t>越小越好</a:t>
+            </a:r>
+            <a:endParaRPr lang="zh-CN" altLang="en-US" sz="2000" b="1">
+              <a:latin typeface="微软雅黑" charset="0"/>
+              <a:ea typeface="微软雅黑" charset="0"/>
+              <a:cs typeface="微软雅黑" charset="0"/>
+            </a:endParaRPr>
+          </a:p>
+        </p:txBody>
+      </p:sp>
+      <p:pic>
+        <p:nvPicPr>
+          <p:cNvPr id="6" name="图片 5"/>
+          <p:cNvPicPr>
+            <a:picLocks noChangeAspect="1"/>
+          </p:cNvPicPr>
+          <p:nvPr>
+            <p:custDataLst>
+              <p:tags r:id="rId5"/>
+            </p:custDataLst>
+          </p:nvPr>
+        </p:nvPicPr>
+        <p:blipFill>
+          <a:blip r:embed="rId6"/>
+          <a:stretch>
+            <a:fillRect/>
+          </a:stretch>
+        </p:blipFill>
+        <p:spPr>
+          <a:xfrm>
+            <a:off x="4255135" y="2859405"/>
+            <a:ext cx="7936865" cy="3998595"/>
+          </a:xfrm>
+          <a:prstGeom prst="rect">
+            <a:avLst/>
+          </a:prstGeom>
+        </p:spPr>
+      </p:pic>
+      <p:sp>
+        <p:nvSpPr>
+          <p:cNvPr id="7" name="文本框 6"/>
+          <p:cNvSpPr txBox="1"/>
+          <p:nvPr>
+            <p:custDataLst>
+              <p:tags r:id="rId7"/>
+            </p:custDataLst>
+          </p:nvPr>
+        </p:nvSpPr>
+        <p:spPr>
+          <a:xfrm>
+            <a:off x="4832985" y="1616710"/>
+            <a:ext cx="3042285" cy="1388110"/>
+          </a:xfrm>
+          <a:prstGeom prst="rect">
+            <a:avLst/>
+          </a:prstGeom>
+          <a:noFill/>
+        </p:spPr>
+        <p:txBody>
+          <a:bodyPr wrap="square" rtlCol="0">
+            <a:noAutofit/>
+          </a:bodyPr>
+          <a:p>
+            <a:pPr algn="l"/>
+            <a:r>
+              <a:rPr lang="zh-CN" altLang="en-US" sz="1200" b="1">
+                <a:latin typeface="微软雅黑" charset="0"/>
+                <a:ea typeface="微软雅黑" charset="0"/>
+                <a:cs typeface="微软雅黑" charset="0"/>
+              </a:rPr>
+              <a:t>第一个基础模型</a:t>
+            </a:r>
+            <a:br>
+              <a:rPr lang="zh-CN" altLang="en-US" sz="1200" b="1">
+                <a:latin typeface="微软雅黑" charset="0"/>
+                <a:ea typeface="微软雅黑" charset="0"/>
+                <a:cs typeface="微软雅黑" charset="0"/>
+              </a:rPr>
+            </a:br>
+            <a:r>
+              <a:rPr lang="en-US" altLang="zh-CN" sz="1200" b="1">
+                <a:latin typeface="微软雅黑" charset="0"/>
+                <a:ea typeface="微软雅黑" charset="0"/>
+                <a:cs typeface="微软雅黑" charset="0"/>
+              </a:rPr>
+              <a:t>ch: </a:t>
+            </a:r>
+            <a:r>
+              <a:rPr lang="zh-CN" altLang="en-US" sz="1200" b="1">
+                <a:latin typeface="微软雅黑" charset="0"/>
+                <a:ea typeface="微软雅黑" charset="0"/>
+                <a:cs typeface="微软雅黑" charset="0"/>
+              </a:rPr>
+              <a:t>通道数</a:t>
+            </a:r>
+            <a:br>
+              <a:rPr lang="zh-CN" altLang="en-US" sz="1200" b="1">
+                <a:latin typeface="微软雅黑" charset="0"/>
+                <a:ea typeface="微软雅黑" charset="0"/>
+                <a:cs typeface="微软雅黑" charset="0"/>
+              </a:rPr>
+            </a:br>
+            <a:r>
+              <a:rPr lang="en-US" altLang="zh-CN" sz="1200" b="1">
+                <a:latin typeface="微软雅黑" charset="0"/>
+                <a:ea typeface="微软雅黑" charset="0"/>
+                <a:cs typeface="微软雅黑" charset="0"/>
+              </a:rPr>
+              <a:t>res: </a:t>
+            </a:r>
+            <a:r>
+              <a:rPr lang="zh-CN" altLang="en-US" sz="1200" b="1">
+                <a:latin typeface="微软雅黑" charset="0"/>
+                <a:ea typeface="微软雅黑" charset="0"/>
+                <a:cs typeface="微软雅黑" charset="0"/>
+              </a:rPr>
+              <a:t>残差数</a:t>
+            </a:r>
+            <a:br>
+              <a:rPr lang="zh-CN" altLang="en-US" sz="1200" b="1">
+                <a:latin typeface="微软雅黑" charset="0"/>
+                <a:ea typeface="微软雅黑" charset="0"/>
+                <a:cs typeface="微软雅黑" charset="0"/>
+              </a:rPr>
+            </a:br>
+            <a:r>
+              <a:rPr lang="en-US" altLang="zh-CN" sz="1200" b="1">
+                <a:latin typeface="微软雅黑" charset="0"/>
+                <a:ea typeface="微软雅黑" charset="0"/>
+                <a:cs typeface="微软雅黑" charset="0"/>
+              </a:rPr>
+              <a:t>mutil-res att </a:t>
+            </a:r>
+            <a:r>
+              <a:rPr lang="zh-CN" altLang="en-US" sz="1200" b="1">
+                <a:latin typeface="微软雅黑" charset="0"/>
+                <a:ea typeface="微软雅黑" charset="0"/>
+                <a:cs typeface="微软雅黑" charset="0"/>
+              </a:rPr>
+              <a:t>多分辨率注意力层</a:t>
+            </a:r>
+            <a:br>
+              <a:rPr lang="zh-CN" altLang="en-US" sz="1200" b="1">
+                <a:latin typeface="微软雅黑" charset="0"/>
+                <a:ea typeface="微软雅黑" charset="0"/>
+                <a:cs typeface="微软雅黑" charset="0"/>
+              </a:rPr>
+            </a:br>
+            <a:r>
+              <a:rPr lang="en-US" altLang="zh-CN" sz="1200" b="1">
+                <a:latin typeface="微软雅黑" charset="0"/>
+                <a:ea typeface="微软雅黑" charset="0"/>
+                <a:cs typeface="微软雅黑" charset="0"/>
+              </a:rPr>
+              <a:t>biggan up/down BigGAN</a:t>
+            </a:r>
+            <a:r>
+              <a:rPr lang="zh-CN" altLang="en-US" sz="1200" b="1">
+                <a:latin typeface="微软雅黑" charset="0"/>
+                <a:ea typeface="微软雅黑" charset="0"/>
+                <a:cs typeface="微软雅黑" charset="0"/>
+              </a:rPr>
+              <a:t>上下采样</a:t>
+            </a:r>
+            <a:br>
+              <a:rPr lang="zh-CN" altLang="en-US" sz="1200" b="1">
+                <a:latin typeface="微软雅黑" charset="0"/>
+                <a:ea typeface="微软雅黑" charset="0"/>
+                <a:cs typeface="微软雅黑" charset="0"/>
+              </a:rPr>
+            </a:br>
+            <a:r>
+              <a:rPr lang="en-US" altLang="zh-CN" sz="1200" b="1">
+                <a:latin typeface="微软雅黑" charset="0"/>
+                <a:ea typeface="微软雅黑" charset="0"/>
+                <a:cs typeface="微软雅黑" charset="0"/>
+              </a:rPr>
+              <a:t>skip rescale: </a:t>
+            </a:r>
+            <a:r>
+              <a:rPr lang="zh-CN" altLang="en-US" sz="1200" b="1">
+                <a:latin typeface="微软雅黑" charset="0"/>
+                <a:ea typeface="微软雅黑" charset="0"/>
+                <a:cs typeface="微软雅黑" charset="0"/>
+              </a:rPr>
+              <a:t>残差链接做重缩放</a:t>
+            </a:r>
+            <a:br>
+              <a:rPr lang="zh-CN" altLang="en-US" sz="1200" b="1">
+                <a:latin typeface="微软雅黑" charset="0"/>
+                <a:ea typeface="微软雅黑" charset="0"/>
+                <a:cs typeface="微软雅黑" charset="0"/>
+              </a:rPr>
+            </a:br>
+            <a:r>
+              <a:rPr lang="zh-CN" altLang="en-US" sz="1200" b="1">
+                <a:latin typeface="微软雅黑" charset="0"/>
+                <a:ea typeface="微软雅黑" charset="0"/>
+                <a:cs typeface="微软雅黑" charset="0"/>
+              </a:rPr>
+              <a:t>越往下改进</a:t>
+            </a:r>
+            <a:r>
+              <a:rPr lang="zh-CN" altLang="en-US" sz="1200" b="1">
+                <a:latin typeface="微软雅黑" charset="0"/>
+                <a:ea typeface="微软雅黑" charset="0"/>
+                <a:cs typeface="微软雅黑" charset="0"/>
+              </a:rPr>
+              <a:t>越好</a:t>
+            </a:r>
+            <a:endParaRPr lang="zh-CN" altLang="en-US" sz="1200" b="1">
+              <a:latin typeface="微软雅黑" charset="0"/>
+              <a:ea typeface="微软雅黑" charset="0"/>
+              <a:cs typeface="微软雅黑" charset="0"/>
+            </a:endParaRPr>
+          </a:p>
+        </p:txBody>
+      </p:sp>
+      <p:sp>
+        <p:nvSpPr>
+          <p:cNvPr id="9" name="文本框 8"/>
+          <p:cNvSpPr txBox="1"/>
+          <p:nvPr>
+            <p:custDataLst>
+              <p:tags r:id="rId8"/>
+            </p:custDataLst>
+          </p:nvPr>
+        </p:nvSpPr>
+        <p:spPr>
+          <a:xfrm>
+            <a:off x="8642985" y="1616710"/>
+            <a:ext cx="3042285" cy="1388110"/>
+          </a:xfrm>
+          <a:prstGeom prst="rect">
+            <a:avLst/>
+          </a:prstGeom>
+          <a:noFill/>
+        </p:spPr>
+        <p:txBody>
+          <a:bodyPr wrap="square" rtlCol="0">
+            <a:noAutofit/>
+          </a:bodyPr>
+          <a:p>
+            <a:pPr algn="l"/>
+            <a:r>
+              <a:rPr lang="zh-CN" altLang="en-US" sz="1200" b="1">
+                <a:latin typeface="微软雅黑" charset="0"/>
+                <a:ea typeface="微软雅黑" charset="0"/>
+                <a:cs typeface="微软雅黑" charset="0"/>
+              </a:rPr>
+              <a:t>注意力头数和</a:t>
+            </a:r>
+            <a:r>
+              <a:rPr lang="zh-CN" altLang="en-US" sz="1200" b="1">
+                <a:latin typeface="微软雅黑" charset="0"/>
+                <a:ea typeface="微软雅黑" charset="0"/>
+                <a:cs typeface="微软雅黑" charset="0"/>
+              </a:rPr>
+              <a:t>通道数</a:t>
+            </a:r>
+            <a:br>
+              <a:rPr lang="zh-CN" altLang="en-US" sz="1200" b="1">
+                <a:latin typeface="微软雅黑" charset="0"/>
+                <a:ea typeface="微软雅黑" charset="0"/>
+                <a:cs typeface="微软雅黑" charset="0"/>
+              </a:rPr>
+            </a:br>
+            <a:r>
+              <a:rPr lang="zh-CN" altLang="en-US" sz="1200" b="1">
+                <a:latin typeface="微软雅黑" charset="0"/>
+                <a:ea typeface="微软雅黑" charset="0"/>
+                <a:cs typeface="微软雅黑" charset="0"/>
+              </a:rPr>
+              <a:t>越往下改进</a:t>
+            </a:r>
+            <a:r>
+              <a:rPr lang="zh-CN" altLang="en-US" sz="1200" b="1">
+                <a:latin typeface="微软雅黑" charset="0"/>
+                <a:ea typeface="微软雅黑" charset="0"/>
+                <a:cs typeface="微软雅黑" charset="0"/>
+              </a:rPr>
+              <a:t>越好</a:t>
+            </a:r>
+            <a:endParaRPr lang="zh-CN" altLang="en-US" sz="1200" b="1">
+              <a:latin typeface="微软雅黑" charset="0"/>
+              <a:ea typeface="微软雅黑" charset="0"/>
+              <a:cs typeface="微软雅黑" charset="0"/>
+            </a:endParaRPr>
+          </a:p>
+        </p:txBody>
+      </p:sp>
+    </p:spTree>
+  </p:cSld>
+  <p:clrMapOvr>
+    <a:masterClrMapping/>
+  </p:clrMapOvr>
+</p:sld>
+</file>
+
 <file path=ppt/slides/slide3.xml><?xml version="1.0" encoding="utf-8"?>
 <p:sld xmlns:a="http://schemas.openxmlformats.org/drawingml/2006/main" xmlns:r="http://schemas.openxmlformats.org/officeDocument/2006/relationships" xmlns:p="http://schemas.openxmlformats.org/presentationml/2006/main">
   <p:cSld>
@@ -17786,6 +18284,42 @@
 </file>
 
 <file path=ppt/tags/tag190.xml><?xml version="1.0" encoding="utf-8"?>
+<p:tagLst xmlns:p="http://schemas.openxmlformats.org/presentationml/2006/main">
+  <p:tag name="KSO_WM_BEAUTIFY_FLAG" val=""/>
+</p:tagLst>
+</file>
+
+<file path=ppt/tags/tag191.xml><?xml version="1.0" encoding="utf-8"?>
+<p:tagLst xmlns:p="http://schemas.openxmlformats.org/presentationml/2006/main">
+  <p:tag name="KSO_WM_BEAUTIFY_FLAG" val=""/>
+</p:tagLst>
+</file>
+
+<file path=ppt/tags/tag192.xml><?xml version="1.0" encoding="utf-8"?>
+<p:tagLst xmlns:p="http://schemas.openxmlformats.org/presentationml/2006/main">
+  <p:tag name="KSO_WM_BEAUTIFY_FLAG" val=""/>
+</p:tagLst>
+</file>
+
+<file path=ppt/tags/tag193.xml><?xml version="1.0" encoding="utf-8"?>
+<p:tagLst xmlns:p="http://schemas.openxmlformats.org/presentationml/2006/main">
+  <p:tag name="KSO_WM_BEAUTIFY_FLAG" val=""/>
+</p:tagLst>
+</file>
+
+<file path=ppt/tags/tag194.xml><?xml version="1.0" encoding="utf-8"?>
+<p:tagLst xmlns:p="http://schemas.openxmlformats.org/presentationml/2006/main">
+  <p:tag name="KSO_WM_BEAUTIFY_FLAG" val=""/>
+</p:tagLst>
+</file>
+
+<file path=ppt/tags/tag195.xml><?xml version="1.0" encoding="utf-8"?>
+<p:tagLst xmlns:p="http://schemas.openxmlformats.org/presentationml/2006/main">
+  <p:tag name="KSO_WM_BEAUTIFY_FLAG" val=""/>
+</p:tagLst>
+</file>
+
+<file path=ppt/tags/tag196.xml><?xml version="1.0" encoding="utf-8"?>
 <p:tagLst xmlns:p="http://schemas.openxmlformats.org/presentationml/2006/main">
   <p:tag name="KSO_WM_BEAUTIFY_FLAG" val=""/>
 </p:tagLst>

</xml_diff>